<commit_message>
Improve presentation cover and dashboard readability
</commit_message>
<xml_diff>
--- a/netflix_long_term_satisfaction/presentations/Nhom9_Netflix_ThuyetTrinh.pptx
+++ b/netflix_long_term_satisfaction/presentations/Nhom9_Netflix_ThuyetTrinh.pptx
@@ -2,25 +2,25 @@
 <file path=ppt/presentation.xml><?xml version="1.0" encoding="utf-8"?>
 <p:presentation xmlns:p="http://schemas.openxmlformats.org/presentationml/2006/main">
   <p:sldMasterIdLst>
-    <p:sldMasterId xmlns:r="http://schemas.openxmlformats.org/officeDocument/2006/relationships" id="2147483648" r:id="R3529c6c354c34753"/>
+    <p:sldMasterId xmlns:r="http://schemas.openxmlformats.org/officeDocument/2006/relationships" id="2147483648" r:id="R75e01fdc86074091"/>
   </p:sldMasterIdLst>
   <p:notesMasterIdLst>
-    <p:notesMasterId xmlns:r="http://schemas.openxmlformats.org/officeDocument/2006/relationships" r:id="R283ab289dc384704"/>
+    <p:notesMasterId xmlns:r="http://schemas.openxmlformats.org/officeDocument/2006/relationships" r:id="R69a65a93e45d48bf"/>
   </p:notesMasterIdLst>
   <p:sldIdLst>
-    <p:sldId xmlns:r="http://schemas.openxmlformats.org/officeDocument/2006/relationships" id="256" r:id="R0e76cc31ae2148b6"/>
-    <p:sldId xmlns:r="http://schemas.openxmlformats.org/officeDocument/2006/relationships" id="257" r:id="Rf899dc8908324379"/>
-    <p:sldId xmlns:r="http://schemas.openxmlformats.org/officeDocument/2006/relationships" id="258" r:id="R26e3033685ea48c7"/>
-    <p:sldId xmlns:r="http://schemas.openxmlformats.org/officeDocument/2006/relationships" id="259" r:id="R189db19e7c374dfc"/>
-    <p:sldId xmlns:r="http://schemas.openxmlformats.org/officeDocument/2006/relationships" id="260" r:id="Ra33a7f1ead034896"/>
-    <p:sldId xmlns:r="http://schemas.openxmlformats.org/officeDocument/2006/relationships" id="261" r:id="R4457c6c99dd1483e"/>
-    <p:sldId xmlns:r="http://schemas.openxmlformats.org/officeDocument/2006/relationships" id="262" r:id="R71b64a0f05464dd6"/>
-    <p:sldId xmlns:r="http://schemas.openxmlformats.org/officeDocument/2006/relationships" id="263" r:id="Re1a9a2ffa9394ac6"/>
-    <p:sldId xmlns:r="http://schemas.openxmlformats.org/officeDocument/2006/relationships" id="264" r:id="R4157aba18cc6441e"/>
-    <p:sldId xmlns:r="http://schemas.openxmlformats.org/officeDocument/2006/relationships" id="265" r:id="Rc89f0765c4d8404d"/>
-    <p:sldId xmlns:r="http://schemas.openxmlformats.org/officeDocument/2006/relationships" id="266" r:id="R7cf3d62c8bcb4dd3"/>
-    <p:sldId xmlns:r="http://schemas.openxmlformats.org/officeDocument/2006/relationships" id="267" r:id="R1dde0b2e5f004da3"/>
-    <p:sldId xmlns:r="http://schemas.openxmlformats.org/officeDocument/2006/relationships" id="268" r:id="R7481241b28f04636"/>
+    <p:sldId xmlns:r="http://schemas.openxmlformats.org/officeDocument/2006/relationships" id="256" r:id="R3eb5151bef4740c5"/>
+    <p:sldId xmlns:r="http://schemas.openxmlformats.org/officeDocument/2006/relationships" id="257" r:id="R34ab581b0adf41fd"/>
+    <p:sldId xmlns:r="http://schemas.openxmlformats.org/officeDocument/2006/relationships" id="258" r:id="R7b44c66e42b04ae6"/>
+    <p:sldId xmlns:r="http://schemas.openxmlformats.org/officeDocument/2006/relationships" id="259" r:id="R7989cfe4960b40d6"/>
+    <p:sldId xmlns:r="http://schemas.openxmlformats.org/officeDocument/2006/relationships" id="260" r:id="Rb636f5335862450d"/>
+    <p:sldId xmlns:r="http://schemas.openxmlformats.org/officeDocument/2006/relationships" id="261" r:id="R53cd1fbc2f2b4ea3"/>
+    <p:sldId xmlns:r="http://schemas.openxmlformats.org/officeDocument/2006/relationships" id="262" r:id="R43f427b1984943cc"/>
+    <p:sldId xmlns:r="http://schemas.openxmlformats.org/officeDocument/2006/relationships" id="263" r:id="R9e6ff2a6b3524e3b"/>
+    <p:sldId xmlns:r="http://schemas.openxmlformats.org/officeDocument/2006/relationships" id="264" r:id="R1b9ec0bffedc4d88"/>
+    <p:sldId xmlns:r="http://schemas.openxmlformats.org/officeDocument/2006/relationships" id="265" r:id="R4fa1b3e85b604309"/>
+    <p:sldId xmlns:r="http://schemas.openxmlformats.org/officeDocument/2006/relationships" id="266" r:id="R74ef8419dae94c8c"/>
+    <p:sldId xmlns:r="http://schemas.openxmlformats.org/officeDocument/2006/relationships" id="267" r:id="R63ff474f510d4b12"/>
+    <p:sldId xmlns:r="http://schemas.openxmlformats.org/officeDocument/2006/relationships" id="268" r:id="Rd5f59a502e7a4625"/>
   </p:sldIdLst>
   <p:sldSz cx="13716000" cy="7715250"/>
   <p:notesSz cx="6858000" cy="9144000"/>
@@ -454,7 +454,7 @@
           <a:lstStyle xmlns:a="http://schemas.openxmlformats.org/drawingml/2006/main"/>
           <a:p xmlns:a="http://schemas.openxmlformats.org/drawingml/2006/main">
             <a:r>
-              <a:t>Giới thiệu nhóm, giảng viên và học phần. Logo lấy từ báo cáo mẫu do người dùng cung cấp.</a:t>
+              <a:t>Giới thiệu đúng tên đề tài, bốn thành viên, giảng viên và học phần.</a:t>
             </a:r>
           </a:p>
         </p:txBody>
@@ -804,7 +804,7 @@
           <a:lstStyle xmlns:a="http://schemas.openxmlformats.org/drawingml/2006/main"/>
           <a:p xmlns:a="http://schemas.openxmlformats.org/drawingml/2006/main">
             <a:r>
-              <a:t>Đọc tên đề tài. Nêu rõ MovieLens mô phỏng bài toán, không phải dữ liệu Netflix.</a:t>
+              <a:t>Nêu ba việc hệ thống làm. MovieLens là dữ liệu thử nghiệm, không phải dữ liệu Netflix.</a:t>
             </a:r>
           </a:p>
         </p:txBody>
@@ -1362,7 +1362,7 @@
   </p:cSld>
   <p:clrMap bg1="lt1" tx1="dk1" bg2="lt2" tx2="dk2" accent1="accent1" accent2="accent2" accent3="accent3" accent4="accent4" accent5="accent5" accent6="accent6" hlink="hlink" folHlink="folHlink"/>
   <p:sldLayoutIdLst>
-    <p:sldLayoutId xmlns:r="http://schemas.openxmlformats.org/officeDocument/2006/relationships" id="2147483649" r:id="R75c7351d5d614a5e"/>
+    <p:sldLayoutId xmlns:r="http://schemas.openxmlformats.org/officeDocument/2006/relationships" id="2147483649" r:id="R418d5850a9a94d47"/>
   </p:sldLayoutIdLst>
   <p:txStyles>
     <p:titleStyle>
@@ -2149,10 +2149,10 @@
       </p:grpSpPr>
       <p:sp>
         <p:nvSpPr>
-          <p:cNvPr id="14" name="">
-            <a:extLst xmlns:a="http://schemas.openxmlformats.org/drawingml/2006/main">
-              <a:ext uri="{FF2B5EF4-FFF2-40B4-BE49-F238E27FC236}">
-                <a16:creationId xmlns:a16="http://schemas.microsoft.com/office/drawing/2014/main" id="{83EA06F5-58A8-4F95-902C-C2C726EFD181}"/>
+          <p:cNvPr id="15" name="">
+            <a:extLst xmlns:a="http://schemas.openxmlformats.org/drawingml/2006/main">
+              <a:ext uri="{FF2B5EF4-FFF2-40B4-BE49-F238E27FC236}">
+                <a16:creationId xmlns:a16="http://schemas.microsoft.com/office/drawing/2014/main" id="{4EEA324A-3E0E-4F44-BD32-78914468AEDF}"/>
               </a:ext>
             </a:extLst>
           </p:cNvPr>
@@ -2182,7 +2182,7 @@
           <p:cNvPr id="2" name="">
             <a:extLst xmlns:a="http://schemas.openxmlformats.org/drawingml/2006/main">
               <a:ext uri="{FF2B5EF4-FFF2-40B4-BE49-F238E27FC236}">
-                <a16:creationId xmlns:a16="http://schemas.microsoft.com/office/drawing/2014/main" id="{B29FDB25-AA22-4FF1-BB49-F549790DB390}"/>
+                <a16:creationId xmlns:a16="http://schemas.microsoft.com/office/drawing/2014/main" id="{015CE37C-ABD1-4FF2-B4E7-4D720C133D8B}"/>
               </a:ext>
             </a:extLst>
           </p:cNvPr>
@@ -2212,19 +2212,19 @@
           <p:cNvPr id="3" name="">
             <a:extLst xmlns:a="http://schemas.openxmlformats.org/drawingml/2006/main">
               <a:ext uri="{FF2B5EF4-FFF2-40B4-BE49-F238E27FC236}">
-                <a16:creationId xmlns:a16="http://schemas.microsoft.com/office/drawing/2014/main" id="{6700E026-E02C-4597-9EE4-42FE27ADC02B}"/>
-              </a:ext>
-            </a:extLst>
-          </p:cNvPr>
-          <p:cNvSpPr>
-            <a:spLocks xmlns:a="http://schemas.openxmlformats.org/drawingml/2006/main" noGrp="1"/>
-          </p:cNvSpPr>
-          <p:nvPr/>
-        </p:nvSpPr>
-        <p:spPr>
-          <a:xfrm xmlns:a="http://schemas.openxmlformats.org/drawingml/2006/main">
-            <a:off x="9953625" y="590550"/>
-            <a:ext cx="2266950" cy="2181225"/>
+                <a16:creationId xmlns:a16="http://schemas.microsoft.com/office/drawing/2014/main" id="{DBE6FE55-E740-418A-AEED-8AA149D76942}"/>
+              </a:ext>
+            </a:extLst>
+          </p:cNvPr>
+          <p:cNvSpPr>
+            <a:spLocks xmlns:a="http://schemas.openxmlformats.org/drawingml/2006/main" noGrp="1"/>
+          </p:cNvSpPr>
+          <p:nvPr/>
+        </p:nvSpPr>
+        <p:spPr>
+          <a:xfrm xmlns:a="http://schemas.openxmlformats.org/drawingml/2006/main">
+            <a:off x="10572750" y="504825"/>
+            <a:ext cx="1714500" cy="1628775"/>
           </a:xfrm>
           <a:prstGeom xmlns:a="http://schemas.openxmlformats.org/drawingml/2006/main" prst="rect">
             <a:avLst/>
@@ -2239,20 +2239,20 @@
       </p:sp>
       <p:pic>
         <p:nvPicPr>
-          <p:cNvPr id="17" name=""/>
+          <p:cNvPr id="18" name=""/>
           <p:cNvPicPr>
             <a:picLocks xmlns:a="http://schemas.openxmlformats.org/drawingml/2006/main" noChangeAspect="1"/>
           </p:cNvPicPr>
           <p:nvPr/>
         </p:nvPicPr>
         <p:blipFill>
-          <a:blip xmlns:r="http://schemas.openxmlformats.org/officeDocument/2006/relationships" xmlns:a="http://schemas.openxmlformats.org/drawingml/2006/main" r:embed="R5d69e30ed23d4a16"/>
+          <a:blip xmlns:r="http://schemas.openxmlformats.org/officeDocument/2006/relationships" xmlns:a="http://schemas.openxmlformats.org/drawingml/2006/main" r:embed="R674b12d7e7cb4e72"/>
           <a:stretch xmlns:a="http://schemas.openxmlformats.org/drawingml/2006/main"/>
         </p:blipFill>
         <p:spPr>
           <a:xfrm xmlns:a="http://schemas.openxmlformats.org/drawingml/2006/main">
-            <a:off x="10048875" y="820175"/>
-            <a:ext cx="2076450" cy="1712451"/>
+            <a:off x="10648950" y="675080"/>
+            <a:ext cx="1562100" cy="1288266"/>
           </a:xfrm>
           <a:prstGeom xmlns:a="http://schemas.openxmlformats.org/drawingml/2006/main" prst="rect">
             <a:avLst/>
@@ -2264,19 +2264,19 @@
           <p:cNvPr id="5" name="">
             <a:extLst xmlns:a="http://schemas.openxmlformats.org/drawingml/2006/main">
               <a:ext uri="{FF2B5EF4-FFF2-40B4-BE49-F238E27FC236}">
-                <a16:creationId xmlns:a16="http://schemas.microsoft.com/office/drawing/2014/main" id="{84D25D82-03DB-4733-AAA9-545A6C9CEF68}"/>
-              </a:ext>
-            </a:extLst>
-          </p:cNvPr>
-          <p:cNvSpPr>
-            <a:spLocks xmlns:a="http://schemas.openxmlformats.org/drawingml/2006/main" noGrp="1"/>
-          </p:cNvSpPr>
-          <p:nvPr/>
-        </p:nvSpPr>
-        <p:spPr>
-          <a:xfrm xmlns:a="http://schemas.openxmlformats.org/drawingml/2006/main">
-            <a:off x="762000" y="561975"/>
-            <a:ext cx="8667750" cy="400050"/>
+                <a16:creationId xmlns:a16="http://schemas.microsoft.com/office/drawing/2014/main" id="{B142455D-929B-4B14-8BEC-8D81867A719D}"/>
+              </a:ext>
+            </a:extLst>
+          </p:cNvPr>
+          <p:cNvSpPr>
+            <a:spLocks xmlns:a="http://schemas.openxmlformats.org/drawingml/2006/main" noGrp="1"/>
+          </p:cNvSpPr>
+          <p:nvPr/>
+        </p:nvSpPr>
+        <p:spPr>
+          <a:xfrm xmlns:a="http://schemas.openxmlformats.org/drawingml/2006/main">
+            <a:off x="771525" y="542925"/>
+            <a:ext cx="9525000" cy="428625"/>
           </a:xfrm>
           <a:prstGeom xmlns:a="http://schemas.openxmlformats.org/drawingml/2006/main" prst="rect">
             <a:avLst/>
@@ -2293,17 +2293,17 @@
           <a:lstStyle xmlns:a="http://schemas.openxmlformats.org/drawingml/2006/main"/>
           <a:p xmlns:a="http://schemas.openxmlformats.org/drawingml/2006/main">
             <a:pPr algn="l">
-              <a:defRPr sz="1950" b="0">
-                <a:solidFill>
-                  <a:srgbClr val="F9F9F9"/>
-                </a:solidFill>
-                <a:latin typeface="Arial"/>
-                <a:ea typeface="Arial"/>
-                <a:cs typeface="Arial"/>
-              </a:defRPr>
-            </a:pPr>
-            <a:r>
-              <a:rPr sz="1950" b="0">
+              <a:defRPr sz="1875" b="0">
+                <a:solidFill>
+                  <a:srgbClr val="F9F9F9"/>
+                </a:solidFill>
+                <a:latin typeface="Arial"/>
+                <a:ea typeface="Arial"/>
+                <a:cs typeface="Arial"/>
+              </a:defRPr>
+            </a:pPr>
+            <a:r>
+              <a:rPr sz="1875" b="0">
                 <a:solidFill>
                   <a:srgbClr val="F9F9F9"/>
                 </a:solidFill>
@@ -2321,19 +2321,106 @@
           <p:cNvPr id="6" name="">
             <a:extLst xmlns:a="http://schemas.openxmlformats.org/drawingml/2006/main">
               <a:ext uri="{FF2B5EF4-FFF2-40B4-BE49-F238E27FC236}">
-                <a16:creationId xmlns:a16="http://schemas.microsoft.com/office/drawing/2014/main" id="{0E32E50D-CC01-473A-9A6B-CFE09E4DD944}"/>
-              </a:ext>
-            </a:extLst>
-          </p:cNvPr>
-          <p:cNvSpPr>
-            <a:spLocks xmlns:a="http://schemas.openxmlformats.org/drawingml/2006/main" noGrp="1"/>
-          </p:cNvSpPr>
-          <p:nvPr/>
-        </p:nvSpPr>
-        <p:spPr>
-          <a:xfrm xmlns:a="http://schemas.openxmlformats.org/drawingml/2006/main">
-            <a:off x="742950" y="1695450"/>
-            <a:ext cx="8763000" cy="1095375"/>
+                <a16:creationId xmlns:a16="http://schemas.microsoft.com/office/drawing/2014/main" id="{D50C3123-F6C2-467B-A77D-677353C21CE5}"/>
+              </a:ext>
+            </a:extLst>
+          </p:cNvPr>
+          <p:cNvSpPr>
+            <a:spLocks xmlns:a="http://schemas.openxmlformats.org/drawingml/2006/main" noGrp="1"/>
+          </p:cNvSpPr>
+          <p:nvPr/>
+        </p:nvSpPr>
+        <p:spPr>
+          <a:xfrm xmlns:a="http://schemas.openxmlformats.org/drawingml/2006/main">
+            <a:off x="771525" y="1362075"/>
+            <a:ext cx="2000250" cy="542925"/>
+          </a:xfrm>
+          <a:prstGeom xmlns:a="http://schemas.openxmlformats.org/drawingml/2006/main" prst="rect">
+            <a:avLst/>
+          </a:prstGeom>
+          <a:solidFill xmlns:a="http://schemas.openxmlformats.org/drawingml/2006/main">
+            <a:srgbClr val="AC8CC0"/>
+          </a:solidFill>
+          <a:ln xmlns:a="http://schemas.openxmlformats.org/drawingml/2006/main" w="0">
+            <a:noFill/>
+          </a:ln>
+        </p:spPr>
+      </p:sp>
+      <p:sp>
+        <p:nvSpPr>
+          <p:cNvPr id="7" name="">
+            <a:extLst xmlns:a="http://schemas.openxmlformats.org/drawingml/2006/main">
+              <a:ext uri="{FF2B5EF4-FFF2-40B4-BE49-F238E27FC236}">
+                <a16:creationId xmlns:a16="http://schemas.microsoft.com/office/drawing/2014/main" id="{53BABCDF-C81F-49AB-9032-7CCB8C12A9A4}"/>
+              </a:ext>
+            </a:extLst>
+          </p:cNvPr>
+          <p:cNvSpPr>
+            <a:spLocks xmlns:a="http://schemas.openxmlformats.org/drawingml/2006/main" noGrp="1"/>
+          </p:cNvSpPr>
+          <p:nvPr/>
+        </p:nvSpPr>
+        <p:spPr>
+          <a:xfrm xmlns:a="http://schemas.openxmlformats.org/drawingml/2006/main">
+            <a:off x="942975" y="1419225"/>
+            <a:ext cx="1657350" cy="428625"/>
+          </a:xfrm>
+          <a:prstGeom xmlns:a="http://schemas.openxmlformats.org/drawingml/2006/main" prst="rect">
+            <a:avLst/>
+          </a:prstGeom>
+          <a:noFill xmlns:a="http://schemas.openxmlformats.org/drawingml/2006/main"/>
+          <a:ln xmlns:a="http://schemas.openxmlformats.org/drawingml/2006/main" w="0">
+            <a:noFill/>
+          </a:ln>
+        </p:spPr>
+        <p:txBody>
+          <a:bodyPr xmlns:a="http://schemas.openxmlformats.org/drawingml/2006/main" lIns="0" tIns="0" rIns="0" bIns="0" anchor="ctr">
+            <a:noAutofit/>
+          </a:bodyPr>
+          <a:lstStyle xmlns:a="http://schemas.openxmlformats.org/drawingml/2006/main"/>
+          <a:p xmlns:a="http://schemas.openxmlformats.org/drawingml/2006/main">
+            <a:pPr algn="ctr">
+              <a:defRPr sz="2250" b="1">
+                <a:solidFill>
+                  <a:srgbClr val="F9F9F9"/>
+                </a:solidFill>
+                <a:latin typeface="Arial"/>
+                <a:ea typeface="Arial"/>
+                <a:cs typeface="Arial"/>
+              </a:defRPr>
+            </a:pPr>
+            <a:r>
+              <a:rPr sz="2250" b="1">
+                <a:solidFill>
+                  <a:srgbClr val="F9F9F9"/>
+                </a:solidFill>
+                <a:latin typeface="Arial"/>
+                <a:ea typeface="Arial"/>
+                <a:cs typeface="Arial"/>
+              </a:rPr>
+              <a:t>NHÓM 9</a:t>
+            </a:r>
+          </a:p>
+        </p:txBody>
+      </p:sp>
+      <p:sp>
+        <p:nvSpPr>
+          <p:cNvPr id="8" name="">
+            <a:extLst xmlns:a="http://schemas.openxmlformats.org/drawingml/2006/main">
+              <a:ext uri="{FF2B5EF4-FFF2-40B4-BE49-F238E27FC236}">
+                <a16:creationId xmlns:a16="http://schemas.microsoft.com/office/drawing/2014/main" id="{BD99ECED-7C3A-4DA6-A14D-84532C52D784}"/>
+              </a:ext>
+            </a:extLst>
+          </p:cNvPr>
+          <p:cNvSpPr>
+            <a:spLocks xmlns:a="http://schemas.openxmlformats.org/drawingml/2006/main" noGrp="1"/>
+          </p:cNvSpPr>
+          <p:nvPr/>
+        </p:nvSpPr>
+        <p:spPr>
+          <a:xfrm xmlns:a="http://schemas.openxmlformats.org/drawingml/2006/main">
+            <a:off x="771525" y="2152650"/>
+            <a:ext cx="11658600" cy="2352675"/>
           </a:xfrm>
           <a:prstGeom xmlns:a="http://schemas.openxmlformats.org/drawingml/2006/main" prst="rect">
             <a:avLst/>
@@ -2350,64 +2437,110 @@
           <a:lstStyle xmlns:a="http://schemas.openxmlformats.org/drawingml/2006/main"/>
           <a:p xmlns:a="http://schemas.openxmlformats.org/drawingml/2006/main">
             <a:pPr algn="l">
-              <a:defRPr sz="7050" b="1">
-                <a:solidFill>
-                  <a:srgbClr val="C7F8B6"/>
-                </a:solidFill>
-                <a:latin typeface="Arial"/>
-                <a:ea typeface="Arial"/>
-                <a:cs typeface="Arial"/>
-              </a:defRPr>
-            </a:pPr>
-            <a:r>
-              <a:rPr sz="7050" b="1">
-                <a:solidFill>
-                  <a:srgbClr val="C7F8B6"/>
-                </a:solidFill>
-                <a:latin typeface="Arial"/>
-                <a:ea typeface="Arial"/>
-                <a:cs typeface="Arial"/>
-              </a:rPr>
-              <a:t>NHÓM 9</a:t>
-            </a:r>
-          </a:p>
-        </p:txBody>
-      </p:sp>
-      <p:sp>
-        <p:nvSpPr>
-          <p:cNvPr id="7" name="">
-            <a:extLst xmlns:a="http://schemas.openxmlformats.org/drawingml/2006/main">
-              <a:ext uri="{FF2B5EF4-FFF2-40B4-BE49-F238E27FC236}">
-                <a16:creationId xmlns:a16="http://schemas.microsoft.com/office/drawing/2014/main" id="{27279C35-8C1E-42A5-986A-B5DA4B8723F2}"/>
-              </a:ext>
-            </a:extLst>
-          </p:cNvPr>
-          <p:cNvSpPr>
-            <a:spLocks xmlns:a="http://schemas.openxmlformats.org/drawingml/2006/main" noGrp="1"/>
-          </p:cNvSpPr>
-          <p:nvPr/>
-        </p:nvSpPr>
-        <p:spPr>
-          <a:xfrm xmlns:a="http://schemas.openxmlformats.org/drawingml/2006/main">
-            <a:off x="762000" y="2990850"/>
-            <a:ext cx="9525000" cy="666750"/>
-          </a:xfrm>
-          <a:prstGeom xmlns:a="http://schemas.openxmlformats.org/drawingml/2006/main" prst="rect">
-            <a:avLst/>
-          </a:prstGeom>
-          <a:noFill xmlns:a="http://schemas.openxmlformats.org/drawingml/2006/main"/>
-          <a:ln xmlns:a="http://schemas.openxmlformats.org/drawingml/2006/main" w="0">
-            <a:noFill/>
-          </a:ln>
-        </p:spPr>
-        <p:txBody>
-          <a:bodyPr xmlns:a="http://schemas.openxmlformats.org/drawingml/2006/main" lIns="0" tIns="0" rIns="0" bIns="0" anchor="ctr">
-            <a:noAutofit/>
-          </a:bodyPr>
-          <a:lstStyle xmlns:a="http://schemas.openxmlformats.org/drawingml/2006/main"/>
+              <a:defRPr sz="4125" b="1">
+                <a:solidFill>
+                  <a:srgbClr val="F9F9F9"/>
+                </a:solidFill>
+                <a:latin typeface="Arial"/>
+                <a:ea typeface="Arial"/>
+                <a:cs typeface="Arial"/>
+              </a:defRPr>
+            </a:pPr>
+            <a:r>
+              <a:rPr sz="4125" b="1">
+                <a:solidFill>
+                  <a:srgbClr val="F9F9F9"/>
+                </a:solidFill>
+                <a:latin typeface="Arial"/>
+                <a:ea typeface="Arial"/>
+                <a:cs typeface="Arial"/>
+              </a:rPr>
+              <a:t>HỆ THỐNG KHUYẾN NGHỊ CHO</a:t>
+            </a:r>
+          </a:p>
           <a:p xmlns:a="http://schemas.openxmlformats.org/drawingml/2006/main">
             <a:pPr algn="l">
-              <a:defRPr sz="4050" b="0">
+              <a:defRPr sz="4125" b="1">
+                <a:solidFill>
+                  <a:srgbClr val="F9F9F9"/>
+                </a:solidFill>
+                <a:latin typeface="Arial"/>
+                <a:ea typeface="Arial"/>
+                <a:cs typeface="Arial"/>
+              </a:defRPr>
+            </a:pPr>
+            <a:r>
+              <a:rPr sz="4125" b="1">
+                <a:solidFill>
+                  <a:srgbClr val="F9F9F9"/>
+                </a:solidFill>
+                <a:latin typeface="Arial"/>
+                <a:ea typeface="Arial"/>
+                <a:cs typeface="Arial"/>
+              </a:rPr>
+              <a:t>SỰ HÀI LÒNG CỦA THÀNH VIÊN</a:t>
+            </a:r>
+          </a:p>
+          <a:p xmlns:a="http://schemas.openxmlformats.org/drawingml/2006/main">
+            <a:pPr algn="l">
+              <a:defRPr sz="4125" b="1">
+                <a:solidFill>
+                  <a:srgbClr val="F9F9F9"/>
+                </a:solidFill>
+                <a:latin typeface="Arial"/>
+                <a:ea typeface="Arial"/>
+                <a:cs typeface="Arial"/>
+              </a:defRPr>
+            </a:pPr>
+            <a:r>
+              <a:rPr sz="4125" b="1">
+                <a:solidFill>
+                  <a:srgbClr val="F9F9F9"/>
+                </a:solidFill>
+                <a:latin typeface="Arial"/>
+                <a:ea typeface="Arial"/>
+                <a:cs typeface="Arial"/>
+              </a:rPr>
+              <a:t>DÀI HẠN TẠI NETFLIX</a:t>
+            </a:r>
+          </a:p>
+        </p:txBody>
+      </p:sp>
+      <p:sp>
+        <p:nvSpPr>
+          <p:cNvPr id="9" name="">
+            <a:extLst xmlns:a="http://schemas.openxmlformats.org/drawingml/2006/main">
+              <a:ext uri="{FF2B5EF4-FFF2-40B4-BE49-F238E27FC236}">
+                <a16:creationId xmlns:a16="http://schemas.microsoft.com/office/drawing/2014/main" id="{880E8B37-16A2-4C32-9813-16DF7B3DA053}"/>
+              </a:ext>
+            </a:extLst>
+          </p:cNvPr>
+          <p:cNvSpPr>
+            <a:spLocks xmlns:a="http://schemas.openxmlformats.org/drawingml/2006/main" noGrp="1"/>
+          </p:cNvSpPr>
+          <p:nvPr/>
+        </p:nvSpPr>
+        <p:spPr>
+          <a:xfrm xmlns:a="http://schemas.openxmlformats.org/drawingml/2006/main">
+            <a:off x="800100" y="4724400"/>
+            <a:ext cx="10763250" cy="466725"/>
+          </a:xfrm>
+          <a:prstGeom xmlns:a="http://schemas.openxmlformats.org/drawingml/2006/main" prst="rect">
+            <a:avLst/>
+          </a:prstGeom>
+          <a:noFill xmlns:a="http://schemas.openxmlformats.org/drawingml/2006/main"/>
+          <a:ln xmlns:a="http://schemas.openxmlformats.org/drawingml/2006/main" w="0">
+            <a:noFill/>
+          </a:ln>
+        </p:spPr>
+        <p:txBody>
+          <a:bodyPr xmlns:a="http://schemas.openxmlformats.org/drawingml/2006/main" lIns="0" tIns="0" rIns="0" bIns="0" anchor="ctr">
+            <a:noAutofit/>
+          </a:bodyPr>
+          <a:lstStyle xmlns:a="http://schemas.openxmlformats.org/drawingml/2006/main"/>
+          <a:p xmlns:a="http://schemas.openxmlformats.org/drawingml/2006/main">
+            <a:pPr algn="l">
+              <a:defRPr sz="2025" b="1">
                 <a:solidFill>
                   <a:srgbClr val="AC8CC0"/>
                 </a:solidFill>
@@ -2417,7 +2550,7 @@
               </a:defRPr>
             </a:pPr>
             <a:r>
-              <a:rPr sz="4050" b="0">
+              <a:rPr sz="2025" b="1">
                 <a:solidFill>
                   <a:srgbClr val="AC8CC0"/>
                 </a:solidFill>
@@ -2425,85 +2558,28 @@
                 <a:ea typeface="Arial"/>
                 <a:cs typeface="Arial"/>
               </a:rPr>
-              <a:t>Công nghệ dữ liệu lớn</a:t>
-            </a:r>
-          </a:p>
-        </p:txBody>
-      </p:sp>
-      <p:sp>
-        <p:nvSpPr>
-          <p:cNvPr id="8" name="">
-            <a:extLst xmlns:a="http://schemas.openxmlformats.org/drawingml/2006/main">
-              <a:ext uri="{FF2B5EF4-FFF2-40B4-BE49-F238E27FC236}">
-                <a16:creationId xmlns:a16="http://schemas.microsoft.com/office/drawing/2014/main" id="{C982DCEC-8FF9-4190-9ACD-5C4E6E4EFE62}"/>
-              </a:ext>
-            </a:extLst>
-          </p:cNvPr>
-          <p:cNvSpPr>
-            <a:spLocks xmlns:a="http://schemas.openxmlformats.org/drawingml/2006/main" noGrp="1"/>
-          </p:cNvSpPr>
-          <p:nvPr/>
-        </p:nvSpPr>
-        <p:spPr>
-          <a:xfrm xmlns:a="http://schemas.openxmlformats.org/drawingml/2006/main">
-            <a:off x="781050" y="3724275"/>
-            <a:ext cx="6477000" cy="457200"/>
-          </a:xfrm>
-          <a:prstGeom xmlns:a="http://schemas.openxmlformats.org/drawingml/2006/main" prst="rect">
-            <a:avLst/>
-          </a:prstGeom>
-          <a:noFill xmlns:a="http://schemas.openxmlformats.org/drawingml/2006/main"/>
-          <a:ln xmlns:a="http://schemas.openxmlformats.org/drawingml/2006/main" w="0">
-            <a:noFill/>
-          </a:ln>
-        </p:spPr>
-        <p:txBody>
-          <a:bodyPr xmlns:a="http://schemas.openxmlformats.org/drawingml/2006/main" lIns="0" tIns="0" rIns="0" bIns="0" anchor="ctr">
-            <a:noAutofit/>
-          </a:bodyPr>
-          <a:lstStyle xmlns:a="http://schemas.openxmlformats.org/drawingml/2006/main"/>
-          <a:p xmlns:a="http://schemas.openxmlformats.org/drawingml/2006/main">
-            <a:pPr algn="l">
-              <a:defRPr sz="2250" b="0">
-                <a:solidFill>
-                  <a:srgbClr val="F9F9F9"/>
-                </a:solidFill>
-                <a:latin typeface="Arial"/>
-                <a:ea typeface="Arial"/>
-                <a:cs typeface="Arial"/>
-              </a:defRPr>
-            </a:pPr>
-            <a:r>
-              <a:rPr sz="2250" b="0">
-                <a:solidFill>
-                  <a:srgbClr val="F9F9F9"/>
-                </a:solidFill>
-                <a:latin typeface="Arial"/>
-                <a:ea typeface="Arial"/>
-                <a:cs typeface="Arial"/>
-              </a:rPr>
-              <a:t>IE212.F22.LT.CNTT</a:t>
-            </a:r>
-          </a:p>
-        </p:txBody>
-      </p:sp>
-      <p:sp>
-        <p:nvSpPr>
-          <p:cNvPr id="9" name="">
-            <a:extLst xmlns:a="http://schemas.openxmlformats.org/drawingml/2006/main">
-              <a:ext uri="{FF2B5EF4-FFF2-40B4-BE49-F238E27FC236}">
-                <a16:creationId xmlns:a16="http://schemas.microsoft.com/office/drawing/2014/main" id="{615261DC-FE03-4663-B681-BFBF673E8AFC}"/>
-              </a:ext>
-            </a:extLst>
-          </p:cNvPr>
-          <p:cNvSpPr>
-            <a:spLocks xmlns:a="http://schemas.openxmlformats.org/drawingml/2006/main" noGrp="1"/>
-          </p:cNvSpPr>
-          <p:nvPr/>
-        </p:nvSpPr>
-        <p:spPr>
-          <a:xfrm xmlns:a="http://schemas.openxmlformats.org/drawingml/2006/main">
-            <a:off x="771525" y="4533900"/>
+              <a:t>CÔNG NGHỆ DỮ LIỆU LỚN  ·  IE212.F22.LT.CNTT</a:t>
+            </a:r>
+          </a:p>
+        </p:txBody>
+      </p:sp>
+      <p:sp>
+        <p:nvSpPr>
+          <p:cNvPr id="10" name="">
+            <a:extLst xmlns:a="http://schemas.openxmlformats.org/drawingml/2006/main">
+              <a:ext uri="{FF2B5EF4-FFF2-40B4-BE49-F238E27FC236}">
+                <a16:creationId xmlns:a16="http://schemas.microsoft.com/office/drawing/2014/main" id="{D9AB80E6-9BB3-4652-BE16-0A9DE945F07D}"/>
+              </a:ext>
+            </a:extLst>
+          </p:cNvPr>
+          <p:cNvSpPr>
+            <a:spLocks xmlns:a="http://schemas.openxmlformats.org/drawingml/2006/main" noGrp="1"/>
+          </p:cNvSpPr>
+          <p:nvPr/>
+        </p:nvSpPr>
+        <p:spPr>
+          <a:xfrm xmlns:a="http://schemas.openxmlformats.org/drawingml/2006/main">
+            <a:off x="771525" y="5410200"/>
             <a:ext cx="11553825" cy="0"/>
           </a:xfrm>
           <a:prstGeom xmlns:a="http://schemas.openxmlformats.org/drawingml/2006/main" prst="line">
@@ -2519,22 +2595,22 @@
       </p:sp>
       <p:sp>
         <p:nvSpPr>
-          <p:cNvPr id="10" name="">
-            <a:extLst xmlns:a="http://schemas.openxmlformats.org/drawingml/2006/main">
-              <a:ext uri="{FF2B5EF4-FFF2-40B4-BE49-F238E27FC236}">
-                <a16:creationId xmlns:a16="http://schemas.microsoft.com/office/drawing/2014/main" id="{FB57ECFE-78C3-4DF3-BE43-181A355CFF60}"/>
-              </a:ext>
-            </a:extLst>
-          </p:cNvPr>
-          <p:cNvSpPr>
-            <a:spLocks xmlns:a="http://schemas.openxmlformats.org/drawingml/2006/main" noGrp="1"/>
-          </p:cNvSpPr>
-          <p:nvPr/>
-        </p:nvSpPr>
-        <p:spPr>
-          <a:xfrm xmlns:a="http://schemas.openxmlformats.org/drawingml/2006/main">
-            <a:off x="800100" y="4914900"/>
-            <a:ext cx="5286375" cy="1028700"/>
+          <p:cNvPr id="11" name="">
+            <a:extLst xmlns:a="http://schemas.openxmlformats.org/drawingml/2006/main">
+              <a:ext uri="{FF2B5EF4-FFF2-40B4-BE49-F238E27FC236}">
+                <a16:creationId xmlns:a16="http://schemas.microsoft.com/office/drawing/2014/main" id="{DF389D86-0CC0-41B0-9CC7-5658A4F553B1}"/>
+              </a:ext>
+            </a:extLst>
+          </p:cNvPr>
+          <p:cNvSpPr>
+            <a:spLocks xmlns:a="http://schemas.openxmlformats.org/drawingml/2006/main" noGrp="1"/>
+          </p:cNvSpPr>
+          <p:nvPr/>
+        </p:nvSpPr>
+        <p:spPr>
+          <a:xfrm xmlns:a="http://schemas.openxmlformats.org/drawingml/2006/main">
+            <a:off x="800100" y="5657850"/>
+            <a:ext cx="5286375" cy="857250"/>
           </a:xfrm>
           <a:prstGeom xmlns:a="http://schemas.openxmlformats.org/drawingml/2006/main" prst="rect">
             <a:avLst/>
@@ -2551,17 +2627,17 @@
           <a:lstStyle xmlns:a="http://schemas.openxmlformats.org/drawingml/2006/main"/>
           <a:p xmlns:a="http://schemas.openxmlformats.org/drawingml/2006/main">
             <a:pPr algn="l">
-              <a:defRPr sz="1875" b="0">
-                <a:solidFill>
-                  <a:srgbClr val="F9F9F9"/>
-                </a:solidFill>
-                <a:latin typeface="Arial"/>
-                <a:ea typeface="Arial"/>
-                <a:cs typeface="Arial"/>
-              </a:defRPr>
-            </a:pPr>
-            <a:r>
-              <a:rPr sz="1875" b="0">
+              <a:defRPr sz="1800" b="0">
+                <a:solidFill>
+                  <a:srgbClr val="F9F9F9"/>
+                </a:solidFill>
+                <a:latin typeface="Arial"/>
+                <a:ea typeface="Arial"/>
+                <a:cs typeface="Arial"/>
+              </a:defRPr>
+            </a:pPr>
+            <a:r>
+              <a:rPr sz="1800" b="0">
                 <a:solidFill>
                   <a:srgbClr val="F9F9F9"/>
                 </a:solidFill>
@@ -2574,17 +2650,17 @@
           </a:p>
           <a:p xmlns:a="http://schemas.openxmlformats.org/drawingml/2006/main">
             <a:pPr algn="l">
-              <a:defRPr sz="1875" b="0">
-                <a:solidFill>
-                  <a:srgbClr val="F9F9F9"/>
-                </a:solidFill>
-                <a:latin typeface="Arial"/>
-                <a:ea typeface="Arial"/>
-                <a:cs typeface="Arial"/>
-              </a:defRPr>
-            </a:pPr>
-            <a:r>
-              <a:rPr sz="1875" b="0">
+              <a:defRPr sz="1800" b="0">
+                <a:solidFill>
+                  <a:srgbClr val="F9F9F9"/>
+                </a:solidFill>
+                <a:latin typeface="Arial"/>
+                <a:ea typeface="Arial"/>
+                <a:cs typeface="Arial"/>
+              </a:defRPr>
+            </a:pPr>
+            <a:r>
+              <a:rPr sz="1800" b="0">
                 <a:solidFill>
                   <a:srgbClr val="F9F9F9"/>
                 </a:solidFill>
@@ -2599,22 +2675,22 @@
       </p:sp>
       <p:sp>
         <p:nvSpPr>
-          <p:cNvPr id="11" name="">
-            <a:extLst xmlns:a="http://schemas.openxmlformats.org/drawingml/2006/main">
-              <a:ext uri="{FF2B5EF4-FFF2-40B4-BE49-F238E27FC236}">
-                <a16:creationId xmlns:a16="http://schemas.microsoft.com/office/drawing/2014/main" id="{39F2BA9F-1585-4ED0-B69B-0A446BDC2B4D}"/>
-              </a:ext>
-            </a:extLst>
-          </p:cNvPr>
-          <p:cNvSpPr>
-            <a:spLocks xmlns:a="http://schemas.openxmlformats.org/drawingml/2006/main" noGrp="1"/>
-          </p:cNvSpPr>
-          <p:nvPr/>
-        </p:nvSpPr>
-        <p:spPr>
-          <a:xfrm xmlns:a="http://schemas.openxmlformats.org/drawingml/2006/main">
-            <a:off x="6543675" y="4914900"/>
-            <a:ext cx="5905500" cy="1028700"/>
+          <p:cNvPr id="12" name="">
+            <a:extLst xmlns:a="http://schemas.openxmlformats.org/drawingml/2006/main">
+              <a:ext uri="{FF2B5EF4-FFF2-40B4-BE49-F238E27FC236}">
+                <a16:creationId xmlns:a16="http://schemas.microsoft.com/office/drawing/2014/main" id="{83D789F8-49DA-441A-AB9B-E6B42CB30F98}"/>
+              </a:ext>
+            </a:extLst>
+          </p:cNvPr>
+          <p:cNvSpPr>
+            <a:spLocks xmlns:a="http://schemas.openxmlformats.org/drawingml/2006/main" noGrp="1"/>
+          </p:cNvSpPr>
+          <p:nvPr/>
+        </p:nvSpPr>
+        <p:spPr>
+          <a:xfrm xmlns:a="http://schemas.openxmlformats.org/drawingml/2006/main">
+            <a:off x="6543675" y="5657850"/>
+            <a:ext cx="5905500" cy="857250"/>
           </a:xfrm>
           <a:prstGeom xmlns:a="http://schemas.openxmlformats.org/drawingml/2006/main" prst="rect">
             <a:avLst/>
@@ -2631,17 +2707,17 @@
           <a:lstStyle xmlns:a="http://schemas.openxmlformats.org/drawingml/2006/main"/>
           <a:p xmlns:a="http://schemas.openxmlformats.org/drawingml/2006/main">
             <a:pPr algn="l">
-              <a:defRPr sz="1875" b="0">
-                <a:solidFill>
-                  <a:srgbClr val="F9F9F9"/>
-                </a:solidFill>
-                <a:latin typeface="Arial"/>
-                <a:ea typeface="Arial"/>
-                <a:cs typeface="Arial"/>
-              </a:defRPr>
-            </a:pPr>
-            <a:r>
-              <a:rPr sz="1875" b="0">
+              <a:defRPr sz="1800" b="0">
+                <a:solidFill>
+                  <a:srgbClr val="F9F9F9"/>
+                </a:solidFill>
+                <a:latin typeface="Arial"/>
+                <a:ea typeface="Arial"/>
+                <a:cs typeface="Arial"/>
+              </a:defRPr>
+            </a:pPr>
+            <a:r>
+              <a:rPr sz="1800" b="0">
                 <a:solidFill>
                   <a:srgbClr val="F9F9F9"/>
                 </a:solidFill>
@@ -2654,17 +2730,17 @@
           </a:p>
           <a:p xmlns:a="http://schemas.openxmlformats.org/drawingml/2006/main">
             <a:pPr algn="l">
-              <a:defRPr sz="1875" b="0">
-                <a:solidFill>
-                  <a:srgbClr val="F9F9F9"/>
-                </a:solidFill>
-                <a:latin typeface="Arial"/>
-                <a:ea typeface="Arial"/>
-                <a:cs typeface="Arial"/>
-              </a:defRPr>
-            </a:pPr>
-            <a:r>
-              <a:rPr sz="1875" b="0">
+              <a:defRPr sz="1800" b="0">
+                <a:solidFill>
+                  <a:srgbClr val="F9F9F9"/>
+                </a:solidFill>
+                <a:latin typeface="Arial"/>
+                <a:ea typeface="Arial"/>
+                <a:cs typeface="Arial"/>
+              </a:defRPr>
+            </a:pPr>
+            <a:r>
+              <a:rPr sz="1800" b="0">
                 <a:solidFill>
                   <a:srgbClr val="F9F9F9"/>
                 </a:solidFill>
@@ -2679,22 +2755,22 @@
       </p:sp>
       <p:sp>
         <p:nvSpPr>
-          <p:cNvPr id="12" name="">
-            <a:extLst xmlns:a="http://schemas.openxmlformats.org/drawingml/2006/main">
-              <a:ext uri="{FF2B5EF4-FFF2-40B4-BE49-F238E27FC236}">
-                <a16:creationId xmlns:a16="http://schemas.microsoft.com/office/drawing/2014/main" id="{CFC7A37C-2CC1-4B02-A7F8-8C95B19E7EC7}"/>
-              </a:ext>
-            </a:extLst>
-          </p:cNvPr>
-          <p:cNvSpPr>
-            <a:spLocks xmlns:a="http://schemas.openxmlformats.org/drawingml/2006/main" noGrp="1"/>
-          </p:cNvSpPr>
-          <p:nvPr/>
-        </p:nvSpPr>
-        <p:spPr>
-          <a:xfrm xmlns:a="http://schemas.openxmlformats.org/drawingml/2006/main">
-            <a:off x="800100" y="6562725"/>
-            <a:ext cx="7239000" cy="409575"/>
+          <p:cNvPr id="13" name="">
+            <a:extLst xmlns:a="http://schemas.openxmlformats.org/drawingml/2006/main">
+              <a:ext uri="{FF2B5EF4-FFF2-40B4-BE49-F238E27FC236}">
+                <a16:creationId xmlns:a16="http://schemas.microsoft.com/office/drawing/2014/main" id="{203894ED-E6B7-44D3-816D-70AE1C770D75}"/>
+              </a:ext>
+            </a:extLst>
+          </p:cNvPr>
+          <p:cNvSpPr>
+            <a:spLocks xmlns:a="http://schemas.openxmlformats.org/drawingml/2006/main" noGrp="1"/>
+          </p:cNvSpPr>
+          <p:nvPr/>
+        </p:nvSpPr>
+        <p:spPr>
+          <a:xfrm xmlns:a="http://schemas.openxmlformats.org/drawingml/2006/main">
+            <a:off x="800100" y="6753225"/>
+            <a:ext cx="7239000" cy="381000"/>
           </a:xfrm>
           <a:prstGeom xmlns:a="http://schemas.openxmlformats.org/drawingml/2006/main" prst="rect">
             <a:avLst/>
@@ -2711,17 +2787,17 @@
           <a:lstStyle xmlns:a="http://schemas.openxmlformats.org/drawingml/2006/main"/>
           <a:p xmlns:a="http://schemas.openxmlformats.org/drawingml/2006/main">
             <a:pPr algn="l">
-              <a:defRPr sz="1950" b="1">
-                <a:solidFill>
-                  <a:srgbClr val="F9F9F9"/>
-                </a:solidFill>
-                <a:latin typeface="Arial"/>
-                <a:ea typeface="Arial"/>
-                <a:cs typeface="Arial"/>
-              </a:defRPr>
-            </a:pPr>
-            <a:r>
-              <a:rPr sz="1950" b="1">
+              <a:defRPr sz="1800" b="1">
+                <a:solidFill>
+                  <a:srgbClr val="F9F9F9"/>
+                </a:solidFill>
+                <a:latin typeface="Arial"/>
+                <a:ea typeface="Arial"/>
+                <a:cs typeface="Arial"/>
+              </a:defRPr>
+            </a:pPr>
+            <a:r>
+              <a:rPr sz="1800" b="1">
                 <a:solidFill>
                   <a:srgbClr val="F9F9F9"/>
                 </a:solidFill>
@@ -2736,22 +2812,22 @@
       </p:sp>
       <p:sp>
         <p:nvSpPr>
-          <p:cNvPr id="13" name="">
-            <a:extLst xmlns:a="http://schemas.openxmlformats.org/drawingml/2006/main">
-              <a:ext uri="{FF2B5EF4-FFF2-40B4-BE49-F238E27FC236}">
-                <a16:creationId xmlns:a16="http://schemas.microsoft.com/office/drawing/2014/main" id="{94FC9A85-524B-4FA7-B716-A4746DA7B25A}"/>
-              </a:ext>
-            </a:extLst>
-          </p:cNvPr>
-          <p:cNvSpPr>
-            <a:spLocks xmlns:a="http://schemas.openxmlformats.org/drawingml/2006/main" noGrp="1"/>
-          </p:cNvSpPr>
-          <p:nvPr/>
-        </p:nvSpPr>
-        <p:spPr>
-          <a:xfrm xmlns:a="http://schemas.openxmlformats.org/drawingml/2006/main">
-            <a:off x="10668000" y="6553200"/>
-            <a:ext cx="1809750" cy="400050"/>
+          <p:cNvPr id="14" name="">
+            <a:extLst xmlns:a="http://schemas.openxmlformats.org/drawingml/2006/main">
+              <a:ext uri="{FF2B5EF4-FFF2-40B4-BE49-F238E27FC236}">
+                <a16:creationId xmlns:a16="http://schemas.microsoft.com/office/drawing/2014/main" id="{7E539167-7250-4596-8640-9419B824A5CB}"/>
+              </a:ext>
+            </a:extLst>
+          </p:cNvPr>
+          <p:cNvSpPr>
+            <a:spLocks xmlns:a="http://schemas.openxmlformats.org/drawingml/2006/main" noGrp="1"/>
+          </p:cNvSpPr>
+          <p:nvPr/>
+        </p:nvSpPr>
+        <p:spPr>
+          <a:xfrm xmlns:a="http://schemas.openxmlformats.org/drawingml/2006/main">
+            <a:off x="10668000" y="6753225"/>
+            <a:ext cx="1809750" cy="381000"/>
           </a:xfrm>
           <a:prstGeom xmlns:a="http://schemas.openxmlformats.org/drawingml/2006/main" prst="rect">
             <a:avLst/>
@@ -2768,7 +2844,7 @@
           <a:lstStyle xmlns:a="http://schemas.openxmlformats.org/drawingml/2006/main"/>
           <a:p xmlns:a="http://schemas.openxmlformats.org/drawingml/2006/main">
             <a:pPr algn="r">
-              <a:defRPr sz="1800" b="0">
+              <a:defRPr sz="1725" b="0">
                 <a:solidFill>
                   <a:srgbClr val="C9C9CE"/>
                 </a:solidFill>
@@ -2778,7 +2854,7 @@
               </a:defRPr>
             </a:pPr>
             <a:r>
-              <a:rPr sz="1800" b="0">
+              <a:rPr sz="1725" b="0">
                 <a:solidFill>
                   <a:srgbClr val="C9C9CE"/>
                 </a:solidFill>
@@ -2794,7 +2870,7 @@
     </p:spTree>
     <p:extLst>
       <p:ext uri="{BB962C8B-B14F-4D97-AF65-F5344CB8AC3E}">
-        <p14:creationId xmlns:p14="http://schemas.microsoft.com/office/powerpoint/2010/main" val="1239586838"/>
+        <p14:creationId xmlns:p14="http://schemas.microsoft.com/office/powerpoint/2010/main" val="715314823"/>
       </p:ext>
     </p:extLst>
   </p:cSld>
@@ -2825,7 +2901,7 @@
           <p:cNvPr id="16" name="">
             <a:extLst xmlns:a="http://schemas.openxmlformats.org/drawingml/2006/main">
               <a:ext uri="{FF2B5EF4-FFF2-40B4-BE49-F238E27FC236}">
-                <a16:creationId xmlns:a16="http://schemas.microsoft.com/office/drawing/2014/main" id="{AC192758-3B8E-4DA3-A764-77A2A529CC22}"/>
+                <a16:creationId xmlns:a16="http://schemas.microsoft.com/office/drawing/2014/main" id="{0B943B96-4AC6-4729-9465-CF1810190888}"/>
               </a:ext>
             </a:extLst>
           </p:cNvPr>
@@ -2855,7 +2931,7 @@
           <p:cNvPr id="2" name="">
             <a:extLst xmlns:a="http://schemas.openxmlformats.org/drawingml/2006/main">
               <a:ext uri="{FF2B5EF4-FFF2-40B4-BE49-F238E27FC236}">
-                <a16:creationId xmlns:a16="http://schemas.microsoft.com/office/drawing/2014/main" id="{B1A48B8E-5EB8-470C-80A7-F9054CB7F7E8}"/>
+                <a16:creationId xmlns:a16="http://schemas.microsoft.com/office/drawing/2014/main" id="{10B76ACD-4F65-4A8B-BD2D-52E8E75D8113}"/>
               </a:ext>
             </a:extLst>
           </p:cNvPr>
@@ -2912,7 +2988,7 @@
           <p:cNvPr id="3" name="">
             <a:extLst xmlns:a="http://schemas.openxmlformats.org/drawingml/2006/main">
               <a:ext uri="{FF2B5EF4-FFF2-40B4-BE49-F238E27FC236}">
-                <a16:creationId xmlns:a16="http://schemas.microsoft.com/office/drawing/2014/main" id="{7ECDA090-5FA9-491C-9A61-684DCDDF3FD0}"/>
+                <a16:creationId xmlns:a16="http://schemas.microsoft.com/office/drawing/2014/main" id="{2C453D94-4732-4447-B9BB-A23E79651B3D}"/>
               </a:ext>
             </a:extLst>
           </p:cNvPr>
@@ -2942,7 +3018,7 @@
           <p:cNvPr id="4" name="">
             <a:extLst xmlns:a="http://schemas.openxmlformats.org/drawingml/2006/main">
               <a:ext uri="{FF2B5EF4-FFF2-40B4-BE49-F238E27FC236}">
-                <a16:creationId xmlns:a16="http://schemas.microsoft.com/office/drawing/2014/main" id="{227ECFB0-FBA4-4400-8E2C-4E14A2CE507B}"/>
+                <a16:creationId xmlns:a16="http://schemas.microsoft.com/office/drawing/2014/main" id="{9404821E-9932-4C1D-A8EC-04AC0334CD1B}"/>
               </a:ext>
             </a:extLst>
           </p:cNvPr>
@@ -2999,7 +3075,7 @@
           <p:cNvPr id="5" name="">
             <a:extLst xmlns:a="http://schemas.openxmlformats.org/drawingml/2006/main">
               <a:ext uri="{FF2B5EF4-FFF2-40B4-BE49-F238E27FC236}">
-                <a16:creationId xmlns:a16="http://schemas.microsoft.com/office/drawing/2014/main" id="{96526336-41F7-4B68-ABCE-06EEAE153041}"/>
+                <a16:creationId xmlns:a16="http://schemas.microsoft.com/office/drawing/2014/main" id="{B0291E69-B6E0-429B-BDEB-93CE281923C1}"/>
               </a:ext>
             </a:extLst>
           </p:cNvPr>
@@ -3029,7 +3105,7 @@
           <p:cNvPr id="6" name="">
             <a:extLst xmlns:a="http://schemas.openxmlformats.org/drawingml/2006/main">
               <a:ext uri="{FF2B5EF4-FFF2-40B4-BE49-F238E27FC236}">
-                <a16:creationId xmlns:a16="http://schemas.microsoft.com/office/drawing/2014/main" id="{F37B2F16-CBC3-4C4A-A8E1-5D010821E597}"/>
+                <a16:creationId xmlns:a16="http://schemas.microsoft.com/office/drawing/2014/main" id="{6147D228-7AB6-4C9C-B2A4-19684D44A020}"/>
               </a:ext>
             </a:extLst>
           </p:cNvPr>
@@ -3086,7 +3162,7 @@
           <p:cNvPr id="7" name="">
             <a:extLst xmlns:a="http://schemas.openxmlformats.org/drawingml/2006/main">
               <a:ext uri="{FF2B5EF4-FFF2-40B4-BE49-F238E27FC236}">
-                <a16:creationId xmlns:a16="http://schemas.microsoft.com/office/drawing/2014/main" id="{96F7475C-24F8-4719-AA04-57F0193EEDB3}"/>
+                <a16:creationId xmlns:a16="http://schemas.microsoft.com/office/drawing/2014/main" id="{45D36307-39DD-477F-8A7B-F1D89174AE0F}"/>
               </a:ext>
             </a:extLst>
           </p:cNvPr>
@@ -3116,7 +3192,7 @@
           <p:cNvPr id="8" name="">
             <a:extLst xmlns:a="http://schemas.openxmlformats.org/drawingml/2006/main">
               <a:ext uri="{FF2B5EF4-FFF2-40B4-BE49-F238E27FC236}">
-                <a16:creationId xmlns:a16="http://schemas.microsoft.com/office/drawing/2014/main" id="{D1E6B4CA-E2AC-4141-9BBE-C27D69211DAC}"/>
+                <a16:creationId xmlns:a16="http://schemas.microsoft.com/office/drawing/2014/main" id="{493DA9D0-51D9-41F8-BB9D-0365D20A7695}"/>
               </a:ext>
             </a:extLst>
           </p:cNvPr>
@@ -3173,7 +3249,7 @@
           <p:cNvPr id="9" name="">
             <a:extLst xmlns:a="http://schemas.openxmlformats.org/drawingml/2006/main">
               <a:ext uri="{FF2B5EF4-FFF2-40B4-BE49-F238E27FC236}">
-                <a16:creationId xmlns:a16="http://schemas.microsoft.com/office/drawing/2014/main" id="{8473817C-E9C6-4BA4-8029-0E9BBB197D64}"/>
+                <a16:creationId xmlns:a16="http://schemas.microsoft.com/office/drawing/2014/main" id="{E6436D17-1DA2-4BEF-9139-0FAF56823D63}"/>
               </a:ext>
             </a:extLst>
           </p:cNvPr>
@@ -3203,7 +3279,7 @@
           <p:cNvPr id="10" name="">
             <a:extLst xmlns:a="http://schemas.openxmlformats.org/drawingml/2006/main">
               <a:ext uri="{FF2B5EF4-FFF2-40B4-BE49-F238E27FC236}">
-                <a16:creationId xmlns:a16="http://schemas.microsoft.com/office/drawing/2014/main" id="{479BF4D4-75E4-4905-8BEE-EBF36235C77B}"/>
+                <a16:creationId xmlns:a16="http://schemas.microsoft.com/office/drawing/2014/main" id="{C4108966-4D44-4A58-A584-36B2BE611AA6}"/>
               </a:ext>
             </a:extLst>
           </p:cNvPr>
@@ -3260,7 +3336,7 @@
           <p:cNvPr id="11" name="">
             <a:extLst xmlns:a="http://schemas.openxmlformats.org/drawingml/2006/main">
               <a:ext uri="{FF2B5EF4-FFF2-40B4-BE49-F238E27FC236}">
-                <a16:creationId xmlns:a16="http://schemas.microsoft.com/office/drawing/2014/main" id="{DF459299-3EEA-4DCC-91DC-3A0D23B353B9}"/>
+                <a16:creationId xmlns:a16="http://schemas.microsoft.com/office/drawing/2014/main" id="{BD4CB5F1-18A8-48A7-AAD2-AD28DBC4D221}"/>
               </a:ext>
             </a:extLst>
           </p:cNvPr>
@@ -3307,7 +3383,7 @@
                 <a:ea typeface="Arial"/>
                 <a:cs typeface="Arial"/>
               </a:rPr>
-              <a:t>DASHBOARD: XEM GỢI Ý CHO MỘT NGƯỜI</a:t>
+              <a:t>DASHBOARD: GỢI Ý CHO MỘT NGƯỜI</a:t>
             </a:r>
           </a:p>
         </p:txBody>
@@ -3317,7 +3393,7 @@
           <p:cNvPr id="12" name="">
             <a:extLst xmlns:a="http://schemas.openxmlformats.org/drawingml/2006/main">
               <a:ext uri="{FF2B5EF4-FFF2-40B4-BE49-F238E27FC236}">
-                <a16:creationId xmlns:a16="http://schemas.microsoft.com/office/drawing/2014/main" id="{E57F8997-868C-49C9-B936-811E4B9A68A3}"/>
+                <a16:creationId xmlns:a16="http://schemas.microsoft.com/office/drawing/2014/main" id="{2D9EC955-C387-446A-8602-1E6A48AB6088}"/>
               </a:ext>
             </a:extLst>
           </p:cNvPr>
@@ -3364,7 +3440,7 @@
                 <a:ea typeface="Arial"/>
                 <a:cs typeface="Arial"/>
               </a:rPr>
-              <a:t>Ảnh chụp chế độ SMOKE, người dùng 1 và ba cách xếp hạng.</a:t>
+              <a:t>Ảnh thật ở chế độ SMOKE: hồ sơ người dùng và ba danh sách phim.</a:t>
             </a:r>
           </a:p>
         </p:txBody>
@@ -3374,7 +3450,7 @@
           <p:cNvPr id="13" name="">
             <a:extLst xmlns:a="http://schemas.openxmlformats.org/drawingml/2006/main">
               <a:ext uri="{FF2B5EF4-FFF2-40B4-BE49-F238E27FC236}">
-                <a16:creationId xmlns:a16="http://schemas.microsoft.com/office/drawing/2014/main" id="{E5D4DCD4-BE21-4F1A-A2F4-5A26D56F036D}"/>
+                <a16:creationId xmlns:a16="http://schemas.microsoft.com/office/drawing/2014/main" id="{2E8FD257-BCE1-4B8F-A2C9-6FA9BCFE80A5}"/>
               </a:ext>
             </a:extLst>
           </p:cNvPr>
@@ -3431,19 +3507,19 @@
           <p:cNvPr id="14" name="">
             <a:extLst xmlns:a="http://schemas.openxmlformats.org/drawingml/2006/main">
               <a:ext uri="{FF2B5EF4-FFF2-40B4-BE49-F238E27FC236}">
-                <a16:creationId xmlns:a16="http://schemas.microsoft.com/office/drawing/2014/main" id="{EB1CCB66-FB2E-428A-A63F-18EC9BE6A2B5}"/>
-              </a:ext>
-            </a:extLst>
-          </p:cNvPr>
-          <p:cNvSpPr>
-            <a:spLocks xmlns:a="http://schemas.openxmlformats.org/drawingml/2006/main" noGrp="1"/>
-          </p:cNvSpPr>
-          <p:nvPr/>
-        </p:nvSpPr>
-        <p:spPr>
-          <a:xfrm xmlns:a="http://schemas.openxmlformats.org/drawingml/2006/main">
-            <a:off x="790575" y="2247900"/>
-            <a:ext cx="12144375" cy="4848225"/>
+                <a16:creationId xmlns:a16="http://schemas.microsoft.com/office/drawing/2014/main" id="{1B5B0B82-9CC8-4D14-9CBA-9E0A6BB1EB8E}"/>
+              </a:ext>
+            </a:extLst>
+          </p:cNvPr>
+          <p:cNvSpPr>
+            <a:spLocks xmlns:a="http://schemas.openxmlformats.org/drawingml/2006/main" noGrp="1"/>
+          </p:cNvSpPr>
+          <p:nvPr/>
+        </p:nvSpPr>
+        <p:spPr>
+          <a:xfrm xmlns:a="http://schemas.openxmlformats.org/drawingml/2006/main">
+            <a:off x="504825" y="1981200"/>
+            <a:ext cx="12715875" cy="5219700"/>
           </a:xfrm>
           <a:prstGeom xmlns:a="http://schemas.openxmlformats.org/drawingml/2006/main" prst="rect">
             <a:avLst/>
@@ -3465,13 +3541,13 @@
           <p:nvPr/>
         </p:nvPicPr>
         <p:blipFill>
-          <a:blip xmlns:r="http://schemas.openxmlformats.org/officeDocument/2006/relationships" xmlns:a="http://schemas.openxmlformats.org/drawingml/2006/main" r:embed="Rbe991c4dec4d4c84"/>
+          <a:blip xmlns:r="http://schemas.openxmlformats.org/officeDocument/2006/relationships" xmlns:a="http://schemas.openxmlformats.org/drawingml/2006/main" r:embed="Rd7fe13044ae44d6e"/>
           <a:stretch xmlns:a="http://schemas.openxmlformats.org/drawingml/2006/main"/>
         </p:blipFill>
         <p:spPr>
           <a:xfrm xmlns:a="http://schemas.openxmlformats.org/drawingml/2006/main">
-            <a:off x="1453792" y="2343150"/>
-            <a:ext cx="10817942" cy="4657725"/>
+            <a:off x="900727" y="2019300"/>
+            <a:ext cx="11924071" cy="5133975"/>
           </a:xfrm>
           <a:prstGeom xmlns:a="http://schemas.openxmlformats.org/drawingml/2006/main" prst="rect">
             <a:avLst/>
@@ -3481,7 +3557,7 @@
     </p:spTree>
     <p:extLst>
       <p:ext uri="{BB962C8B-B14F-4D97-AF65-F5344CB8AC3E}">
-        <p14:creationId xmlns:p14="http://schemas.microsoft.com/office/powerpoint/2010/main" val="1351089121"/>
+        <p14:creationId xmlns:p14="http://schemas.microsoft.com/office/powerpoint/2010/main" val="159013796"/>
       </p:ext>
     </p:extLst>
   </p:cSld>
@@ -3512,7 +3588,7 @@
           <p:cNvPr id="17" name="">
             <a:extLst xmlns:a="http://schemas.openxmlformats.org/drawingml/2006/main">
               <a:ext uri="{FF2B5EF4-FFF2-40B4-BE49-F238E27FC236}">
-                <a16:creationId xmlns:a16="http://schemas.microsoft.com/office/drawing/2014/main" id="{D87406FA-7069-4E38-B555-A2B76C444CEC}"/>
+                <a16:creationId xmlns:a16="http://schemas.microsoft.com/office/drawing/2014/main" id="{9E916DE9-DE1C-4B20-8D83-5B1A5B9C001B}"/>
               </a:ext>
             </a:extLst>
           </p:cNvPr>
@@ -3542,7 +3618,7 @@
           <p:cNvPr id="2" name="">
             <a:extLst xmlns:a="http://schemas.openxmlformats.org/drawingml/2006/main">
               <a:ext uri="{FF2B5EF4-FFF2-40B4-BE49-F238E27FC236}">
-                <a16:creationId xmlns:a16="http://schemas.microsoft.com/office/drawing/2014/main" id="{30A79B10-F966-49D7-A429-92B783977F6A}"/>
+                <a16:creationId xmlns:a16="http://schemas.microsoft.com/office/drawing/2014/main" id="{B5F34643-2E39-45CA-8CAA-EC767582D407}"/>
               </a:ext>
             </a:extLst>
           </p:cNvPr>
@@ -3599,7 +3675,7 @@
           <p:cNvPr id="3" name="">
             <a:extLst xmlns:a="http://schemas.openxmlformats.org/drawingml/2006/main">
               <a:ext uri="{FF2B5EF4-FFF2-40B4-BE49-F238E27FC236}">
-                <a16:creationId xmlns:a16="http://schemas.microsoft.com/office/drawing/2014/main" id="{5909739A-D027-4731-B795-E4A667E978C6}"/>
+                <a16:creationId xmlns:a16="http://schemas.microsoft.com/office/drawing/2014/main" id="{5E4CF914-08FC-4CA0-9A09-09843BF3C365}"/>
               </a:ext>
             </a:extLst>
           </p:cNvPr>
@@ -3629,7 +3705,7 @@
           <p:cNvPr id="4" name="">
             <a:extLst xmlns:a="http://schemas.openxmlformats.org/drawingml/2006/main">
               <a:ext uri="{FF2B5EF4-FFF2-40B4-BE49-F238E27FC236}">
-                <a16:creationId xmlns:a16="http://schemas.microsoft.com/office/drawing/2014/main" id="{015AAAD0-13D7-46E1-89FF-0B3FFFECCAD2}"/>
+                <a16:creationId xmlns:a16="http://schemas.microsoft.com/office/drawing/2014/main" id="{A7B2E788-3179-47BF-99DF-24B1342634A3}"/>
               </a:ext>
             </a:extLst>
           </p:cNvPr>
@@ -3686,7 +3762,7 @@
           <p:cNvPr id="5" name="">
             <a:extLst xmlns:a="http://schemas.openxmlformats.org/drawingml/2006/main">
               <a:ext uri="{FF2B5EF4-FFF2-40B4-BE49-F238E27FC236}">
-                <a16:creationId xmlns:a16="http://schemas.microsoft.com/office/drawing/2014/main" id="{84B3497B-2187-48D7-A9C3-5AD3370BDBF2}"/>
+                <a16:creationId xmlns:a16="http://schemas.microsoft.com/office/drawing/2014/main" id="{0A64C75A-415A-40B0-9B73-A40880BE0290}"/>
               </a:ext>
             </a:extLst>
           </p:cNvPr>
@@ -3716,7 +3792,7 @@
           <p:cNvPr id="6" name="">
             <a:extLst xmlns:a="http://schemas.openxmlformats.org/drawingml/2006/main">
               <a:ext uri="{FF2B5EF4-FFF2-40B4-BE49-F238E27FC236}">
-                <a16:creationId xmlns:a16="http://schemas.microsoft.com/office/drawing/2014/main" id="{C7139AE7-37B1-4B58-942C-90F85884D3BD}"/>
+                <a16:creationId xmlns:a16="http://schemas.microsoft.com/office/drawing/2014/main" id="{7016C105-B3F2-49F0-98F3-97D005B99F67}"/>
               </a:ext>
             </a:extLst>
           </p:cNvPr>
@@ -3773,7 +3849,7 @@
           <p:cNvPr id="7" name="">
             <a:extLst xmlns:a="http://schemas.openxmlformats.org/drawingml/2006/main">
               <a:ext uri="{FF2B5EF4-FFF2-40B4-BE49-F238E27FC236}">
-                <a16:creationId xmlns:a16="http://schemas.microsoft.com/office/drawing/2014/main" id="{6BA6B566-22BE-4A7A-8FB4-B91370BE4ED0}"/>
+                <a16:creationId xmlns:a16="http://schemas.microsoft.com/office/drawing/2014/main" id="{F7BC93BE-E230-4A1D-BA35-6F2BB7058F85}"/>
               </a:ext>
             </a:extLst>
           </p:cNvPr>
@@ -3803,7 +3879,7 @@
           <p:cNvPr id="8" name="">
             <a:extLst xmlns:a="http://schemas.openxmlformats.org/drawingml/2006/main">
               <a:ext uri="{FF2B5EF4-FFF2-40B4-BE49-F238E27FC236}">
-                <a16:creationId xmlns:a16="http://schemas.microsoft.com/office/drawing/2014/main" id="{76882CBB-DF16-4082-9ECD-43796E6BD157}"/>
+                <a16:creationId xmlns:a16="http://schemas.microsoft.com/office/drawing/2014/main" id="{2A83AC05-9D6E-45D2-8D00-D7E3EAD2D162}"/>
               </a:ext>
             </a:extLst>
           </p:cNvPr>
@@ -3860,7 +3936,7 @@
           <p:cNvPr id="9" name="">
             <a:extLst xmlns:a="http://schemas.openxmlformats.org/drawingml/2006/main">
               <a:ext uri="{FF2B5EF4-FFF2-40B4-BE49-F238E27FC236}">
-                <a16:creationId xmlns:a16="http://schemas.microsoft.com/office/drawing/2014/main" id="{54B55572-20EE-41C4-8B1A-FC47B01266F3}"/>
+                <a16:creationId xmlns:a16="http://schemas.microsoft.com/office/drawing/2014/main" id="{69A383A0-0891-41B9-9AB3-ADE650AC636F}"/>
               </a:ext>
             </a:extLst>
           </p:cNvPr>
@@ -3890,7 +3966,7 @@
           <p:cNvPr id="10" name="">
             <a:extLst xmlns:a="http://schemas.openxmlformats.org/drawingml/2006/main">
               <a:ext uri="{FF2B5EF4-FFF2-40B4-BE49-F238E27FC236}">
-                <a16:creationId xmlns:a16="http://schemas.microsoft.com/office/drawing/2014/main" id="{453EED95-F376-400C-82BE-CE9A1CC80A6F}"/>
+                <a16:creationId xmlns:a16="http://schemas.microsoft.com/office/drawing/2014/main" id="{264836BE-4773-42AE-B627-EFEB104B955C}"/>
               </a:ext>
             </a:extLst>
           </p:cNvPr>
@@ -3947,7 +4023,7 @@
           <p:cNvPr id="11" name="">
             <a:extLst xmlns:a="http://schemas.openxmlformats.org/drawingml/2006/main">
               <a:ext uri="{FF2B5EF4-FFF2-40B4-BE49-F238E27FC236}">
-                <a16:creationId xmlns:a16="http://schemas.microsoft.com/office/drawing/2014/main" id="{7A771FD2-EBB7-4761-BDBA-F9A3AD4025E7}"/>
+                <a16:creationId xmlns:a16="http://schemas.microsoft.com/office/drawing/2014/main" id="{6AE7D183-E749-44D4-B0CD-436E52F1D207}"/>
               </a:ext>
             </a:extLst>
           </p:cNvPr>
@@ -4004,7 +4080,7 @@
           <p:cNvPr id="12" name="">
             <a:extLst xmlns:a="http://schemas.openxmlformats.org/drawingml/2006/main">
               <a:ext uri="{FF2B5EF4-FFF2-40B4-BE49-F238E27FC236}">
-                <a16:creationId xmlns:a16="http://schemas.microsoft.com/office/drawing/2014/main" id="{93E90489-A284-4390-AADC-F187698A87B5}"/>
+                <a16:creationId xmlns:a16="http://schemas.microsoft.com/office/drawing/2014/main" id="{E0F9F17B-16F7-4655-B63C-DFB245179C8B}"/>
               </a:ext>
             </a:extLst>
           </p:cNvPr>
@@ -4061,7 +4137,7 @@
           <p:cNvPr id="13" name="">
             <a:extLst xmlns:a="http://schemas.openxmlformats.org/drawingml/2006/main">
               <a:ext uri="{FF2B5EF4-FFF2-40B4-BE49-F238E27FC236}">
-                <a16:creationId xmlns:a16="http://schemas.microsoft.com/office/drawing/2014/main" id="{55C87F88-6F03-40C1-8C7F-6B344BE3236F}"/>
+                <a16:creationId xmlns:a16="http://schemas.microsoft.com/office/drawing/2014/main" id="{644AFBD2-675D-45E2-B519-6D7E7A61BCD5}"/>
               </a:ext>
             </a:extLst>
           </p:cNvPr>
@@ -4118,7 +4194,7 @@
           <p:cNvPr id="14" name="">
             <a:extLst xmlns:a="http://schemas.openxmlformats.org/drawingml/2006/main">
               <a:ext uri="{FF2B5EF4-FFF2-40B4-BE49-F238E27FC236}">
-                <a16:creationId xmlns:a16="http://schemas.microsoft.com/office/drawing/2014/main" id="{3FE1D6C5-2CEA-457D-B482-A0FF4618B75D}"/>
+                <a16:creationId xmlns:a16="http://schemas.microsoft.com/office/drawing/2014/main" id="{CD0314AA-7C7B-451C-9AD2-16764266A76F}"/>
               </a:ext>
             </a:extLst>
           </p:cNvPr>
@@ -4155,7 +4231,7 @@
         </p:xfrm>
         <a:graphic xmlns:a="http://schemas.openxmlformats.org/drawingml/2006/main">
           <a:graphicData uri="http://schemas.openxmlformats.org/drawingml/2006/chart">
-            <c:chart xmlns:r="http://schemas.openxmlformats.org/officeDocument/2006/relationships" xmlns:c="http://schemas.openxmlformats.org/drawingml/2006/chart" r:id="R2c4adacfe76f405f"/>
+            <c:chart xmlns:r="http://schemas.openxmlformats.org/officeDocument/2006/relationships" xmlns:c="http://schemas.openxmlformats.org/drawingml/2006/chart" r:id="Re6b1a93429354f5e"/>
           </a:graphicData>
         </a:graphic>
       </p:graphicFrame>
@@ -4164,7 +4240,7 @@
           <p:cNvPr id="16" name="">
             <a:extLst xmlns:a="http://schemas.openxmlformats.org/drawingml/2006/main">
               <a:ext uri="{FF2B5EF4-FFF2-40B4-BE49-F238E27FC236}">
-                <a16:creationId xmlns:a16="http://schemas.microsoft.com/office/drawing/2014/main" id="{7278E740-54FA-4B53-A5C4-214CC3A54EAF}"/>
+                <a16:creationId xmlns:a16="http://schemas.microsoft.com/office/drawing/2014/main" id="{90297316-6A10-4880-9AD5-69AFDB8942E2}"/>
               </a:ext>
             </a:extLst>
           </p:cNvPr>
@@ -4219,7 +4295,7 @@
     </p:spTree>
     <p:extLst>
       <p:ext uri="{BB962C8B-B14F-4D97-AF65-F5344CB8AC3E}">
-        <p14:creationId xmlns:p14="http://schemas.microsoft.com/office/powerpoint/2010/main" val="324019123"/>
+        <p14:creationId xmlns:p14="http://schemas.microsoft.com/office/powerpoint/2010/main" val="2039077655"/>
       </p:ext>
     </p:extLst>
   </p:cSld>
@@ -4250,7 +4326,7 @@
           <p:cNvPr id="22" name="">
             <a:extLst xmlns:a="http://schemas.openxmlformats.org/drawingml/2006/main">
               <a:ext uri="{FF2B5EF4-FFF2-40B4-BE49-F238E27FC236}">
-                <a16:creationId xmlns:a16="http://schemas.microsoft.com/office/drawing/2014/main" id="{0E3F0FAB-E6C5-4244-A798-B25407D1A0FB}"/>
+                <a16:creationId xmlns:a16="http://schemas.microsoft.com/office/drawing/2014/main" id="{BAF1970B-F57A-4B31-8FDC-CEAC1E4D3B33}"/>
               </a:ext>
             </a:extLst>
           </p:cNvPr>
@@ -4280,7 +4356,7 @@
           <p:cNvPr id="2" name="">
             <a:extLst xmlns:a="http://schemas.openxmlformats.org/drawingml/2006/main">
               <a:ext uri="{FF2B5EF4-FFF2-40B4-BE49-F238E27FC236}">
-                <a16:creationId xmlns:a16="http://schemas.microsoft.com/office/drawing/2014/main" id="{684F60D9-931C-4E3F-BF2D-B74E2FBCC78A}"/>
+                <a16:creationId xmlns:a16="http://schemas.microsoft.com/office/drawing/2014/main" id="{9C38D726-7622-4224-973B-91FEEDB416BA}"/>
               </a:ext>
             </a:extLst>
           </p:cNvPr>
@@ -4337,7 +4413,7 @@
           <p:cNvPr id="3" name="">
             <a:extLst xmlns:a="http://schemas.openxmlformats.org/drawingml/2006/main">
               <a:ext uri="{FF2B5EF4-FFF2-40B4-BE49-F238E27FC236}">
-                <a16:creationId xmlns:a16="http://schemas.microsoft.com/office/drawing/2014/main" id="{237C9505-F82A-42CF-A7BC-C68A2DD9687A}"/>
+                <a16:creationId xmlns:a16="http://schemas.microsoft.com/office/drawing/2014/main" id="{09F0556A-FCDF-4A9C-9FBE-6FF086CD5593}"/>
               </a:ext>
             </a:extLst>
           </p:cNvPr>
@@ -4367,7 +4443,7 @@
           <p:cNvPr id="4" name="">
             <a:extLst xmlns:a="http://schemas.openxmlformats.org/drawingml/2006/main">
               <a:ext uri="{FF2B5EF4-FFF2-40B4-BE49-F238E27FC236}">
-                <a16:creationId xmlns:a16="http://schemas.microsoft.com/office/drawing/2014/main" id="{CCDF042F-9601-41EF-A4C8-7A8FAD5B1D92}"/>
+                <a16:creationId xmlns:a16="http://schemas.microsoft.com/office/drawing/2014/main" id="{7587280D-7CFB-4559-9E10-1ADA88989D5C}"/>
               </a:ext>
             </a:extLst>
           </p:cNvPr>
@@ -4424,7 +4500,7 @@
           <p:cNvPr id="5" name="">
             <a:extLst xmlns:a="http://schemas.openxmlformats.org/drawingml/2006/main">
               <a:ext uri="{FF2B5EF4-FFF2-40B4-BE49-F238E27FC236}">
-                <a16:creationId xmlns:a16="http://schemas.microsoft.com/office/drawing/2014/main" id="{EB4E0ECC-58EA-4634-8A43-F56DA3892ADE}"/>
+                <a16:creationId xmlns:a16="http://schemas.microsoft.com/office/drawing/2014/main" id="{B5EFD281-4637-48DC-BA2A-9EEAAA1D0990}"/>
               </a:ext>
             </a:extLst>
           </p:cNvPr>
@@ -4454,7 +4530,7 @@
           <p:cNvPr id="6" name="">
             <a:extLst xmlns:a="http://schemas.openxmlformats.org/drawingml/2006/main">
               <a:ext uri="{FF2B5EF4-FFF2-40B4-BE49-F238E27FC236}">
-                <a16:creationId xmlns:a16="http://schemas.microsoft.com/office/drawing/2014/main" id="{EFCAEAA0-01D3-4868-8513-EB73D64CC101}"/>
+                <a16:creationId xmlns:a16="http://schemas.microsoft.com/office/drawing/2014/main" id="{96342040-4860-45AB-A579-CF6E81058835}"/>
               </a:ext>
             </a:extLst>
           </p:cNvPr>
@@ -4511,7 +4587,7 @@
           <p:cNvPr id="7" name="">
             <a:extLst xmlns:a="http://schemas.openxmlformats.org/drawingml/2006/main">
               <a:ext uri="{FF2B5EF4-FFF2-40B4-BE49-F238E27FC236}">
-                <a16:creationId xmlns:a16="http://schemas.microsoft.com/office/drawing/2014/main" id="{671D7BA0-A7A9-4993-8BEB-90DF73053DE4}"/>
+                <a16:creationId xmlns:a16="http://schemas.microsoft.com/office/drawing/2014/main" id="{CFBC6846-901A-48A7-AAD1-2A47A2F16395}"/>
               </a:ext>
             </a:extLst>
           </p:cNvPr>
@@ -4541,7 +4617,7 @@
           <p:cNvPr id="8" name="">
             <a:extLst xmlns:a="http://schemas.openxmlformats.org/drawingml/2006/main">
               <a:ext uri="{FF2B5EF4-FFF2-40B4-BE49-F238E27FC236}">
-                <a16:creationId xmlns:a16="http://schemas.microsoft.com/office/drawing/2014/main" id="{749DF864-9F9A-4600-8321-EDF2EDDE084B}"/>
+                <a16:creationId xmlns:a16="http://schemas.microsoft.com/office/drawing/2014/main" id="{27433426-B7C6-4810-A2C6-2292CF4CE56C}"/>
               </a:ext>
             </a:extLst>
           </p:cNvPr>
@@ -4598,7 +4674,7 @@
           <p:cNvPr id="9" name="">
             <a:extLst xmlns:a="http://schemas.openxmlformats.org/drawingml/2006/main">
               <a:ext uri="{FF2B5EF4-FFF2-40B4-BE49-F238E27FC236}">
-                <a16:creationId xmlns:a16="http://schemas.microsoft.com/office/drawing/2014/main" id="{2C102F94-7C26-4F20-8D32-DF988A8590CF}"/>
+                <a16:creationId xmlns:a16="http://schemas.microsoft.com/office/drawing/2014/main" id="{25A9207F-13DD-4B31-9B86-EC9C43D419D4}"/>
               </a:ext>
             </a:extLst>
           </p:cNvPr>
@@ -4628,7 +4704,7 @@
           <p:cNvPr id="10" name="">
             <a:extLst xmlns:a="http://schemas.openxmlformats.org/drawingml/2006/main">
               <a:ext uri="{FF2B5EF4-FFF2-40B4-BE49-F238E27FC236}">
-                <a16:creationId xmlns:a16="http://schemas.microsoft.com/office/drawing/2014/main" id="{D00608B7-4F80-4B46-8D00-30F6FF7305D9}"/>
+                <a16:creationId xmlns:a16="http://schemas.microsoft.com/office/drawing/2014/main" id="{AD8116C4-AE0B-40E9-8436-441A5D5C563C}"/>
               </a:ext>
             </a:extLst>
           </p:cNvPr>
@@ -4685,7 +4761,7 @@
           <p:cNvPr id="11" name="">
             <a:extLst xmlns:a="http://schemas.openxmlformats.org/drawingml/2006/main">
               <a:ext uri="{FF2B5EF4-FFF2-40B4-BE49-F238E27FC236}">
-                <a16:creationId xmlns:a16="http://schemas.microsoft.com/office/drawing/2014/main" id="{073E8708-F8AB-47E8-8E6C-7F4040FD4D03}"/>
+                <a16:creationId xmlns:a16="http://schemas.microsoft.com/office/drawing/2014/main" id="{04F65940-71B1-4A89-AD33-94CCD9BA475B}"/>
               </a:ext>
             </a:extLst>
           </p:cNvPr>
@@ -4742,7 +4818,7 @@
           <p:cNvPr id="12" name="">
             <a:extLst xmlns:a="http://schemas.openxmlformats.org/drawingml/2006/main">
               <a:ext uri="{FF2B5EF4-FFF2-40B4-BE49-F238E27FC236}">
-                <a16:creationId xmlns:a16="http://schemas.microsoft.com/office/drawing/2014/main" id="{445A1B50-96CF-416A-8E6D-BF773770793A}"/>
+                <a16:creationId xmlns:a16="http://schemas.microsoft.com/office/drawing/2014/main" id="{678361E5-5464-4398-8D25-E5492C4A04DC}"/>
               </a:ext>
             </a:extLst>
           </p:cNvPr>
@@ -4799,7 +4875,7 @@
           <p:cNvPr id="13" name="">
             <a:extLst xmlns:a="http://schemas.openxmlformats.org/drawingml/2006/main">
               <a:ext uri="{FF2B5EF4-FFF2-40B4-BE49-F238E27FC236}">
-                <a16:creationId xmlns:a16="http://schemas.microsoft.com/office/drawing/2014/main" id="{B54E3617-567D-4182-B9AE-D4257FC2C9B6}"/>
+                <a16:creationId xmlns:a16="http://schemas.microsoft.com/office/drawing/2014/main" id="{705C8B19-8E52-49D2-8F03-69B2E71908D3}"/>
               </a:ext>
             </a:extLst>
           </p:cNvPr>
@@ -4856,7 +4932,7 @@
           <p:cNvPr id="14" name="">
             <a:extLst xmlns:a="http://schemas.openxmlformats.org/drawingml/2006/main">
               <a:ext uri="{FF2B5EF4-FFF2-40B4-BE49-F238E27FC236}">
-                <a16:creationId xmlns:a16="http://schemas.microsoft.com/office/drawing/2014/main" id="{CB5D99BF-5C73-429C-87EB-7B4A415FB307}"/>
+                <a16:creationId xmlns:a16="http://schemas.microsoft.com/office/drawing/2014/main" id="{7A9D8AB1-02B2-4342-82E2-FFE6F25E0071}"/>
               </a:ext>
             </a:extLst>
           </p:cNvPr>
@@ -4886,7 +4962,7 @@
           <p:cNvPr id="15" name="">
             <a:extLst xmlns:a="http://schemas.openxmlformats.org/drawingml/2006/main">
               <a:ext uri="{FF2B5EF4-FFF2-40B4-BE49-F238E27FC236}">
-                <a16:creationId xmlns:a16="http://schemas.microsoft.com/office/drawing/2014/main" id="{779D902D-4D95-431E-AB8C-F3226C36A428}"/>
+                <a16:creationId xmlns:a16="http://schemas.microsoft.com/office/drawing/2014/main" id="{42FDC2B1-A784-4A79-844E-464D2C667DB1}"/>
               </a:ext>
             </a:extLst>
           </p:cNvPr>
@@ -4943,7 +5019,7 @@
           <p:cNvPr id="16" name="">
             <a:extLst xmlns:a="http://schemas.openxmlformats.org/drawingml/2006/main">
               <a:ext uri="{FF2B5EF4-FFF2-40B4-BE49-F238E27FC236}">
-                <a16:creationId xmlns:a16="http://schemas.microsoft.com/office/drawing/2014/main" id="{93659DAD-5474-4ADB-8D3B-F0437ABEBA3B}"/>
+                <a16:creationId xmlns:a16="http://schemas.microsoft.com/office/drawing/2014/main" id="{91E80833-C8C0-4F56-95B2-1FA5768ED3BF}"/>
               </a:ext>
             </a:extLst>
           </p:cNvPr>
@@ -5000,7 +5076,7 @@
           <p:cNvPr id="17" name="">
             <a:extLst xmlns:a="http://schemas.openxmlformats.org/drawingml/2006/main">
               <a:ext uri="{FF2B5EF4-FFF2-40B4-BE49-F238E27FC236}">
-                <a16:creationId xmlns:a16="http://schemas.microsoft.com/office/drawing/2014/main" id="{76F3C698-BC37-4642-B59B-179F5D6F1E2B}"/>
+                <a16:creationId xmlns:a16="http://schemas.microsoft.com/office/drawing/2014/main" id="{0FCEB2C3-0B99-47B6-AB09-D846826B455A}"/>
               </a:ext>
             </a:extLst>
           </p:cNvPr>
@@ -5030,7 +5106,7 @@
           <p:cNvPr id="18" name="">
             <a:extLst xmlns:a="http://schemas.openxmlformats.org/drawingml/2006/main">
               <a:ext uri="{FF2B5EF4-FFF2-40B4-BE49-F238E27FC236}">
-                <a16:creationId xmlns:a16="http://schemas.microsoft.com/office/drawing/2014/main" id="{FE2CF806-28C5-4C50-BE8C-98B7717CA289}"/>
+                <a16:creationId xmlns:a16="http://schemas.microsoft.com/office/drawing/2014/main" id="{0D9951DE-E712-4A6B-8F48-67373772D9AA}"/>
               </a:ext>
             </a:extLst>
           </p:cNvPr>
@@ -5087,7 +5163,7 @@
           <p:cNvPr id="19" name="">
             <a:extLst xmlns:a="http://schemas.openxmlformats.org/drawingml/2006/main">
               <a:ext uri="{FF2B5EF4-FFF2-40B4-BE49-F238E27FC236}">
-                <a16:creationId xmlns:a16="http://schemas.microsoft.com/office/drawing/2014/main" id="{6200DD5C-90AE-4821-8A2B-650FC216E519}"/>
+                <a16:creationId xmlns:a16="http://schemas.microsoft.com/office/drawing/2014/main" id="{34B1187B-5C24-4CCF-89CD-66C6C977667E}"/>
               </a:ext>
             </a:extLst>
           </p:cNvPr>
@@ -5144,7 +5220,7 @@
           <p:cNvPr id="20" name="">
             <a:extLst xmlns:a="http://schemas.openxmlformats.org/drawingml/2006/main">
               <a:ext uri="{FF2B5EF4-FFF2-40B4-BE49-F238E27FC236}">
-                <a16:creationId xmlns:a16="http://schemas.microsoft.com/office/drawing/2014/main" id="{CED31AF1-D925-4608-BFFA-BD5C6B1B613C}"/>
+                <a16:creationId xmlns:a16="http://schemas.microsoft.com/office/drawing/2014/main" id="{86AE33E0-7085-462E-8645-01169D6E41D9}"/>
               </a:ext>
             </a:extLst>
           </p:cNvPr>
@@ -5174,7 +5250,7 @@
           <p:cNvPr id="21" name="">
             <a:extLst xmlns:a="http://schemas.openxmlformats.org/drawingml/2006/main">
               <a:ext uri="{FF2B5EF4-FFF2-40B4-BE49-F238E27FC236}">
-                <a16:creationId xmlns:a16="http://schemas.microsoft.com/office/drawing/2014/main" id="{D5D1D749-D638-4E90-ABEE-B3AF691923AB}"/>
+                <a16:creationId xmlns:a16="http://schemas.microsoft.com/office/drawing/2014/main" id="{86FB6DD1-E3AE-4D23-BCED-6BD96B7E469F}"/>
               </a:ext>
             </a:extLst>
           </p:cNvPr>
@@ -5229,7 +5305,7 @@
     </p:spTree>
     <p:extLst>
       <p:ext uri="{BB962C8B-B14F-4D97-AF65-F5344CB8AC3E}">
-        <p14:creationId xmlns:p14="http://schemas.microsoft.com/office/powerpoint/2010/main" val="1894635877"/>
+        <p14:creationId xmlns:p14="http://schemas.microsoft.com/office/powerpoint/2010/main" val="1525377107"/>
       </p:ext>
     </p:extLst>
   </p:cSld>
@@ -5260,7 +5336,7 @@
           <p:cNvPr id="9" name="">
             <a:extLst xmlns:a="http://schemas.openxmlformats.org/drawingml/2006/main">
               <a:ext uri="{FF2B5EF4-FFF2-40B4-BE49-F238E27FC236}">
-                <a16:creationId xmlns:a16="http://schemas.microsoft.com/office/drawing/2014/main" id="{1B818DB4-CB87-4132-BA96-9941057E666C}"/>
+                <a16:creationId xmlns:a16="http://schemas.microsoft.com/office/drawing/2014/main" id="{A03A9254-28C8-4519-A532-A24506E5C1B2}"/>
               </a:ext>
             </a:extLst>
           </p:cNvPr>
@@ -5294,7 +5370,7 @@
           <p:nvPr/>
         </p:nvPicPr>
         <p:blipFill>
-          <a:blip xmlns:r="http://schemas.openxmlformats.org/officeDocument/2006/relationships" xmlns:a="http://schemas.openxmlformats.org/drawingml/2006/main" r:embed="Ra450db418fea403a"/>
+          <a:blip xmlns:r="http://schemas.openxmlformats.org/officeDocument/2006/relationships" xmlns:a="http://schemas.openxmlformats.org/drawingml/2006/main" r:embed="R0932ecabff00472c"/>
           <a:stretch xmlns:a="http://schemas.openxmlformats.org/drawingml/2006/main"/>
         </p:blipFill>
         <p:spPr>
@@ -5312,7 +5388,7 @@
           <p:cNvPr id="3" name="">
             <a:extLst xmlns:a="http://schemas.openxmlformats.org/drawingml/2006/main">
               <a:ext uri="{FF2B5EF4-FFF2-40B4-BE49-F238E27FC236}">
-                <a16:creationId xmlns:a16="http://schemas.microsoft.com/office/drawing/2014/main" id="{2C5F22ED-3DCB-4AE0-8199-03C054A49F3A}"/>
+                <a16:creationId xmlns:a16="http://schemas.microsoft.com/office/drawing/2014/main" id="{A38F8957-9A3E-45B0-B608-D5EE64A17E98}"/>
               </a:ext>
             </a:extLst>
           </p:cNvPr>
@@ -5369,7 +5445,7 @@
           <p:cNvPr id="4" name="">
             <a:extLst xmlns:a="http://schemas.openxmlformats.org/drawingml/2006/main">
               <a:ext uri="{FF2B5EF4-FFF2-40B4-BE49-F238E27FC236}">
-                <a16:creationId xmlns:a16="http://schemas.microsoft.com/office/drawing/2014/main" id="{A508DAFF-933C-4214-861A-24580083D6B0}"/>
+                <a16:creationId xmlns:a16="http://schemas.microsoft.com/office/drawing/2014/main" id="{761F10D1-1FD2-4A23-9E4A-704C59CD48DB}"/>
               </a:ext>
             </a:extLst>
           </p:cNvPr>
@@ -5426,7 +5502,7 @@
           <p:cNvPr id="5" name="">
             <a:extLst xmlns:a="http://schemas.openxmlformats.org/drawingml/2006/main">
               <a:ext uri="{FF2B5EF4-FFF2-40B4-BE49-F238E27FC236}">
-                <a16:creationId xmlns:a16="http://schemas.microsoft.com/office/drawing/2014/main" id="{EAEBDF3B-5E00-48B4-90BC-6A3EFA633E70}"/>
+                <a16:creationId xmlns:a16="http://schemas.microsoft.com/office/drawing/2014/main" id="{75A952F0-001B-499D-857A-CE9838EEFA0D}"/>
               </a:ext>
             </a:extLst>
           </p:cNvPr>
@@ -5456,7 +5532,7 @@
           <p:cNvPr id="6" name="">
             <a:extLst xmlns:a="http://schemas.openxmlformats.org/drawingml/2006/main">
               <a:ext uri="{FF2B5EF4-FFF2-40B4-BE49-F238E27FC236}">
-                <a16:creationId xmlns:a16="http://schemas.microsoft.com/office/drawing/2014/main" id="{FBA08A03-9624-488E-8BE0-2841839C5014}"/>
+                <a16:creationId xmlns:a16="http://schemas.microsoft.com/office/drawing/2014/main" id="{6BB92A5B-5B3B-4BDB-B1DA-02CC22F76513}"/>
               </a:ext>
             </a:extLst>
           </p:cNvPr>
@@ -5513,7 +5589,7 @@
           <p:cNvPr id="7" name="">
             <a:extLst xmlns:a="http://schemas.openxmlformats.org/drawingml/2006/main">
               <a:ext uri="{FF2B5EF4-FFF2-40B4-BE49-F238E27FC236}">
-                <a16:creationId xmlns:a16="http://schemas.microsoft.com/office/drawing/2014/main" id="{EEC53757-E18B-4F5D-8892-7B5E4D0AA808}"/>
+                <a16:creationId xmlns:a16="http://schemas.microsoft.com/office/drawing/2014/main" id="{A8C69042-9ADA-4873-AD35-C9F5BF13842A}"/>
               </a:ext>
             </a:extLst>
           </p:cNvPr>
@@ -5570,7 +5646,7 @@
           <p:cNvPr id="8" name="">
             <a:extLst xmlns:a="http://schemas.openxmlformats.org/drawingml/2006/main">
               <a:ext uri="{FF2B5EF4-FFF2-40B4-BE49-F238E27FC236}">
-                <a16:creationId xmlns:a16="http://schemas.microsoft.com/office/drawing/2014/main" id="{1B0B413F-682F-4BAF-BCE5-95B131E45CCB}"/>
+                <a16:creationId xmlns:a16="http://schemas.microsoft.com/office/drawing/2014/main" id="{1B476107-F3A7-48BD-98D0-68495706834F}"/>
               </a:ext>
             </a:extLst>
           </p:cNvPr>
@@ -5625,7 +5701,7 @@
     </p:spTree>
     <p:extLst>
       <p:ext uri="{BB962C8B-B14F-4D97-AF65-F5344CB8AC3E}">
-        <p14:creationId xmlns:p14="http://schemas.microsoft.com/office/powerpoint/2010/main" val="33189316"/>
+        <p14:creationId xmlns:p14="http://schemas.microsoft.com/office/powerpoint/2010/main" val="284366183"/>
       </p:ext>
     </p:extLst>
   </p:cSld>
@@ -5653,24 +5729,24 @@
       </p:grpSpPr>
       <p:sp>
         <p:nvSpPr>
-          <p:cNvPr id="8" name="">
-            <a:extLst xmlns:a="http://schemas.openxmlformats.org/drawingml/2006/main">
-              <a:ext uri="{FF2B5EF4-FFF2-40B4-BE49-F238E27FC236}">
-                <a16:creationId xmlns:a16="http://schemas.microsoft.com/office/drawing/2014/main" id="{A0AC3C2A-ACC2-4071-B926-8B39F5E7613A}"/>
-              </a:ext>
-            </a:extLst>
-          </p:cNvPr>
-          <p:cNvSpPr>
-            <a:spLocks xmlns:a="http://schemas.openxmlformats.org/drawingml/2006/main" noGrp="1"/>
-          </p:cNvSpPr>
-          <p:nvPr/>
-        </p:nvSpPr>
-        <p:spPr>
-          <a:xfrm xmlns:a="http://schemas.openxmlformats.org/drawingml/2006/main">
-            <a:off x="0" y="0"/>
-            <a:ext cx="228600" cy="7715250"/>
-          </a:xfrm>
-          <a:prstGeom xmlns:a="http://schemas.openxmlformats.org/drawingml/2006/main" prst="rect">
+          <p:cNvPr id="28" name="">
+            <a:extLst xmlns:a="http://schemas.openxmlformats.org/drawingml/2006/main">
+              <a:ext uri="{FF2B5EF4-FFF2-40B4-BE49-F238E27FC236}">
+                <a16:creationId xmlns:a16="http://schemas.microsoft.com/office/drawing/2014/main" id="{E78691BC-CE18-45FA-ACC9-F38485A7E805}"/>
+              </a:ext>
+            </a:extLst>
+          </p:cNvPr>
+          <p:cNvSpPr>
+            <a:spLocks xmlns:a="http://schemas.openxmlformats.org/drawingml/2006/main" noGrp="1"/>
+          </p:cNvSpPr>
+          <p:nvPr/>
+        </p:nvSpPr>
+        <p:spPr>
+          <a:xfrm xmlns:a="http://schemas.openxmlformats.org/drawingml/2006/main">
+            <a:off x="542925" y="171450"/>
+            <a:ext cx="2476500" cy="533400"/>
+          </a:xfrm>
+          <a:prstGeom xmlns:a="http://schemas.openxmlformats.org/drawingml/2006/main" prst="rightArrow">
             <a:avLst/>
           </a:prstGeom>
           <a:solidFill xmlns:a="http://schemas.openxmlformats.org/drawingml/2006/main">
@@ -5681,46 +5757,429 @@
           </a:ln>
         </p:spPr>
       </p:sp>
-      <p:pic>
-        <p:nvPicPr>
-          <p:cNvPr id="9" name=""/>
-          <p:cNvPicPr>
-            <a:picLocks xmlns:a="http://schemas.openxmlformats.org/drawingml/2006/main" noChangeAspect="1"/>
-          </p:cNvPicPr>
-          <p:nvPr/>
-        </p:nvPicPr>
-        <p:blipFill>
-          <a:blip xmlns:r="http://schemas.openxmlformats.org/officeDocument/2006/relationships" xmlns:a="http://schemas.openxmlformats.org/drawingml/2006/main" r:embed="R1731bdff38d842bf"/>
-          <a:stretch xmlns:a="http://schemas.openxmlformats.org/drawingml/2006/main"/>
-        </p:blipFill>
-        <p:spPr>
-          <a:xfrm xmlns:a="http://schemas.openxmlformats.org/drawingml/2006/main">
-            <a:off x="10906125" y="569375"/>
-            <a:ext cx="1714500" cy="1413950"/>
-          </a:xfrm>
-          <a:prstGeom xmlns:a="http://schemas.openxmlformats.org/drawingml/2006/main" prst="rect">
-            <a:avLst/>
-          </a:prstGeom>
-        </p:spPr>
-      </p:pic>
+      <p:sp>
+        <p:nvSpPr>
+          <p:cNvPr id="2" name="">
+            <a:extLst xmlns:a="http://schemas.openxmlformats.org/drawingml/2006/main">
+              <a:ext uri="{FF2B5EF4-FFF2-40B4-BE49-F238E27FC236}">
+                <a16:creationId xmlns:a16="http://schemas.microsoft.com/office/drawing/2014/main" id="{A1405465-1CB4-4CEA-976E-EA7244913D75}"/>
+              </a:ext>
+            </a:extLst>
+          </p:cNvPr>
+          <p:cNvSpPr>
+            <a:spLocks xmlns:a="http://schemas.openxmlformats.org/drawingml/2006/main" noGrp="1"/>
+          </p:cNvSpPr>
+          <p:nvPr/>
+        </p:nvSpPr>
+        <p:spPr>
+          <a:xfrm xmlns:a="http://schemas.openxmlformats.org/drawingml/2006/main">
+            <a:off x="733425" y="276225"/>
+            <a:ext cx="2047875" cy="285750"/>
+          </a:xfrm>
+          <a:prstGeom xmlns:a="http://schemas.openxmlformats.org/drawingml/2006/main" prst="rect">
+            <a:avLst/>
+          </a:prstGeom>
+          <a:noFill xmlns:a="http://schemas.openxmlformats.org/drawingml/2006/main"/>
+          <a:ln xmlns:a="http://schemas.openxmlformats.org/drawingml/2006/main" w="0">
+            <a:noFill/>
+          </a:ln>
+        </p:spPr>
+        <p:txBody>
+          <a:bodyPr xmlns:a="http://schemas.openxmlformats.org/drawingml/2006/main" lIns="0" tIns="0" rIns="0" bIns="0" anchor="ctr">
+            <a:noAutofit/>
+          </a:bodyPr>
+          <a:lstStyle xmlns:a="http://schemas.openxmlformats.org/drawingml/2006/main"/>
+          <a:p xmlns:a="http://schemas.openxmlformats.org/drawingml/2006/main">
+            <a:pPr algn="ctr">
+              <a:defRPr sz="1425" b="1">
+                <a:solidFill>
+                  <a:srgbClr val="F9F9F9"/>
+                </a:solidFill>
+                <a:latin typeface="Arial"/>
+                <a:ea typeface="Arial"/>
+                <a:cs typeface="Arial"/>
+              </a:defRPr>
+            </a:pPr>
+            <a:r>
+              <a:rPr sz="1425" b="1">
+                <a:solidFill>
+                  <a:srgbClr val="F9F9F9"/>
+                </a:solidFill>
+                <a:latin typeface="Arial"/>
+                <a:ea typeface="Arial"/>
+                <a:cs typeface="Arial"/>
+              </a:rPr>
+              <a:t>BÀI TOÁN</a:t>
+            </a:r>
+          </a:p>
+        </p:txBody>
+      </p:sp>
       <p:sp>
         <p:nvSpPr>
           <p:cNvPr id="3" name="">
             <a:extLst xmlns:a="http://schemas.openxmlformats.org/drawingml/2006/main">
               <a:ext uri="{FF2B5EF4-FFF2-40B4-BE49-F238E27FC236}">
-                <a16:creationId xmlns:a16="http://schemas.microsoft.com/office/drawing/2014/main" id="{70E8A37C-3EA7-401E-AED9-794AE2452DED}"/>
-              </a:ext>
-            </a:extLst>
-          </p:cNvPr>
-          <p:cNvSpPr>
-            <a:spLocks xmlns:a="http://schemas.openxmlformats.org/drawingml/2006/main" noGrp="1"/>
-          </p:cNvSpPr>
-          <p:nvPr/>
-        </p:nvSpPr>
-        <p:spPr>
-          <a:xfrm xmlns:a="http://schemas.openxmlformats.org/drawingml/2006/main">
-            <a:off x="752475" y="619125"/>
-            <a:ext cx="3810000" cy="523875"/>
+                <a16:creationId xmlns:a16="http://schemas.microsoft.com/office/drawing/2014/main" id="{A31EEF49-3C72-410B-8EEA-6A5C75D3E114}"/>
+              </a:ext>
+            </a:extLst>
+          </p:cNvPr>
+          <p:cNvSpPr>
+            <a:spLocks xmlns:a="http://schemas.openxmlformats.org/drawingml/2006/main" noGrp="1"/>
+          </p:cNvSpPr>
+          <p:nvPr/>
+        </p:nvSpPr>
+        <p:spPr>
+          <a:xfrm xmlns:a="http://schemas.openxmlformats.org/drawingml/2006/main">
+            <a:off x="3114675" y="171450"/>
+            <a:ext cx="2476500" cy="533400"/>
+          </a:xfrm>
+          <a:prstGeom xmlns:a="http://schemas.openxmlformats.org/drawingml/2006/main" prst="rightArrow">
+            <a:avLst/>
+          </a:prstGeom>
+          <a:solidFill xmlns:a="http://schemas.openxmlformats.org/drawingml/2006/main">
+            <a:srgbClr val="195F9A"/>
+          </a:solidFill>
+          <a:ln xmlns:a="http://schemas.openxmlformats.org/drawingml/2006/main" w="0">
+            <a:noFill/>
+          </a:ln>
+        </p:spPr>
+      </p:sp>
+      <p:sp>
+        <p:nvSpPr>
+          <p:cNvPr id="4" name="">
+            <a:extLst xmlns:a="http://schemas.openxmlformats.org/drawingml/2006/main">
+              <a:ext uri="{FF2B5EF4-FFF2-40B4-BE49-F238E27FC236}">
+                <a16:creationId xmlns:a16="http://schemas.microsoft.com/office/drawing/2014/main" id="{A2BDDA68-D76E-466A-BA94-C761C8C1B314}"/>
+              </a:ext>
+            </a:extLst>
+          </p:cNvPr>
+          <p:cNvSpPr>
+            <a:spLocks xmlns:a="http://schemas.openxmlformats.org/drawingml/2006/main" noGrp="1"/>
+          </p:cNvSpPr>
+          <p:nvPr/>
+        </p:nvSpPr>
+        <p:spPr>
+          <a:xfrm xmlns:a="http://schemas.openxmlformats.org/drawingml/2006/main">
+            <a:off x="3305175" y="276225"/>
+            <a:ext cx="2047875" cy="285750"/>
+          </a:xfrm>
+          <a:prstGeom xmlns:a="http://schemas.openxmlformats.org/drawingml/2006/main" prst="rect">
+            <a:avLst/>
+          </a:prstGeom>
+          <a:noFill xmlns:a="http://schemas.openxmlformats.org/drawingml/2006/main"/>
+          <a:ln xmlns:a="http://schemas.openxmlformats.org/drawingml/2006/main" w="0">
+            <a:noFill/>
+          </a:ln>
+        </p:spPr>
+        <p:txBody>
+          <a:bodyPr xmlns:a="http://schemas.openxmlformats.org/drawingml/2006/main" lIns="0" tIns="0" rIns="0" bIns="0" anchor="ctr">
+            <a:noAutofit/>
+          </a:bodyPr>
+          <a:lstStyle xmlns:a="http://schemas.openxmlformats.org/drawingml/2006/main"/>
+          <a:p xmlns:a="http://schemas.openxmlformats.org/drawingml/2006/main">
+            <a:pPr algn="ctr">
+              <a:defRPr sz="1425" b="1">
+                <a:solidFill>
+                  <a:srgbClr val="F9F9F9"/>
+                </a:solidFill>
+                <a:latin typeface="Arial"/>
+                <a:ea typeface="Arial"/>
+                <a:cs typeface="Arial"/>
+              </a:defRPr>
+            </a:pPr>
+            <a:r>
+              <a:rPr sz="1425" b="1">
+                <a:solidFill>
+                  <a:srgbClr val="F9F9F9"/>
+                </a:solidFill>
+                <a:latin typeface="Arial"/>
+                <a:ea typeface="Arial"/>
+                <a:cs typeface="Arial"/>
+              </a:rPr>
+              <a:t>DỮ LIỆU</a:t>
+            </a:r>
+          </a:p>
+        </p:txBody>
+      </p:sp>
+      <p:sp>
+        <p:nvSpPr>
+          <p:cNvPr id="5" name="">
+            <a:extLst xmlns:a="http://schemas.openxmlformats.org/drawingml/2006/main">
+              <a:ext uri="{FF2B5EF4-FFF2-40B4-BE49-F238E27FC236}">
+                <a16:creationId xmlns:a16="http://schemas.microsoft.com/office/drawing/2014/main" id="{953D37E0-77F5-44AF-9AD7-069E6A9EE996}"/>
+              </a:ext>
+            </a:extLst>
+          </p:cNvPr>
+          <p:cNvSpPr>
+            <a:spLocks xmlns:a="http://schemas.openxmlformats.org/drawingml/2006/main" noGrp="1"/>
+          </p:cNvSpPr>
+          <p:nvPr/>
+        </p:nvSpPr>
+        <p:spPr>
+          <a:xfrm xmlns:a="http://schemas.openxmlformats.org/drawingml/2006/main">
+            <a:off x="5686425" y="171450"/>
+            <a:ext cx="2476500" cy="533400"/>
+          </a:xfrm>
+          <a:prstGeom xmlns:a="http://schemas.openxmlformats.org/drawingml/2006/main" prst="rightArrow">
+            <a:avLst/>
+          </a:prstGeom>
+          <a:solidFill xmlns:a="http://schemas.openxmlformats.org/drawingml/2006/main">
+            <a:srgbClr val="195F9A"/>
+          </a:solidFill>
+          <a:ln xmlns:a="http://schemas.openxmlformats.org/drawingml/2006/main" w="0">
+            <a:noFill/>
+          </a:ln>
+        </p:spPr>
+      </p:sp>
+      <p:sp>
+        <p:nvSpPr>
+          <p:cNvPr id="6" name="">
+            <a:extLst xmlns:a="http://schemas.openxmlformats.org/drawingml/2006/main">
+              <a:ext uri="{FF2B5EF4-FFF2-40B4-BE49-F238E27FC236}">
+                <a16:creationId xmlns:a16="http://schemas.microsoft.com/office/drawing/2014/main" id="{81CCB29B-91E6-49B5-BFB4-705AFFDF66B6}"/>
+              </a:ext>
+            </a:extLst>
+          </p:cNvPr>
+          <p:cNvSpPr>
+            <a:spLocks xmlns:a="http://schemas.openxmlformats.org/drawingml/2006/main" noGrp="1"/>
+          </p:cNvSpPr>
+          <p:nvPr/>
+        </p:nvSpPr>
+        <p:spPr>
+          <a:xfrm xmlns:a="http://schemas.openxmlformats.org/drawingml/2006/main">
+            <a:off x="5876925" y="276225"/>
+            <a:ext cx="2047875" cy="285750"/>
+          </a:xfrm>
+          <a:prstGeom xmlns:a="http://schemas.openxmlformats.org/drawingml/2006/main" prst="rect">
+            <a:avLst/>
+          </a:prstGeom>
+          <a:noFill xmlns:a="http://schemas.openxmlformats.org/drawingml/2006/main"/>
+          <a:ln xmlns:a="http://schemas.openxmlformats.org/drawingml/2006/main" w="0">
+            <a:noFill/>
+          </a:ln>
+        </p:spPr>
+        <p:txBody>
+          <a:bodyPr xmlns:a="http://schemas.openxmlformats.org/drawingml/2006/main" lIns="0" tIns="0" rIns="0" bIns="0" anchor="ctr">
+            <a:noAutofit/>
+          </a:bodyPr>
+          <a:lstStyle xmlns:a="http://schemas.openxmlformats.org/drawingml/2006/main"/>
+          <a:p xmlns:a="http://schemas.openxmlformats.org/drawingml/2006/main">
+            <a:pPr algn="ctr">
+              <a:defRPr sz="1425" b="1">
+                <a:solidFill>
+                  <a:srgbClr val="F9F9F9"/>
+                </a:solidFill>
+                <a:latin typeface="Arial"/>
+                <a:ea typeface="Arial"/>
+                <a:cs typeface="Arial"/>
+              </a:defRPr>
+            </a:pPr>
+            <a:r>
+              <a:rPr sz="1425" b="1">
+                <a:solidFill>
+                  <a:srgbClr val="F9F9F9"/>
+                </a:solidFill>
+                <a:latin typeface="Arial"/>
+                <a:ea typeface="Arial"/>
+                <a:cs typeface="Arial"/>
+              </a:rPr>
+              <a:t>XỬ LÝ</a:t>
+            </a:r>
+          </a:p>
+        </p:txBody>
+      </p:sp>
+      <p:sp>
+        <p:nvSpPr>
+          <p:cNvPr id="7" name="">
+            <a:extLst xmlns:a="http://schemas.openxmlformats.org/drawingml/2006/main">
+              <a:ext uri="{FF2B5EF4-FFF2-40B4-BE49-F238E27FC236}">
+                <a16:creationId xmlns:a16="http://schemas.microsoft.com/office/drawing/2014/main" id="{F9E67CFF-4C75-4E99-B292-888C1B8FFB83}"/>
+              </a:ext>
+            </a:extLst>
+          </p:cNvPr>
+          <p:cNvSpPr>
+            <a:spLocks xmlns:a="http://schemas.openxmlformats.org/drawingml/2006/main" noGrp="1"/>
+          </p:cNvSpPr>
+          <p:nvPr/>
+        </p:nvSpPr>
+        <p:spPr>
+          <a:xfrm xmlns:a="http://schemas.openxmlformats.org/drawingml/2006/main">
+            <a:off x="8258175" y="171450"/>
+            <a:ext cx="2476500" cy="533400"/>
+          </a:xfrm>
+          <a:prstGeom xmlns:a="http://schemas.openxmlformats.org/drawingml/2006/main" prst="rightArrow">
+            <a:avLst/>
+          </a:prstGeom>
+          <a:solidFill xmlns:a="http://schemas.openxmlformats.org/drawingml/2006/main">
+            <a:srgbClr val="195F9A"/>
+          </a:solidFill>
+          <a:ln xmlns:a="http://schemas.openxmlformats.org/drawingml/2006/main" w="0">
+            <a:noFill/>
+          </a:ln>
+        </p:spPr>
+      </p:sp>
+      <p:sp>
+        <p:nvSpPr>
+          <p:cNvPr id="8" name="">
+            <a:extLst xmlns:a="http://schemas.openxmlformats.org/drawingml/2006/main">
+              <a:ext uri="{FF2B5EF4-FFF2-40B4-BE49-F238E27FC236}">
+                <a16:creationId xmlns:a16="http://schemas.microsoft.com/office/drawing/2014/main" id="{5F90BAE4-A226-4190-91A1-1F40AAB5A3E9}"/>
+              </a:ext>
+            </a:extLst>
+          </p:cNvPr>
+          <p:cNvSpPr>
+            <a:spLocks xmlns:a="http://schemas.openxmlformats.org/drawingml/2006/main" noGrp="1"/>
+          </p:cNvSpPr>
+          <p:nvPr/>
+        </p:nvSpPr>
+        <p:spPr>
+          <a:xfrm xmlns:a="http://schemas.openxmlformats.org/drawingml/2006/main">
+            <a:off x="8448675" y="276225"/>
+            <a:ext cx="2047875" cy="285750"/>
+          </a:xfrm>
+          <a:prstGeom xmlns:a="http://schemas.openxmlformats.org/drawingml/2006/main" prst="rect">
+            <a:avLst/>
+          </a:prstGeom>
+          <a:noFill xmlns:a="http://schemas.openxmlformats.org/drawingml/2006/main"/>
+          <a:ln xmlns:a="http://schemas.openxmlformats.org/drawingml/2006/main" w="0">
+            <a:noFill/>
+          </a:ln>
+        </p:spPr>
+        <p:txBody>
+          <a:bodyPr xmlns:a="http://schemas.openxmlformats.org/drawingml/2006/main" lIns="0" tIns="0" rIns="0" bIns="0" anchor="ctr">
+            <a:noAutofit/>
+          </a:bodyPr>
+          <a:lstStyle xmlns:a="http://schemas.openxmlformats.org/drawingml/2006/main"/>
+          <a:p xmlns:a="http://schemas.openxmlformats.org/drawingml/2006/main">
+            <a:pPr algn="ctr">
+              <a:defRPr sz="1425" b="1">
+                <a:solidFill>
+                  <a:srgbClr val="F9F9F9"/>
+                </a:solidFill>
+                <a:latin typeface="Arial"/>
+                <a:ea typeface="Arial"/>
+                <a:cs typeface="Arial"/>
+              </a:defRPr>
+            </a:pPr>
+            <a:r>
+              <a:rPr sz="1425" b="1">
+                <a:solidFill>
+                  <a:srgbClr val="F9F9F9"/>
+                </a:solidFill>
+                <a:latin typeface="Arial"/>
+                <a:ea typeface="Arial"/>
+                <a:cs typeface="Arial"/>
+              </a:rPr>
+              <a:t>MÔ HÌNH</a:t>
+            </a:r>
+          </a:p>
+        </p:txBody>
+      </p:sp>
+      <p:sp>
+        <p:nvSpPr>
+          <p:cNvPr id="9" name="">
+            <a:extLst xmlns:a="http://schemas.openxmlformats.org/drawingml/2006/main">
+              <a:ext uri="{FF2B5EF4-FFF2-40B4-BE49-F238E27FC236}">
+                <a16:creationId xmlns:a16="http://schemas.microsoft.com/office/drawing/2014/main" id="{6D55B95B-BB7F-42B2-90AB-3CAB9536BF2D}"/>
+              </a:ext>
+            </a:extLst>
+          </p:cNvPr>
+          <p:cNvSpPr>
+            <a:spLocks xmlns:a="http://schemas.openxmlformats.org/drawingml/2006/main" noGrp="1"/>
+          </p:cNvSpPr>
+          <p:nvPr/>
+        </p:nvSpPr>
+        <p:spPr>
+          <a:xfrm xmlns:a="http://schemas.openxmlformats.org/drawingml/2006/main">
+            <a:off x="10829925" y="171450"/>
+            <a:ext cx="2476500" cy="533400"/>
+          </a:xfrm>
+          <a:prstGeom xmlns:a="http://schemas.openxmlformats.org/drawingml/2006/main" prst="rightArrow">
+            <a:avLst/>
+          </a:prstGeom>
+          <a:solidFill xmlns:a="http://schemas.openxmlformats.org/drawingml/2006/main">
+            <a:srgbClr val="195F9A"/>
+          </a:solidFill>
+          <a:ln xmlns:a="http://schemas.openxmlformats.org/drawingml/2006/main" w="0">
+            <a:noFill/>
+          </a:ln>
+        </p:spPr>
+      </p:sp>
+      <p:sp>
+        <p:nvSpPr>
+          <p:cNvPr id="10" name="">
+            <a:extLst xmlns:a="http://schemas.openxmlformats.org/drawingml/2006/main">
+              <a:ext uri="{FF2B5EF4-FFF2-40B4-BE49-F238E27FC236}">
+                <a16:creationId xmlns:a16="http://schemas.microsoft.com/office/drawing/2014/main" id="{877ABE15-9667-46CF-83FB-B0AAFAD334DD}"/>
+              </a:ext>
+            </a:extLst>
+          </p:cNvPr>
+          <p:cNvSpPr>
+            <a:spLocks xmlns:a="http://schemas.openxmlformats.org/drawingml/2006/main" noGrp="1"/>
+          </p:cNvSpPr>
+          <p:nvPr/>
+        </p:nvSpPr>
+        <p:spPr>
+          <a:xfrm xmlns:a="http://schemas.openxmlformats.org/drawingml/2006/main">
+            <a:off x="11020425" y="276225"/>
+            <a:ext cx="2047875" cy="285750"/>
+          </a:xfrm>
+          <a:prstGeom xmlns:a="http://schemas.openxmlformats.org/drawingml/2006/main" prst="rect">
+            <a:avLst/>
+          </a:prstGeom>
+          <a:noFill xmlns:a="http://schemas.openxmlformats.org/drawingml/2006/main"/>
+          <a:ln xmlns:a="http://schemas.openxmlformats.org/drawingml/2006/main" w="0">
+            <a:noFill/>
+          </a:ln>
+        </p:spPr>
+        <p:txBody>
+          <a:bodyPr xmlns:a="http://schemas.openxmlformats.org/drawingml/2006/main" lIns="0" tIns="0" rIns="0" bIns="0" anchor="ctr">
+            <a:noAutofit/>
+          </a:bodyPr>
+          <a:lstStyle xmlns:a="http://schemas.openxmlformats.org/drawingml/2006/main"/>
+          <a:p xmlns:a="http://schemas.openxmlformats.org/drawingml/2006/main">
+            <a:pPr algn="ctr">
+              <a:defRPr sz="1425" b="1">
+                <a:solidFill>
+                  <a:srgbClr val="F9F9F9"/>
+                </a:solidFill>
+                <a:latin typeface="Arial"/>
+                <a:ea typeface="Arial"/>
+                <a:cs typeface="Arial"/>
+              </a:defRPr>
+            </a:pPr>
+            <a:r>
+              <a:rPr sz="1425" b="1">
+                <a:solidFill>
+                  <a:srgbClr val="F9F9F9"/>
+                </a:solidFill>
+                <a:latin typeface="Arial"/>
+                <a:ea typeface="Arial"/>
+                <a:cs typeface="Arial"/>
+              </a:rPr>
+              <a:t>KẾT QUẢ</a:t>
+            </a:r>
+          </a:p>
+        </p:txBody>
+      </p:sp>
+      <p:sp>
+        <p:nvSpPr>
+          <p:cNvPr id="11" name="">
+            <a:extLst xmlns:a="http://schemas.openxmlformats.org/drawingml/2006/main">
+              <a:ext uri="{FF2B5EF4-FFF2-40B4-BE49-F238E27FC236}">
+                <a16:creationId xmlns:a16="http://schemas.microsoft.com/office/drawing/2014/main" id="{42B41630-ED48-463B-9178-34B4972A4B65}"/>
+              </a:ext>
+            </a:extLst>
+          </p:cNvPr>
+          <p:cNvSpPr>
+            <a:spLocks xmlns:a="http://schemas.openxmlformats.org/drawingml/2006/main" noGrp="1"/>
+          </p:cNvSpPr>
+          <p:nvPr/>
+        </p:nvSpPr>
+        <p:spPr>
+          <a:xfrm xmlns:a="http://schemas.openxmlformats.org/drawingml/2006/main">
+            <a:off x="619125" y="1066800"/>
+            <a:ext cx="12287250" cy="571500"/>
           </a:xfrm>
           <a:prstGeom xmlns:a="http://schemas.openxmlformats.org/drawingml/2006/main" prst="rect">
             <a:avLst/>
@@ -5737,47 +6196,47 @@
           <a:lstStyle xmlns:a="http://schemas.openxmlformats.org/drawingml/2006/main"/>
           <a:p xmlns:a="http://schemas.openxmlformats.org/drawingml/2006/main">
             <a:pPr algn="l">
-              <a:defRPr sz="2475" b="1">
-                <a:solidFill>
-                  <a:srgbClr val="AC8CC0"/>
-                </a:solidFill>
-                <a:latin typeface="Arial"/>
-                <a:ea typeface="Arial"/>
-                <a:cs typeface="Arial"/>
-              </a:defRPr>
-            </a:pPr>
-            <a:r>
-              <a:rPr sz="2475" b="1">
-                <a:solidFill>
-                  <a:srgbClr val="AC8CC0"/>
-                </a:solidFill>
-                <a:latin typeface="Arial"/>
-                <a:ea typeface="Arial"/>
-                <a:cs typeface="Arial"/>
-              </a:rPr>
-              <a:t>ĐỀ TÀI</a:t>
-            </a:r>
-          </a:p>
-        </p:txBody>
-      </p:sp>
-      <p:sp>
-        <p:nvSpPr>
-          <p:cNvPr id="4" name="">
-            <a:extLst xmlns:a="http://schemas.openxmlformats.org/drawingml/2006/main">
-              <a:ext uri="{FF2B5EF4-FFF2-40B4-BE49-F238E27FC236}">
-                <a16:creationId xmlns:a16="http://schemas.microsoft.com/office/drawing/2014/main" id="{5395842A-4C91-456A-848B-14C15225FE86}"/>
-              </a:ext>
-            </a:extLst>
-          </p:cNvPr>
-          <p:cNvSpPr>
-            <a:spLocks xmlns:a="http://schemas.openxmlformats.org/drawingml/2006/main" noGrp="1"/>
-          </p:cNvSpPr>
-          <p:nvPr/>
-        </p:nvSpPr>
-        <p:spPr>
-          <a:xfrm xmlns:a="http://schemas.openxmlformats.org/drawingml/2006/main">
-            <a:off x="771525" y="1495425"/>
-            <a:ext cx="10477500" cy="3924300"/>
+              <a:defRPr sz="3300" b="1">
+                <a:solidFill>
+                  <a:srgbClr val="F9F9F9"/>
+                </a:solidFill>
+                <a:latin typeface="Arial"/>
+                <a:ea typeface="Arial"/>
+                <a:cs typeface="Arial"/>
+              </a:defRPr>
+            </a:pPr>
+            <a:r>
+              <a:rPr sz="3300" b="1">
+                <a:solidFill>
+                  <a:srgbClr val="F9F9F9"/>
+                </a:solidFill>
+                <a:latin typeface="Arial"/>
+                <a:ea typeface="Arial"/>
+                <a:cs typeface="Arial"/>
+              </a:rPr>
+              <a:t>HỆ THỐNG CẦN LÀM GÌ?</a:t>
+            </a:r>
+          </a:p>
+        </p:txBody>
+      </p:sp>
+      <p:sp>
+        <p:nvSpPr>
+          <p:cNvPr id="12" name="">
+            <a:extLst xmlns:a="http://schemas.openxmlformats.org/drawingml/2006/main">
+              <a:ext uri="{FF2B5EF4-FFF2-40B4-BE49-F238E27FC236}">
+                <a16:creationId xmlns:a16="http://schemas.microsoft.com/office/drawing/2014/main" id="{7C1DE063-FFCD-46F8-86A3-32823EBB1C37}"/>
+              </a:ext>
+            </a:extLst>
+          </p:cNvPr>
+          <p:cNvSpPr>
+            <a:spLocks xmlns:a="http://schemas.openxmlformats.org/drawingml/2006/main" noGrp="1"/>
+          </p:cNvSpPr>
+          <p:nvPr/>
+        </p:nvSpPr>
+        <p:spPr>
+          <a:xfrm xmlns:a="http://schemas.openxmlformats.org/drawingml/2006/main">
+            <a:off x="638175" y="1685925"/>
+            <a:ext cx="12192000" cy="361950"/>
           </a:xfrm>
           <a:prstGeom xmlns:a="http://schemas.openxmlformats.org/drawingml/2006/main" prst="rect">
             <a:avLst/>
@@ -5794,163 +6253,7 @@
           <a:lstStyle xmlns:a="http://schemas.openxmlformats.org/drawingml/2006/main"/>
           <a:p xmlns:a="http://schemas.openxmlformats.org/drawingml/2006/main">
             <a:pPr algn="l">
-              <a:defRPr sz="4275" b="1">
-                <a:solidFill>
-                  <a:srgbClr val="F9F9F9"/>
-                </a:solidFill>
-                <a:latin typeface="Arial"/>
-                <a:ea typeface="Arial"/>
-                <a:cs typeface="Arial"/>
-              </a:defRPr>
-            </a:pPr>
-            <a:r>
-              <a:rPr sz="4275" b="1">
-                <a:solidFill>
-                  <a:srgbClr val="F9F9F9"/>
-                </a:solidFill>
-                <a:latin typeface="Arial"/>
-                <a:ea typeface="Arial"/>
-                <a:cs typeface="Arial"/>
-              </a:rPr>
-              <a:t>HỆ THỐNG KHUYẾN NGHỊ</a:t>
-            </a:r>
-          </a:p>
-          <a:p xmlns:a="http://schemas.openxmlformats.org/drawingml/2006/main">
-            <a:pPr algn="l">
-              <a:defRPr sz="4275" b="1">
-                <a:solidFill>
-                  <a:srgbClr val="F9F9F9"/>
-                </a:solidFill>
-                <a:latin typeface="Arial"/>
-                <a:ea typeface="Arial"/>
-                <a:cs typeface="Arial"/>
-              </a:defRPr>
-            </a:pPr>
-            <a:r>
-              <a:rPr sz="4275" b="1">
-                <a:solidFill>
-                  <a:srgbClr val="F9F9F9"/>
-                </a:solidFill>
-                <a:latin typeface="Arial"/>
-                <a:ea typeface="Arial"/>
-                <a:cs typeface="Arial"/>
-              </a:rPr>
-              <a:t>CHO SỰ HÀI LÒNG CỦA</a:t>
-            </a:r>
-          </a:p>
-          <a:p xmlns:a="http://schemas.openxmlformats.org/drawingml/2006/main">
-            <a:pPr algn="l">
-              <a:defRPr sz="4275" b="1">
-                <a:solidFill>
-                  <a:srgbClr val="F9F9F9"/>
-                </a:solidFill>
-                <a:latin typeface="Arial"/>
-                <a:ea typeface="Arial"/>
-                <a:cs typeface="Arial"/>
-              </a:defRPr>
-            </a:pPr>
-            <a:r>
-              <a:rPr sz="4275" b="1">
-                <a:solidFill>
-                  <a:srgbClr val="F9F9F9"/>
-                </a:solidFill>
-                <a:latin typeface="Arial"/>
-                <a:ea typeface="Arial"/>
-                <a:cs typeface="Arial"/>
-              </a:rPr>
-              <a:t>THÀNH VIÊN DÀI HẠN</a:t>
-            </a:r>
-          </a:p>
-          <a:p xmlns:a="http://schemas.openxmlformats.org/drawingml/2006/main">
-            <a:pPr algn="l">
-              <a:defRPr sz="4275" b="1">
-                <a:solidFill>
-                  <a:srgbClr val="F9F9F9"/>
-                </a:solidFill>
-                <a:latin typeface="Arial"/>
-                <a:ea typeface="Arial"/>
-                <a:cs typeface="Arial"/>
-              </a:defRPr>
-            </a:pPr>
-            <a:r>
-              <a:rPr sz="4275" b="1">
-                <a:solidFill>
-                  <a:srgbClr val="F9F9F9"/>
-                </a:solidFill>
-                <a:latin typeface="Arial"/>
-                <a:ea typeface="Arial"/>
-                <a:cs typeface="Arial"/>
-              </a:rPr>
-              <a:t>TẠI NETFLIX</a:t>
-            </a:r>
-          </a:p>
-        </p:txBody>
-      </p:sp>
-      <p:sp>
-        <p:nvSpPr>
-          <p:cNvPr id="5" name="">
-            <a:extLst xmlns:a="http://schemas.openxmlformats.org/drawingml/2006/main">
-              <a:ext uri="{FF2B5EF4-FFF2-40B4-BE49-F238E27FC236}">
-                <a16:creationId xmlns:a16="http://schemas.microsoft.com/office/drawing/2014/main" id="{4B25D7DC-3E56-4F8E-B481-148D646DC940}"/>
-              </a:ext>
-            </a:extLst>
-          </p:cNvPr>
-          <p:cNvSpPr>
-            <a:spLocks xmlns:a="http://schemas.openxmlformats.org/drawingml/2006/main" noGrp="1"/>
-          </p:cNvSpPr>
-          <p:nvPr/>
-        </p:nvSpPr>
-        <p:spPr>
-          <a:xfrm xmlns:a="http://schemas.openxmlformats.org/drawingml/2006/main">
-            <a:off x="771525" y="5857875"/>
-            <a:ext cx="11801475" cy="0"/>
-          </a:xfrm>
-          <a:prstGeom xmlns:a="http://schemas.openxmlformats.org/drawingml/2006/main" prst="line">
-            <a:avLst/>
-          </a:prstGeom>
-          <a:noFill xmlns:a="http://schemas.openxmlformats.org/drawingml/2006/main"/>
-          <a:ln xmlns:a="http://schemas.openxmlformats.org/drawingml/2006/main" w="38100">
-            <a:solidFill>
-              <a:srgbClr val="AC8CC0"/>
-            </a:solidFill>
-          </a:ln>
-        </p:spPr>
-      </p:sp>
-      <p:sp>
-        <p:nvSpPr>
-          <p:cNvPr id="6" name="">
-            <a:extLst xmlns:a="http://schemas.openxmlformats.org/drawingml/2006/main">
-              <a:ext uri="{FF2B5EF4-FFF2-40B4-BE49-F238E27FC236}">
-                <a16:creationId xmlns:a16="http://schemas.microsoft.com/office/drawing/2014/main" id="{4080D9B3-FFD2-4630-9245-A9922A938A21}"/>
-              </a:ext>
-            </a:extLst>
-          </p:cNvPr>
-          <p:cNvSpPr>
-            <a:spLocks xmlns:a="http://schemas.openxmlformats.org/drawingml/2006/main" noGrp="1"/>
-          </p:cNvSpPr>
-          <p:nvPr/>
-        </p:nvSpPr>
-        <p:spPr>
-          <a:xfrm xmlns:a="http://schemas.openxmlformats.org/drawingml/2006/main">
-            <a:off x="771525" y="6181725"/>
-            <a:ext cx="11334750" cy="504825"/>
-          </a:xfrm>
-          <a:prstGeom xmlns:a="http://schemas.openxmlformats.org/drawingml/2006/main" prst="rect">
-            <a:avLst/>
-          </a:prstGeom>
-          <a:noFill xmlns:a="http://schemas.openxmlformats.org/drawingml/2006/main"/>
-          <a:ln xmlns:a="http://schemas.openxmlformats.org/drawingml/2006/main" w="0">
-            <a:noFill/>
-          </a:ln>
-        </p:spPr>
-        <p:txBody>
-          <a:bodyPr xmlns:a="http://schemas.openxmlformats.org/drawingml/2006/main" lIns="0" tIns="0" rIns="0" bIns="0" anchor="ctr">
-            <a:noAutofit/>
-          </a:bodyPr>
-          <a:lstStyle xmlns:a="http://schemas.openxmlformats.org/drawingml/2006/main"/>
-          <a:p xmlns:a="http://schemas.openxmlformats.org/drawingml/2006/main">
-            <a:pPr algn="l">
-              <a:defRPr sz="2100" b="0">
+              <a:defRPr sz="1800" b="0">
                 <a:solidFill>
                   <a:srgbClr val="C9C9CE"/>
                 </a:solidFill>
@@ -5960,7 +6263,7 @@
               </a:defRPr>
             </a:pPr>
             <a:r>
-              <a:rPr sz="2100" b="0">
+              <a:rPr sz="1800" b="0">
                 <a:solidFill>
                   <a:srgbClr val="C9C9CE"/>
                 </a:solidFill>
@@ -5968,29 +6271,29 @@
                 <a:ea typeface="Arial"/>
                 <a:cs typeface="Arial"/>
               </a:rPr>
-              <a:t>MovieLens 25M là dữ liệu thử nghiệm cho bài toán gợi ý phim.</a:t>
-            </a:r>
-          </a:p>
-        </p:txBody>
-      </p:sp>
-      <p:sp>
-        <p:nvSpPr>
-          <p:cNvPr id="7" name="">
-            <a:extLst xmlns:a="http://schemas.openxmlformats.org/drawingml/2006/main">
-              <a:ext uri="{FF2B5EF4-FFF2-40B4-BE49-F238E27FC236}">
-                <a16:creationId xmlns:a16="http://schemas.microsoft.com/office/drawing/2014/main" id="{823930C6-ED87-4BF6-9E83-5CF057810BF1}"/>
-              </a:ext>
-            </a:extLst>
-          </p:cNvPr>
-          <p:cNvSpPr>
-            <a:spLocks xmlns:a="http://schemas.openxmlformats.org/drawingml/2006/main" noGrp="1"/>
-          </p:cNvSpPr>
-          <p:nvPr/>
-        </p:nvSpPr>
-        <p:spPr>
-          <a:xfrm xmlns:a="http://schemas.openxmlformats.org/drawingml/2006/main">
-            <a:off x="12792075" y="7267575"/>
-            <a:ext cx="428625" cy="238125"/>
+              <a:t>Từ lịch sử chấm điểm đến danh sách gợi ý có thể kiểm tra.</a:t>
+            </a:r>
+          </a:p>
+        </p:txBody>
+      </p:sp>
+      <p:sp>
+        <p:nvSpPr>
+          <p:cNvPr id="13" name="">
+            <a:extLst xmlns:a="http://schemas.openxmlformats.org/drawingml/2006/main">
+              <a:ext uri="{FF2B5EF4-FFF2-40B4-BE49-F238E27FC236}">
+                <a16:creationId xmlns:a16="http://schemas.microsoft.com/office/drawing/2014/main" id="{A3B3DDFC-FD36-407A-B05B-C23825D30E0C}"/>
+              </a:ext>
+            </a:extLst>
+          </p:cNvPr>
+          <p:cNvSpPr>
+            <a:spLocks xmlns:a="http://schemas.openxmlformats.org/drawingml/2006/main" noGrp="1"/>
+          </p:cNvSpPr>
+          <p:nvPr/>
+        </p:nvSpPr>
+        <p:spPr>
+          <a:xfrm xmlns:a="http://schemas.openxmlformats.org/drawingml/2006/main">
+            <a:off x="12782550" y="7258050"/>
+            <a:ext cx="428625" cy="257175"/>
           </a:xfrm>
           <a:prstGeom xmlns:a="http://schemas.openxmlformats.org/drawingml/2006/main" prst="rect">
             <a:avLst/>
@@ -6026,6 +6329,621 @@
                 <a:cs typeface="Arial"/>
               </a:rPr>
               <a:t>02</a:t>
+            </a:r>
+          </a:p>
+        </p:txBody>
+      </p:sp>
+      <p:sp>
+        <p:nvSpPr>
+          <p:cNvPr id="14" name="">
+            <a:extLst xmlns:a="http://schemas.openxmlformats.org/drawingml/2006/main">
+              <a:ext uri="{FF2B5EF4-FFF2-40B4-BE49-F238E27FC236}">
+                <a16:creationId xmlns:a16="http://schemas.microsoft.com/office/drawing/2014/main" id="{C556BEB6-8384-49D4-9527-41308BF583D5}"/>
+              </a:ext>
+            </a:extLst>
+          </p:cNvPr>
+          <p:cNvSpPr>
+            <a:spLocks xmlns:a="http://schemas.openxmlformats.org/drawingml/2006/main" noGrp="1"/>
+          </p:cNvSpPr>
+          <p:nvPr/>
+        </p:nvSpPr>
+        <p:spPr>
+          <a:xfrm xmlns:a="http://schemas.openxmlformats.org/drawingml/2006/main">
+            <a:off x="638175" y="2609850"/>
+            <a:ext cx="3924300" cy="2562225"/>
+          </a:xfrm>
+          <a:prstGeom xmlns:a="http://schemas.openxmlformats.org/drawingml/2006/main" prst="roundRect">
+            <a:avLst>
+              <a:gd name="adj" fmla="val 2974"/>
+            </a:avLst>
+          </a:prstGeom>
+          <a:solidFill xmlns:a="http://schemas.openxmlformats.org/drawingml/2006/main">
+            <a:srgbClr val="F5F5F6"/>
+          </a:solidFill>
+          <a:ln xmlns:a="http://schemas.openxmlformats.org/drawingml/2006/main" w="0">
+            <a:noFill/>
+          </a:ln>
+        </p:spPr>
+      </p:sp>
+      <p:sp>
+        <p:nvSpPr>
+          <p:cNvPr id="15" name="">
+            <a:extLst xmlns:a="http://schemas.openxmlformats.org/drawingml/2006/main">
+              <a:ext uri="{FF2B5EF4-FFF2-40B4-BE49-F238E27FC236}">
+                <a16:creationId xmlns:a16="http://schemas.microsoft.com/office/drawing/2014/main" id="{02F64EDC-1385-4AB3-BD39-8CE8F5145783}"/>
+              </a:ext>
+            </a:extLst>
+          </p:cNvPr>
+          <p:cNvSpPr>
+            <a:spLocks xmlns:a="http://schemas.openxmlformats.org/drawingml/2006/main" noGrp="1"/>
+          </p:cNvSpPr>
+          <p:nvPr/>
+        </p:nvSpPr>
+        <p:spPr>
+          <a:xfrm xmlns:a="http://schemas.openxmlformats.org/drawingml/2006/main">
+            <a:off x="638175" y="2609850"/>
+            <a:ext cx="3924300" cy="85725"/>
+          </a:xfrm>
+          <a:prstGeom xmlns:a="http://schemas.openxmlformats.org/drawingml/2006/main" prst="rect">
+            <a:avLst/>
+          </a:prstGeom>
+          <a:solidFill xmlns:a="http://schemas.openxmlformats.org/drawingml/2006/main">
+            <a:srgbClr val="195F9A"/>
+          </a:solidFill>
+          <a:ln xmlns:a="http://schemas.openxmlformats.org/drawingml/2006/main" w="0">
+            <a:noFill/>
+          </a:ln>
+        </p:spPr>
+      </p:sp>
+      <p:sp>
+        <p:nvSpPr>
+          <p:cNvPr id="16" name="">
+            <a:extLst xmlns:a="http://schemas.openxmlformats.org/drawingml/2006/main">
+              <a:ext uri="{FF2B5EF4-FFF2-40B4-BE49-F238E27FC236}">
+                <a16:creationId xmlns:a16="http://schemas.microsoft.com/office/drawing/2014/main" id="{BC516DD9-445B-4EF7-ACFE-6BD3D2E4D397}"/>
+              </a:ext>
+            </a:extLst>
+          </p:cNvPr>
+          <p:cNvSpPr>
+            <a:spLocks xmlns:a="http://schemas.openxmlformats.org/drawingml/2006/main" noGrp="1"/>
+          </p:cNvSpPr>
+          <p:nvPr/>
+        </p:nvSpPr>
+        <p:spPr>
+          <a:xfrm xmlns:a="http://schemas.openxmlformats.org/drawingml/2006/main">
+            <a:off x="876300" y="2838450"/>
+            <a:ext cx="3448050" cy="590550"/>
+          </a:xfrm>
+          <a:prstGeom xmlns:a="http://schemas.openxmlformats.org/drawingml/2006/main" prst="rect">
+            <a:avLst/>
+          </a:prstGeom>
+          <a:noFill xmlns:a="http://schemas.openxmlformats.org/drawingml/2006/main"/>
+          <a:ln xmlns:a="http://schemas.openxmlformats.org/drawingml/2006/main" w="0">
+            <a:noFill/>
+          </a:ln>
+        </p:spPr>
+        <p:txBody>
+          <a:bodyPr xmlns:a="http://schemas.openxmlformats.org/drawingml/2006/main" lIns="0" tIns="0" rIns="0" bIns="0" anchor="ctr">
+            <a:noAutofit/>
+          </a:bodyPr>
+          <a:lstStyle xmlns:a="http://schemas.openxmlformats.org/drawingml/2006/main"/>
+          <a:p xmlns:a="http://schemas.openxmlformats.org/drawingml/2006/main">
+            <a:pPr algn="l">
+              <a:defRPr sz="2325" b="1">
+                <a:solidFill>
+                  <a:srgbClr val="16233F"/>
+                </a:solidFill>
+                <a:latin typeface="Arial"/>
+                <a:ea typeface="Arial"/>
+                <a:cs typeface="Arial"/>
+              </a:defRPr>
+            </a:pPr>
+            <a:r>
+              <a:rPr sz="2325" b="1">
+                <a:solidFill>
+                  <a:srgbClr val="16233F"/>
+                </a:solidFill>
+                <a:latin typeface="Arial"/>
+                <a:ea typeface="Arial"/>
+                <a:cs typeface="Arial"/>
+              </a:rPr>
+              <a:t>1 · CHỌN PHIM</a:t>
+            </a:r>
+          </a:p>
+        </p:txBody>
+      </p:sp>
+      <p:sp>
+        <p:nvSpPr>
+          <p:cNvPr id="17" name="">
+            <a:extLst xmlns:a="http://schemas.openxmlformats.org/drawingml/2006/main">
+              <a:ext uri="{FF2B5EF4-FFF2-40B4-BE49-F238E27FC236}">
+                <a16:creationId xmlns:a16="http://schemas.microsoft.com/office/drawing/2014/main" id="{982437D2-A4C5-463A-A0AA-68FA36B6F35D}"/>
+              </a:ext>
+            </a:extLst>
+          </p:cNvPr>
+          <p:cNvSpPr>
+            <a:spLocks xmlns:a="http://schemas.openxmlformats.org/drawingml/2006/main" noGrp="1"/>
+          </p:cNvSpPr>
+          <p:nvPr/>
+        </p:nvSpPr>
+        <p:spPr>
+          <a:xfrm xmlns:a="http://schemas.openxmlformats.org/drawingml/2006/main">
+            <a:off x="876300" y="3590925"/>
+            <a:ext cx="3448050" cy="1276350"/>
+          </a:xfrm>
+          <a:prstGeom xmlns:a="http://schemas.openxmlformats.org/drawingml/2006/main" prst="rect">
+            <a:avLst/>
+          </a:prstGeom>
+          <a:noFill xmlns:a="http://schemas.openxmlformats.org/drawingml/2006/main"/>
+          <a:ln xmlns:a="http://schemas.openxmlformats.org/drawingml/2006/main" w="0">
+            <a:noFill/>
+          </a:ln>
+        </p:spPr>
+        <p:txBody>
+          <a:bodyPr xmlns:a="http://schemas.openxmlformats.org/drawingml/2006/main" lIns="0" tIns="0" rIns="0" bIns="0" anchor="ctr">
+            <a:noAutofit/>
+          </a:bodyPr>
+          <a:lstStyle xmlns:a="http://schemas.openxmlformats.org/drawingml/2006/main"/>
+          <a:p xmlns:a="http://schemas.openxmlformats.org/drawingml/2006/main">
+            <a:pPr algn="l">
+              <a:defRPr sz="1875" b="0">
+                <a:solidFill>
+                  <a:srgbClr val="16233F"/>
+                </a:solidFill>
+                <a:latin typeface="Arial"/>
+                <a:ea typeface="Arial"/>
+                <a:cs typeface="Arial"/>
+              </a:defRPr>
+            </a:pPr>
+            <a:r>
+              <a:rPr sz="1875" b="0">
+                <a:solidFill>
+                  <a:srgbClr val="16233F"/>
+                </a:solidFill>
+                <a:latin typeface="Arial"/>
+                <a:ea typeface="Arial"/>
+                <a:cs typeface="Arial"/>
+              </a:rPr>
+              <a:t>Tạo ứng viên chưa được người dùng chấm</a:t>
+            </a:r>
+          </a:p>
+        </p:txBody>
+      </p:sp>
+      <p:sp>
+        <p:nvSpPr>
+          <p:cNvPr id="18" name="">
+            <a:extLst xmlns:a="http://schemas.openxmlformats.org/drawingml/2006/main">
+              <a:ext uri="{FF2B5EF4-FFF2-40B4-BE49-F238E27FC236}">
+                <a16:creationId xmlns:a16="http://schemas.microsoft.com/office/drawing/2014/main" id="{15B62B7E-69DD-43EE-92D0-2BB77BD3F5B0}"/>
+              </a:ext>
+            </a:extLst>
+          </p:cNvPr>
+          <p:cNvSpPr>
+            <a:spLocks xmlns:a="http://schemas.openxmlformats.org/drawingml/2006/main" noGrp="1"/>
+          </p:cNvSpPr>
+          <p:nvPr/>
+        </p:nvSpPr>
+        <p:spPr>
+          <a:xfrm xmlns:a="http://schemas.openxmlformats.org/drawingml/2006/main">
+            <a:off x="4886325" y="2609850"/>
+            <a:ext cx="3924300" cy="2562225"/>
+          </a:xfrm>
+          <a:prstGeom xmlns:a="http://schemas.openxmlformats.org/drawingml/2006/main" prst="roundRect">
+            <a:avLst>
+              <a:gd name="adj" fmla="val 2974"/>
+            </a:avLst>
+          </a:prstGeom>
+          <a:solidFill xmlns:a="http://schemas.openxmlformats.org/drawingml/2006/main">
+            <a:srgbClr val="F5F5F6"/>
+          </a:solidFill>
+          <a:ln xmlns:a="http://schemas.openxmlformats.org/drawingml/2006/main" w="0">
+            <a:noFill/>
+          </a:ln>
+        </p:spPr>
+      </p:sp>
+      <p:sp>
+        <p:nvSpPr>
+          <p:cNvPr id="19" name="">
+            <a:extLst xmlns:a="http://schemas.openxmlformats.org/drawingml/2006/main">
+              <a:ext uri="{FF2B5EF4-FFF2-40B4-BE49-F238E27FC236}">
+                <a16:creationId xmlns:a16="http://schemas.microsoft.com/office/drawing/2014/main" id="{198DBCD8-0280-43A6-A546-54DEFA6B3832}"/>
+              </a:ext>
+            </a:extLst>
+          </p:cNvPr>
+          <p:cNvSpPr>
+            <a:spLocks xmlns:a="http://schemas.openxmlformats.org/drawingml/2006/main" noGrp="1"/>
+          </p:cNvSpPr>
+          <p:nvPr/>
+        </p:nvSpPr>
+        <p:spPr>
+          <a:xfrm xmlns:a="http://schemas.openxmlformats.org/drawingml/2006/main">
+            <a:off x="4886325" y="2609850"/>
+            <a:ext cx="3924300" cy="85725"/>
+          </a:xfrm>
+          <a:prstGeom xmlns:a="http://schemas.openxmlformats.org/drawingml/2006/main" prst="rect">
+            <a:avLst/>
+          </a:prstGeom>
+          <a:solidFill xmlns:a="http://schemas.openxmlformats.org/drawingml/2006/main">
+            <a:srgbClr val="AC8CC0"/>
+          </a:solidFill>
+          <a:ln xmlns:a="http://schemas.openxmlformats.org/drawingml/2006/main" w="0">
+            <a:noFill/>
+          </a:ln>
+        </p:spPr>
+      </p:sp>
+      <p:sp>
+        <p:nvSpPr>
+          <p:cNvPr id="20" name="">
+            <a:extLst xmlns:a="http://schemas.openxmlformats.org/drawingml/2006/main">
+              <a:ext uri="{FF2B5EF4-FFF2-40B4-BE49-F238E27FC236}">
+                <a16:creationId xmlns:a16="http://schemas.microsoft.com/office/drawing/2014/main" id="{63B7B901-17C6-4D72-81C9-FDF3696CA33E}"/>
+              </a:ext>
+            </a:extLst>
+          </p:cNvPr>
+          <p:cNvSpPr>
+            <a:spLocks xmlns:a="http://schemas.openxmlformats.org/drawingml/2006/main" noGrp="1"/>
+          </p:cNvSpPr>
+          <p:nvPr/>
+        </p:nvSpPr>
+        <p:spPr>
+          <a:xfrm xmlns:a="http://schemas.openxmlformats.org/drawingml/2006/main">
+            <a:off x="5124450" y="2838450"/>
+            <a:ext cx="3448050" cy="590550"/>
+          </a:xfrm>
+          <a:prstGeom xmlns:a="http://schemas.openxmlformats.org/drawingml/2006/main" prst="rect">
+            <a:avLst/>
+          </a:prstGeom>
+          <a:noFill xmlns:a="http://schemas.openxmlformats.org/drawingml/2006/main"/>
+          <a:ln xmlns:a="http://schemas.openxmlformats.org/drawingml/2006/main" w="0">
+            <a:noFill/>
+          </a:ln>
+        </p:spPr>
+        <p:txBody>
+          <a:bodyPr xmlns:a="http://schemas.openxmlformats.org/drawingml/2006/main" lIns="0" tIns="0" rIns="0" bIns="0" anchor="ctr">
+            <a:noAutofit/>
+          </a:bodyPr>
+          <a:lstStyle xmlns:a="http://schemas.openxmlformats.org/drawingml/2006/main"/>
+          <a:p xmlns:a="http://schemas.openxmlformats.org/drawingml/2006/main">
+            <a:pPr algn="l">
+              <a:defRPr sz="2325" b="1">
+                <a:solidFill>
+                  <a:srgbClr val="16233F"/>
+                </a:solidFill>
+                <a:latin typeface="Arial"/>
+                <a:ea typeface="Arial"/>
+                <a:cs typeface="Arial"/>
+              </a:defRPr>
+            </a:pPr>
+            <a:r>
+              <a:rPr sz="2325" b="1">
+                <a:solidFill>
+                  <a:srgbClr val="16233F"/>
+                </a:solidFill>
+                <a:latin typeface="Arial"/>
+                <a:ea typeface="Arial"/>
+                <a:cs typeface="Arial"/>
+              </a:rPr>
+              <a:t>2 · XẾP HẠNG</a:t>
+            </a:r>
+          </a:p>
+        </p:txBody>
+      </p:sp>
+      <p:sp>
+        <p:nvSpPr>
+          <p:cNvPr id="21" name="">
+            <a:extLst xmlns:a="http://schemas.openxmlformats.org/drawingml/2006/main">
+              <a:ext uri="{FF2B5EF4-FFF2-40B4-BE49-F238E27FC236}">
+                <a16:creationId xmlns:a16="http://schemas.microsoft.com/office/drawing/2014/main" id="{E92C5177-8618-45CA-8C6C-07A7A61B3EF1}"/>
+              </a:ext>
+            </a:extLst>
+          </p:cNvPr>
+          <p:cNvSpPr>
+            <a:spLocks xmlns:a="http://schemas.openxmlformats.org/drawingml/2006/main" noGrp="1"/>
+          </p:cNvSpPr>
+          <p:nvPr/>
+        </p:nvSpPr>
+        <p:spPr>
+          <a:xfrm xmlns:a="http://schemas.openxmlformats.org/drawingml/2006/main">
+            <a:off x="5124450" y="3590925"/>
+            <a:ext cx="3448050" cy="1276350"/>
+          </a:xfrm>
+          <a:prstGeom xmlns:a="http://schemas.openxmlformats.org/drawingml/2006/main" prst="rect">
+            <a:avLst/>
+          </a:prstGeom>
+          <a:noFill xmlns:a="http://schemas.openxmlformats.org/drawingml/2006/main"/>
+          <a:ln xmlns:a="http://schemas.openxmlformats.org/drawingml/2006/main" w="0">
+            <a:noFill/>
+          </a:ln>
+        </p:spPr>
+        <p:txBody>
+          <a:bodyPr xmlns:a="http://schemas.openxmlformats.org/drawingml/2006/main" lIns="0" tIns="0" rIns="0" bIns="0" anchor="ctr">
+            <a:noAutofit/>
+          </a:bodyPr>
+          <a:lstStyle xmlns:a="http://schemas.openxmlformats.org/drawingml/2006/main"/>
+          <a:p xmlns:a="http://schemas.openxmlformats.org/drawingml/2006/main">
+            <a:pPr algn="l">
+              <a:defRPr sz="1875" b="0">
+                <a:solidFill>
+                  <a:srgbClr val="16233F"/>
+                </a:solidFill>
+                <a:latin typeface="Arial"/>
+                <a:ea typeface="Arial"/>
+                <a:cs typeface="Arial"/>
+              </a:defRPr>
+            </a:pPr>
+            <a:r>
+              <a:rPr sz="1875" b="0">
+                <a:solidFill>
+                  <a:srgbClr val="16233F"/>
+                </a:solidFill>
+                <a:latin typeface="Arial"/>
+                <a:ea typeface="Arial"/>
+                <a:cs typeface="Arial"/>
+              </a:rPr>
+              <a:t>Ưu tiên phim phù hợp với từng người</a:t>
+            </a:r>
+          </a:p>
+        </p:txBody>
+      </p:sp>
+      <p:sp>
+        <p:nvSpPr>
+          <p:cNvPr id="22" name="">
+            <a:extLst xmlns:a="http://schemas.openxmlformats.org/drawingml/2006/main">
+              <a:ext uri="{FF2B5EF4-FFF2-40B4-BE49-F238E27FC236}">
+                <a16:creationId xmlns:a16="http://schemas.microsoft.com/office/drawing/2014/main" id="{CD6D7350-C54D-4E4C-8C3B-E6E2615AF2C6}"/>
+              </a:ext>
+            </a:extLst>
+          </p:cNvPr>
+          <p:cNvSpPr>
+            <a:spLocks xmlns:a="http://schemas.openxmlformats.org/drawingml/2006/main" noGrp="1"/>
+          </p:cNvSpPr>
+          <p:nvPr/>
+        </p:nvSpPr>
+        <p:spPr>
+          <a:xfrm xmlns:a="http://schemas.openxmlformats.org/drawingml/2006/main">
+            <a:off x="9134475" y="2609850"/>
+            <a:ext cx="3924300" cy="2562225"/>
+          </a:xfrm>
+          <a:prstGeom xmlns:a="http://schemas.openxmlformats.org/drawingml/2006/main" prst="roundRect">
+            <a:avLst>
+              <a:gd name="adj" fmla="val 2974"/>
+            </a:avLst>
+          </a:prstGeom>
+          <a:solidFill xmlns:a="http://schemas.openxmlformats.org/drawingml/2006/main">
+            <a:srgbClr val="F5F5F6"/>
+          </a:solidFill>
+          <a:ln xmlns:a="http://schemas.openxmlformats.org/drawingml/2006/main" w="0">
+            <a:noFill/>
+          </a:ln>
+        </p:spPr>
+      </p:sp>
+      <p:sp>
+        <p:nvSpPr>
+          <p:cNvPr id="23" name="">
+            <a:extLst xmlns:a="http://schemas.openxmlformats.org/drawingml/2006/main">
+              <a:ext uri="{FF2B5EF4-FFF2-40B4-BE49-F238E27FC236}">
+                <a16:creationId xmlns:a16="http://schemas.microsoft.com/office/drawing/2014/main" id="{CB2D85E1-BC71-4B91-B2EE-FBDE0C4A6872}"/>
+              </a:ext>
+            </a:extLst>
+          </p:cNvPr>
+          <p:cNvSpPr>
+            <a:spLocks xmlns:a="http://schemas.openxmlformats.org/drawingml/2006/main" noGrp="1"/>
+          </p:cNvSpPr>
+          <p:nvPr/>
+        </p:nvSpPr>
+        <p:spPr>
+          <a:xfrm xmlns:a="http://schemas.openxmlformats.org/drawingml/2006/main">
+            <a:off x="9134475" y="2609850"/>
+            <a:ext cx="3924300" cy="85725"/>
+          </a:xfrm>
+          <a:prstGeom xmlns:a="http://schemas.openxmlformats.org/drawingml/2006/main" prst="rect">
+            <a:avLst/>
+          </a:prstGeom>
+          <a:solidFill xmlns:a="http://schemas.openxmlformats.org/drawingml/2006/main">
+            <a:srgbClr val="50A779"/>
+          </a:solidFill>
+          <a:ln xmlns:a="http://schemas.openxmlformats.org/drawingml/2006/main" w="0">
+            <a:noFill/>
+          </a:ln>
+        </p:spPr>
+      </p:sp>
+      <p:sp>
+        <p:nvSpPr>
+          <p:cNvPr id="24" name="">
+            <a:extLst xmlns:a="http://schemas.openxmlformats.org/drawingml/2006/main">
+              <a:ext uri="{FF2B5EF4-FFF2-40B4-BE49-F238E27FC236}">
+                <a16:creationId xmlns:a16="http://schemas.microsoft.com/office/drawing/2014/main" id="{36D535C6-9BD6-4C7A-9934-A8C1A8E3D559}"/>
+              </a:ext>
+            </a:extLst>
+          </p:cNvPr>
+          <p:cNvSpPr>
+            <a:spLocks xmlns:a="http://schemas.openxmlformats.org/drawingml/2006/main" noGrp="1"/>
+          </p:cNvSpPr>
+          <p:nvPr/>
+        </p:nvSpPr>
+        <p:spPr>
+          <a:xfrm xmlns:a="http://schemas.openxmlformats.org/drawingml/2006/main">
+            <a:off x="9372600" y="2838450"/>
+            <a:ext cx="3448050" cy="590550"/>
+          </a:xfrm>
+          <a:prstGeom xmlns:a="http://schemas.openxmlformats.org/drawingml/2006/main" prst="rect">
+            <a:avLst/>
+          </a:prstGeom>
+          <a:noFill xmlns:a="http://schemas.openxmlformats.org/drawingml/2006/main"/>
+          <a:ln xmlns:a="http://schemas.openxmlformats.org/drawingml/2006/main" w="0">
+            <a:noFill/>
+          </a:ln>
+        </p:spPr>
+        <p:txBody>
+          <a:bodyPr xmlns:a="http://schemas.openxmlformats.org/drawingml/2006/main" lIns="0" tIns="0" rIns="0" bIns="0" anchor="ctr">
+            <a:noAutofit/>
+          </a:bodyPr>
+          <a:lstStyle xmlns:a="http://schemas.openxmlformats.org/drawingml/2006/main"/>
+          <a:p xmlns:a="http://schemas.openxmlformats.org/drawingml/2006/main">
+            <a:pPr algn="l">
+              <a:defRPr sz="2325" b="1">
+                <a:solidFill>
+                  <a:srgbClr val="16233F"/>
+                </a:solidFill>
+                <a:latin typeface="Arial"/>
+                <a:ea typeface="Arial"/>
+                <a:cs typeface="Arial"/>
+              </a:defRPr>
+            </a:pPr>
+            <a:r>
+              <a:rPr sz="2325" b="1">
+                <a:solidFill>
+                  <a:srgbClr val="16233F"/>
+                </a:solidFill>
+                <a:latin typeface="Arial"/>
+                <a:ea typeface="Arial"/>
+                <a:cs typeface="Arial"/>
+              </a:rPr>
+              <a:t>3 · ĐÁNH GIÁ</a:t>
+            </a:r>
+          </a:p>
+        </p:txBody>
+      </p:sp>
+      <p:sp>
+        <p:nvSpPr>
+          <p:cNvPr id="25" name="">
+            <a:extLst xmlns:a="http://schemas.openxmlformats.org/drawingml/2006/main">
+              <a:ext uri="{FF2B5EF4-FFF2-40B4-BE49-F238E27FC236}">
+                <a16:creationId xmlns:a16="http://schemas.microsoft.com/office/drawing/2014/main" id="{16332048-F149-4A91-8FA5-87FA4520042E}"/>
+              </a:ext>
+            </a:extLst>
+          </p:cNvPr>
+          <p:cNvSpPr>
+            <a:spLocks xmlns:a="http://schemas.openxmlformats.org/drawingml/2006/main" noGrp="1"/>
+          </p:cNvSpPr>
+          <p:nvPr/>
+        </p:nvSpPr>
+        <p:spPr>
+          <a:xfrm xmlns:a="http://schemas.openxmlformats.org/drawingml/2006/main">
+            <a:off x="9372600" y="3590925"/>
+            <a:ext cx="3448050" cy="1276350"/>
+          </a:xfrm>
+          <a:prstGeom xmlns:a="http://schemas.openxmlformats.org/drawingml/2006/main" prst="rect">
+            <a:avLst/>
+          </a:prstGeom>
+          <a:noFill xmlns:a="http://schemas.openxmlformats.org/drawingml/2006/main"/>
+          <a:ln xmlns:a="http://schemas.openxmlformats.org/drawingml/2006/main" w="0">
+            <a:noFill/>
+          </a:ln>
+        </p:spPr>
+        <p:txBody>
+          <a:bodyPr xmlns:a="http://schemas.openxmlformats.org/drawingml/2006/main" lIns="0" tIns="0" rIns="0" bIns="0" anchor="ctr">
+            <a:noAutofit/>
+          </a:bodyPr>
+          <a:lstStyle xmlns:a="http://schemas.openxmlformats.org/drawingml/2006/main"/>
+          <a:p xmlns:a="http://schemas.openxmlformats.org/drawingml/2006/main">
+            <a:pPr algn="l">
+              <a:defRPr sz="1875" b="0">
+                <a:solidFill>
+                  <a:srgbClr val="16233F"/>
+                </a:solidFill>
+                <a:latin typeface="Arial"/>
+                <a:ea typeface="Arial"/>
+                <a:cs typeface="Arial"/>
+              </a:defRPr>
+            </a:pPr>
+            <a:r>
+              <a:rPr sz="1875" b="0">
+                <a:solidFill>
+                  <a:srgbClr val="16233F"/>
+                </a:solidFill>
+                <a:latin typeface="Arial"/>
+                <a:ea typeface="Arial"/>
+                <a:cs typeface="Arial"/>
+              </a:rPr>
+              <a:t>Dùng các lượt chấm xảy ra sau để kiểm tra</a:t>
+            </a:r>
+          </a:p>
+        </p:txBody>
+      </p:sp>
+      <p:sp>
+        <p:nvSpPr>
+          <p:cNvPr id="26" name="">
+            <a:extLst xmlns:a="http://schemas.openxmlformats.org/drawingml/2006/main">
+              <a:ext uri="{FF2B5EF4-FFF2-40B4-BE49-F238E27FC236}">
+                <a16:creationId xmlns:a16="http://schemas.microsoft.com/office/drawing/2014/main" id="{42ED229F-0474-419C-AFED-B38EDB55B1B2}"/>
+              </a:ext>
+            </a:extLst>
+          </p:cNvPr>
+          <p:cNvSpPr>
+            <a:spLocks xmlns:a="http://schemas.openxmlformats.org/drawingml/2006/main" noGrp="1"/>
+          </p:cNvSpPr>
+          <p:nvPr/>
+        </p:nvSpPr>
+        <p:spPr>
+          <a:xfrm xmlns:a="http://schemas.openxmlformats.org/drawingml/2006/main">
+            <a:off x="666750" y="5753100"/>
+            <a:ext cx="12372975" cy="714375"/>
+          </a:xfrm>
+          <a:prstGeom xmlns:a="http://schemas.openxmlformats.org/drawingml/2006/main" prst="rect">
+            <a:avLst/>
+          </a:prstGeom>
+          <a:solidFill xmlns:a="http://schemas.openxmlformats.org/drawingml/2006/main">
+            <a:srgbClr val="F5E8EC"/>
+          </a:solidFill>
+          <a:ln xmlns:a="http://schemas.openxmlformats.org/drawingml/2006/main" w="0">
+            <a:noFill/>
+          </a:ln>
+        </p:spPr>
+      </p:sp>
+      <p:sp>
+        <p:nvSpPr>
+          <p:cNvPr id="27" name="">
+            <a:extLst xmlns:a="http://schemas.openxmlformats.org/drawingml/2006/main">
+              <a:ext uri="{FF2B5EF4-FFF2-40B4-BE49-F238E27FC236}">
+                <a16:creationId xmlns:a16="http://schemas.microsoft.com/office/drawing/2014/main" id="{7312000A-8D8D-4FF5-B9C9-F6B1608CC238}"/>
+              </a:ext>
+            </a:extLst>
+          </p:cNvPr>
+          <p:cNvSpPr>
+            <a:spLocks xmlns:a="http://schemas.openxmlformats.org/drawingml/2006/main" noGrp="1"/>
+          </p:cNvSpPr>
+          <p:nvPr/>
+        </p:nvSpPr>
+        <p:spPr>
+          <a:xfrm xmlns:a="http://schemas.openxmlformats.org/drawingml/2006/main">
+            <a:off x="923925" y="5829300"/>
+            <a:ext cx="11858625" cy="552450"/>
+          </a:xfrm>
+          <a:prstGeom xmlns:a="http://schemas.openxmlformats.org/drawingml/2006/main" prst="rect">
+            <a:avLst/>
+          </a:prstGeom>
+          <a:noFill xmlns:a="http://schemas.openxmlformats.org/drawingml/2006/main"/>
+          <a:ln xmlns:a="http://schemas.openxmlformats.org/drawingml/2006/main" w="0">
+            <a:noFill/>
+          </a:ln>
+        </p:spPr>
+        <p:txBody>
+          <a:bodyPr xmlns:a="http://schemas.openxmlformats.org/drawingml/2006/main" lIns="0" tIns="0" rIns="0" bIns="0" anchor="ctr">
+            <a:noAutofit/>
+          </a:bodyPr>
+          <a:lstStyle xmlns:a="http://schemas.openxmlformats.org/drawingml/2006/main"/>
+          <a:p xmlns:a="http://schemas.openxmlformats.org/drawingml/2006/main">
+            <a:pPr algn="l">
+              <a:defRPr sz="2025" b="1">
+                <a:solidFill>
+                  <a:srgbClr val="16233F"/>
+                </a:solidFill>
+                <a:latin typeface="Arial"/>
+                <a:ea typeface="Arial"/>
+                <a:cs typeface="Arial"/>
+              </a:defRPr>
+            </a:pPr>
+            <a:r>
+              <a:rPr sz="2025" b="1">
+                <a:solidFill>
+                  <a:srgbClr val="16233F"/>
+                </a:solidFill>
+                <a:latin typeface="Arial"/>
+                <a:ea typeface="Arial"/>
+                <a:cs typeface="Arial"/>
+              </a:rPr>
+              <a:t>MovieLens 25M là dữ liệu thử nghiệm, không phải dữ liệu thuê bao Netflix.</a:t>
             </a:r>
           </a:p>
         </p:txBody>
@@ -6033,7 +6951,7 @@
     </p:spTree>
     <p:extLst>
       <p:ext uri="{BB962C8B-B14F-4D97-AF65-F5344CB8AC3E}">
-        <p14:creationId xmlns:p14="http://schemas.microsoft.com/office/powerpoint/2010/main" val="320429493"/>
+        <p14:creationId xmlns:p14="http://schemas.microsoft.com/office/powerpoint/2010/main" val="1175276643"/>
       </p:ext>
     </p:extLst>
   </p:cSld>
@@ -6064,7 +6982,7 @@
           <p:cNvPr id="30" name="">
             <a:extLst xmlns:a="http://schemas.openxmlformats.org/drawingml/2006/main">
               <a:ext uri="{FF2B5EF4-FFF2-40B4-BE49-F238E27FC236}">
-                <a16:creationId xmlns:a16="http://schemas.microsoft.com/office/drawing/2014/main" id="{433DD0EF-B180-490C-BA01-5160813DCA79}"/>
+                <a16:creationId xmlns:a16="http://schemas.microsoft.com/office/drawing/2014/main" id="{65083697-DCA7-408E-A0F9-7B763D176FB2}"/>
               </a:ext>
             </a:extLst>
           </p:cNvPr>
@@ -6094,7 +7012,7 @@
           <p:cNvPr id="2" name="">
             <a:extLst xmlns:a="http://schemas.openxmlformats.org/drawingml/2006/main">
               <a:ext uri="{FF2B5EF4-FFF2-40B4-BE49-F238E27FC236}">
-                <a16:creationId xmlns:a16="http://schemas.microsoft.com/office/drawing/2014/main" id="{7A5DB637-77BE-4B4A-9198-9EF2A142126A}"/>
+                <a16:creationId xmlns:a16="http://schemas.microsoft.com/office/drawing/2014/main" id="{BC423074-B8FD-423C-8950-9F3FB8FEA045}"/>
               </a:ext>
             </a:extLst>
           </p:cNvPr>
@@ -6151,7 +7069,7 @@
           <p:cNvPr id="3" name="">
             <a:extLst xmlns:a="http://schemas.openxmlformats.org/drawingml/2006/main">
               <a:ext uri="{FF2B5EF4-FFF2-40B4-BE49-F238E27FC236}">
-                <a16:creationId xmlns:a16="http://schemas.microsoft.com/office/drawing/2014/main" id="{C98731DA-8EB7-4DD5-B452-457287624E32}"/>
+                <a16:creationId xmlns:a16="http://schemas.microsoft.com/office/drawing/2014/main" id="{94D7A3BC-A7A0-4619-9570-F2519E46E8D1}"/>
               </a:ext>
             </a:extLst>
           </p:cNvPr>
@@ -6181,7 +7099,7 @@
           <p:cNvPr id="4" name="">
             <a:extLst xmlns:a="http://schemas.openxmlformats.org/drawingml/2006/main">
               <a:ext uri="{FF2B5EF4-FFF2-40B4-BE49-F238E27FC236}">
-                <a16:creationId xmlns:a16="http://schemas.microsoft.com/office/drawing/2014/main" id="{582D7F1E-B60B-441E-849E-8ADA2873659E}"/>
+                <a16:creationId xmlns:a16="http://schemas.microsoft.com/office/drawing/2014/main" id="{84DFAC89-C607-4CEB-97D1-58D8E8B92804}"/>
               </a:ext>
             </a:extLst>
           </p:cNvPr>
@@ -6238,7 +7156,7 @@
           <p:cNvPr id="5" name="">
             <a:extLst xmlns:a="http://schemas.openxmlformats.org/drawingml/2006/main">
               <a:ext uri="{FF2B5EF4-FFF2-40B4-BE49-F238E27FC236}">
-                <a16:creationId xmlns:a16="http://schemas.microsoft.com/office/drawing/2014/main" id="{9BD82ADF-B493-4FEC-891B-B0DF9E45B03A}"/>
+                <a16:creationId xmlns:a16="http://schemas.microsoft.com/office/drawing/2014/main" id="{5735B821-936B-4D7C-95A3-780DB42B10FC}"/>
               </a:ext>
             </a:extLst>
           </p:cNvPr>
@@ -6268,7 +7186,7 @@
           <p:cNvPr id="6" name="">
             <a:extLst xmlns:a="http://schemas.openxmlformats.org/drawingml/2006/main">
               <a:ext uri="{FF2B5EF4-FFF2-40B4-BE49-F238E27FC236}">
-                <a16:creationId xmlns:a16="http://schemas.microsoft.com/office/drawing/2014/main" id="{8A3AABF0-E0F1-460C-89CC-9ABA82698DCF}"/>
+                <a16:creationId xmlns:a16="http://schemas.microsoft.com/office/drawing/2014/main" id="{1713C380-DFD1-4D54-A4A5-4F7FACFE01A2}"/>
               </a:ext>
             </a:extLst>
           </p:cNvPr>
@@ -6325,7 +7243,7 @@
           <p:cNvPr id="7" name="">
             <a:extLst xmlns:a="http://schemas.openxmlformats.org/drawingml/2006/main">
               <a:ext uri="{FF2B5EF4-FFF2-40B4-BE49-F238E27FC236}">
-                <a16:creationId xmlns:a16="http://schemas.microsoft.com/office/drawing/2014/main" id="{C03AD4B4-CF7B-4558-AB7F-66ABF6327EB2}"/>
+                <a16:creationId xmlns:a16="http://schemas.microsoft.com/office/drawing/2014/main" id="{B93BA506-8C47-46C1-A53C-E26686334AE7}"/>
               </a:ext>
             </a:extLst>
           </p:cNvPr>
@@ -6355,7 +7273,7 @@
           <p:cNvPr id="8" name="">
             <a:extLst xmlns:a="http://schemas.openxmlformats.org/drawingml/2006/main">
               <a:ext uri="{FF2B5EF4-FFF2-40B4-BE49-F238E27FC236}">
-                <a16:creationId xmlns:a16="http://schemas.microsoft.com/office/drawing/2014/main" id="{FBA6334E-09B7-4DBF-BD2F-819EA802B5C4}"/>
+                <a16:creationId xmlns:a16="http://schemas.microsoft.com/office/drawing/2014/main" id="{732A228C-97D7-499E-99A6-DBCF4F212B73}"/>
               </a:ext>
             </a:extLst>
           </p:cNvPr>
@@ -6412,7 +7330,7 @@
           <p:cNvPr id="9" name="">
             <a:extLst xmlns:a="http://schemas.openxmlformats.org/drawingml/2006/main">
               <a:ext uri="{FF2B5EF4-FFF2-40B4-BE49-F238E27FC236}">
-                <a16:creationId xmlns:a16="http://schemas.microsoft.com/office/drawing/2014/main" id="{7B54215E-9513-4EC5-8FED-E8B7AEF70567}"/>
+                <a16:creationId xmlns:a16="http://schemas.microsoft.com/office/drawing/2014/main" id="{8677A5F8-DD7D-4E25-97FE-D5ACC23882A1}"/>
               </a:ext>
             </a:extLst>
           </p:cNvPr>
@@ -6442,7 +7360,7 @@
           <p:cNvPr id="10" name="">
             <a:extLst xmlns:a="http://schemas.openxmlformats.org/drawingml/2006/main">
               <a:ext uri="{FF2B5EF4-FFF2-40B4-BE49-F238E27FC236}">
-                <a16:creationId xmlns:a16="http://schemas.microsoft.com/office/drawing/2014/main" id="{179EEC67-4D3E-4D16-B423-837A8C677B1C}"/>
+                <a16:creationId xmlns:a16="http://schemas.microsoft.com/office/drawing/2014/main" id="{A59DA652-5894-456B-BB56-2C324CF1B072}"/>
               </a:ext>
             </a:extLst>
           </p:cNvPr>
@@ -6499,7 +7417,7 @@
           <p:cNvPr id="11" name="">
             <a:extLst xmlns:a="http://schemas.openxmlformats.org/drawingml/2006/main">
               <a:ext uri="{FF2B5EF4-FFF2-40B4-BE49-F238E27FC236}">
-                <a16:creationId xmlns:a16="http://schemas.microsoft.com/office/drawing/2014/main" id="{79F96EC1-EBAF-4EFE-8DFF-842C6D2D12C0}"/>
+                <a16:creationId xmlns:a16="http://schemas.microsoft.com/office/drawing/2014/main" id="{88184071-8E88-4F66-9BAE-1088E31B6172}"/>
               </a:ext>
             </a:extLst>
           </p:cNvPr>
@@ -6556,7 +7474,7 @@
           <p:cNvPr id="12" name="">
             <a:extLst xmlns:a="http://schemas.openxmlformats.org/drawingml/2006/main">
               <a:ext uri="{FF2B5EF4-FFF2-40B4-BE49-F238E27FC236}">
-                <a16:creationId xmlns:a16="http://schemas.microsoft.com/office/drawing/2014/main" id="{D19B8322-7F70-4F43-8CB3-EFA15DD84E53}"/>
+                <a16:creationId xmlns:a16="http://schemas.microsoft.com/office/drawing/2014/main" id="{35E9BA7C-07B1-4744-95E9-393CAF7BBCFD}"/>
               </a:ext>
             </a:extLst>
           </p:cNvPr>
@@ -6613,7 +7531,7 @@
           <p:cNvPr id="13" name="">
             <a:extLst xmlns:a="http://schemas.openxmlformats.org/drawingml/2006/main">
               <a:ext uri="{FF2B5EF4-FFF2-40B4-BE49-F238E27FC236}">
-                <a16:creationId xmlns:a16="http://schemas.microsoft.com/office/drawing/2014/main" id="{4764B82B-C47E-406E-9E32-6333C960017F}"/>
+                <a16:creationId xmlns:a16="http://schemas.microsoft.com/office/drawing/2014/main" id="{6EA6BF21-7336-48BC-B154-79BBA5114B62}"/>
               </a:ext>
             </a:extLst>
           </p:cNvPr>
@@ -6670,7 +7588,7 @@
           <p:cNvPr id="14" name="">
             <a:extLst xmlns:a="http://schemas.openxmlformats.org/drawingml/2006/main">
               <a:ext uri="{FF2B5EF4-FFF2-40B4-BE49-F238E27FC236}">
-                <a16:creationId xmlns:a16="http://schemas.microsoft.com/office/drawing/2014/main" id="{37D4D459-214F-44B4-8AEE-47301F84A8F8}"/>
+                <a16:creationId xmlns:a16="http://schemas.microsoft.com/office/drawing/2014/main" id="{DE056321-D8B8-4AAE-9788-2A6FFB26C420}"/>
               </a:ext>
             </a:extLst>
           </p:cNvPr>
@@ -6700,7 +7618,7 @@
           <p:cNvPr id="15" name="">
             <a:extLst xmlns:a="http://schemas.openxmlformats.org/drawingml/2006/main">
               <a:ext uri="{FF2B5EF4-FFF2-40B4-BE49-F238E27FC236}">
-                <a16:creationId xmlns:a16="http://schemas.microsoft.com/office/drawing/2014/main" id="{8514AAEE-9AC7-47A0-B6D7-6F78CC892B09}"/>
+                <a16:creationId xmlns:a16="http://schemas.microsoft.com/office/drawing/2014/main" id="{6218999D-CCA1-4496-9727-C0C5FBA916F3}"/>
               </a:ext>
             </a:extLst>
           </p:cNvPr>
@@ -6732,7 +7650,7 @@
           <p:cNvPr id="16" name="">
             <a:extLst xmlns:a="http://schemas.openxmlformats.org/drawingml/2006/main">
               <a:ext uri="{FF2B5EF4-FFF2-40B4-BE49-F238E27FC236}">
-                <a16:creationId xmlns:a16="http://schemas.microsoft.com/office/drawing/2014/main" id="{C8057054-F9AC-47F1-8829-16DF66679076}"/>
+                <a16:creationId xmlns:a16="http://schemas.microsoft.com/office/drawing/2014/main" id="{E793B045-6491-406A-910C-FB4BEE9EA8CF}"/>
               </a:ext>
             </a:extLst>
           </p:cNvPr>
@@ -6789,7 +7707,7 @@
           <p:cNvPr id="17" name="">
             <a:extLst xmlns:a="http://schemas.openxmlformats.org/drawingml/2006/main">
               <a:ext uri="{FF2B5EF4-FFF2-40B4-BE49-F238E27FC236}">
-                <a16:creationId xmlns:a16="http://schemas.microsoft.com/office/drawing/2014/main" id="{89C4309B-AFFD-47F2-998B-AB466DE176F3}"/>
+                <a16:creationId xmlns:a16="http://schemas.microsoft.com/office/drawing/2014/main" id="{1CCA3474-F569-4D0D-8A1E-E980AD15A0EA}"/>
               </a:ext>
             </a:extLst>
           </p:cNvPr>
@@ -6846,7 +7764,7 @@
           <p:cNvPr id="18" name="">
             <a:extLst xmlns:a="http://schemas.openxmlformats.org/drawingml/2006/main">
               <a:ext uri="{FF2B5EF4-FFF2-40B4-BE49-F238E27FC236}">
-                <a16:creationId xmlns:a16="http://schemas.microsoft.com/office/drawing/2014/main" id="{EFE7A95A-2CBC-4B6B-A03B-45E1BA8CE5DF}"/>
+                <a16:creationId xmlns:a16="http://schemas.microsoft.com/office/drawing/2014/main" id="{D5048685-9425-4ADE-A163-C9BBC870E187}"/>
               </a:ext>
             </a:extLst>
           </p:cNvPr>
@@ -6878,7 +7796,7 @@
           <p:cNvPr id="19" name="">
             <a:extLst xmlns:a="http://schemas.openxmlformats.org/drawingml/2006/main">
               <a:ext uri="{FF2B5EF4-FFF2-40B4-BE49-F238E27FC236}">
-                <a16:creationId xmlns:a16="http://schemas.microsoft.com/office/drawing/2014/main" id="{D2DEED4A-5810-44E2-B207-43F4AB0A5EE2}"/>
+                <a16:creationId xmlns:a16="http://schemas.microsoft.com/office/drawing/2014/main" id="{8AA7E228-73E9-4630-A221-C66CE6F7147E}"/>
               </a:ext>
             </a:extLst>
           </p:cNvPr>
@@ -6935,7 +7853,7 @@
           <p:cNvPr id="20" name="">
             <a:extLst xmlns:a="http://schemas.openxmlformats.org/drawingml/2006/main">
               <a:ext uri="{FF2B5EF4-FFF2-40B4-BE49-F238E27FC236}">
-                <a16:creationId xmlns:a16="http://schemas.microsoft.com/office/drawing/2014/main" id="{C1E4407E-D483-4DBF-92BE-568E876F4FF1}"/>
+                <a16:creationId xmlns:a16="http://schemas.microsoft.com/office/drawing/2014/main" id="{FDCBC5AA-92C0-4345-B600-67F99F3100EE}"/>
               </a:ext>
             </a:extLst>
           </p:cNvPr>
@@ -6992,7 +7910,7 @@
           <p:cNvPr id="21" name="">
             <a:extLst xmlns:a="http://schemas.openxmlformats.org/drawingml/2006/main">
               <a:ext uri="{FF2B5EF4-FFF2-40B4-BE49-F238E27FC236}">
-                <a16:creationId xmlns:a16="http://schemas.microsoft.com/office/drawing/2014/main" id="{0540A70F-84E7-42EB-B921-F4B9873C3563}"/>
+                <a16:creationId xmlns:a16="http://schemas.microsoft.com/office/drawing/2014/main" id="{EF36DD73-B03B-413D-B762-5E8876C0A098}"/>
               </a:ext>
             </a:extLst>
           </p:cNvPr>
@@ -7024,7 +7942,7 @@
           <p:cNvPr id="22" name="">
             <a:extLst xmlns:a="http://schemas.openxmlformats.org/drawingml/2006/main">
               <a:ext uri="{FF2B5EF4-FFF2-40B4-BE49-F238E27FC236}">
-                <a16:creationId xmlns:a16="http://schemas.microsoft.com/office/drawing/2014/main" id="{26A3DA71-4DD4-4D87-BB5C-004B8B587A67}"/>
+                <a16:creationId xmlns:a16="http://schemas.microsoft.com/office/drawing/2014/main" id="{15BCF4CA-C94C-43A6-AA29-0F153FA8C4B0}"/>
               </a:ext>
             </a:extLst>
           </p:cNvPr>
@@ -7081,7 +7999,7 @@
           <p:cNvPr id="23" name="">
             <a:extLst xmlns:a="http://schemas.openxmlformats.org/drawingml/2006/main">
               <a:ext uri="{FF2B5EF4-FFF2-40B4-BE49-F238E27FC236}">
-                <a16:creationId xmlns:a16="http://schemas.microsoft.com/office/drawing/2014/main" id="{F8964734-DE77-4581-BB64-C8EA0D250804}"/>
+                <a16:creationId xmlns:a16="http://schemas.microsoft.com/office/drawing/2014/main" id="{735129F2-DE74-47E6-8D07-FD2389B106F3}"/>
               </a:ext>
             </a:extLst>
           </p:cNvPr>
@@ -7138,7 +8056,7 @@
           <p:cNvPr id="24" name="">
             <a:extLst xmlns:a="http://schemas.openxmlformats.org/drawingml/2006/main">
               <a:ext uri="{FF2B5EF4-FFF2-40B4-BE49-F238E27FC236}">
-                <a16:creationId xmlns:a16="http://schemas.microsoft.com/office/drawing/2014/main" id="{C473FEB2-785C-4E28-8612-71DA98B88979}"/>
+                <a16:creationId xmlns:a16="http://schemas.microsoft.com/office/drawing/2014/main" id="{C5545A11-A978-4C01-9289-451CFB6EF1B7}"/>
               </a:ext>
             </a:extLst>
           </p:cNvPr>
@@ -7170,7 +8088,7 @@
           <p:cNvPr id="25" name="">
             <a:extLst xmlns:a="http://schemas.openxmlformats.org/drawingml/2006/main">
               <a:ext uri="{FF2B5EF4-FFF2-40B4-BE49-F238E27FC236}">
-                <a16:creationId xmlns:a16="http://schemas.microsoft.com/office/drawing/2014/main" id="{4BD8C672-09C6-40F9-8FFC-3B4A9433F1C4}"/>
+                <a16:creationId xmlns:a16="http://schemas.microsoft.com/office/drawing/2014/main" id="{77E20B9F-7755-4273-BF02-9A9B094157BC}"/>
               </a:ext>
             </a:extLst>
           </p:cNvPr>
@@ -7227,7 +8145,7 @@
           <p:cNvPr id="26" name="">
             <a:extLst xmlns:a="http://schemas.openxmlformats.org/drawingml/2006/main">
               <a:ext uri="{FF2B5EF4-FFF2-40B4-BE49-F238E27FC236}">
-                <a16:creationId xmlns:a16="http://schemas.microsoft.com/office/drawing/2014/main" id="{99F0F823-1517-451D-9A99-16F4555BB20B}"/>
+                <a16:creationId xmlns:a16="http://schemas.microsoft.com/office/drawing/2014/main" id="{BB1C8821-E3EA-4503-806E-FA74AB71B93D}"/>
               </a:ext>
             </a:extLst>
           </p:cNvPr>
@@ -7284,7 +8202,7 @@
           <p:cNvPr id="27" name="">
             <a:extLst xmlns:a="http://schemas.openxmlformats.org/drawingml/2006/main">
               <a:ext uri="{FF2B5EF4-FFF2-40B4-BE49-F238E27FC236}">
-                <a16:creationId xmlns:a16="http://schemas.microsoft.com/office/drawing/2014/main" id="{F2DAC201-C557-40A0-B8F7-D240809D295B}"/>
+                <a16:creationId xmlns:a16="http://schemas.microsoft.com/office/drawing/2014/main" id="{A7DED8F7-66A1-497E-8512-90756E1E9A78}"/>
               </a:ext>
             </a:extLst>
           </p:cNvPr>
@@ -7316,7 +8234,7 @@
           <p:cNvPr id="28" name="">
             <a:extLst xmlns:a="http://schemas.openxmlformats.org/drawingml/2006/main">
               <a:ext uri="{FF2B5EF4-FFF2-40B4-BE49-F238E27FC236}">
-                <a16:creationId xmlns:a16="http://schemas.microsoft.com/office/drawing/2014/main" id="{92EEAED6-C324-4691-B5E6-2610E6D899D9}"/>
+                <a16:creationId xmlns:a16="http://schemas.microsoft.com/office/drawing/2014/main" id="{381220B8-F11D-4F05-A924-C12060C9D80F}"/>
               </a:ext>
             </a:extLst>
           </p:cNvPr>
@@ -7373,7 +8291,7 @@
           <p:cNvPr id="29" name="">
             <a:extLst xmlns:a="http://schemas.openxmlformats.org/drawingml/2006/main">
               <a:ext uri="{FF2B5EF4-FFF2-40B4-BE49-F238E27FC236}">
-                <a16:creationId xmlns:a16="http://schemas.microsoft.com/office/drawing/2014/main" id="{09DCDEB2-EE5B-4237-8F9C-FB94654B935D}"/>
+                <a16:creationId xmlns:a16="http://schemas.microsoft.com/office/drawing/2014/main" id="{5DA4F1CC-C6D1-4787-A48F-7672EAB2398F}"/>
               </a:ext>
             </a:extLst>
           </p:cNvPr>
@@ -7428,7 +8346,7 @@
     </p:spTree>
     <p:extLst>
       <p:ext uri="{BB962C8B-B14F-4D97-AF65-F5344CB8AC3E}">
-        <p14:creationId xmlns:p14="http://schemas.microsoft.com/office/powerpoint/2010/main" val="774048745"/>
+        <p14:creationId xmlns:p14="http://schemas.microsoft.com/office/powerpoint/2010/main" val="863607487"/>
       </p:ext>
     </p:extLst>
   </p:cSld>
@@ -7459,7 +8377,7 @@
           <p:cNvPr id="29" name="">
             <a:extLst xmlns:a="http://schemas.openxmlformats.org/drawingml/2006/main">
               <a:ext uri="{FF2B5EF4-FFF2-40B4-BE49-F238E27FC236}">
-                <a16:creationId xmlns:a16="http://schemas.microsoft.com/office/drawing/2014/main" id="{43B31247-945E-4F3D-A1BC-5599B4E7FED7}"/>
+                <a16:creationId xmlns:a16="http://schemas.microsoft.com/office/drawing/2014/main" id="{01F8F576-40D6-4562-9454-12CB6FC2C543}"/>
               </a:ext>
             </a:extLst>
           </p:cNvPr>
@@ -7489,7 +8407,7 @@
           <p:cNvPr id="2" name="">
             <a:extLst xmlns:a="http://schemas.openxmlformats.org/drawingml/2006/main">
               <a:ext uri="{FF2B5EF4-FFF2-40B4-BE49-F238E27FC236}">
-                <a16:creationId xmlns:a16="http://schemas.microsoft.com/office/drawing/2014/main" id="{78E57E76-B0DC-4828-8C22-656132FCE695}"/>
+                <a16:creationId xmlns:a16="http://schemas.microsoft.com/office/drawing/2014/main" id="{113FA5FA-5E1C-4FF1-AA8A-372496FC11E7}"/>
               </a:ext>
             </a:extLst>
           </p:cNvPr>
@@ -7546,7 +8464,7 @@
           <p:cNvPr id="3" name="">
             <a:extLst xmlns:a="http://schemas.openxmlformats.org/drawingml/2006/main">
               <a:ext uri="{FF2B5EF4-FFF2-40B4-BE49-F238E27FC236}">
-                <a16:creationId xmlns:a16="http://schemas.microsoft.com/office/drawing/2014/main" id="{C4FEF54D-C111-4C34-B8B2-875993343107}"/>
+                <a16:creationId xmlns:a16="http://schemas.microsoft.com/office/drawing/2014/main" id="{4603D017-31D8-456A-A6DA-2A57E3506E78}"/>
               </a:ext>
             </a:extLst>
           </p:cNvPr>
@@ -7576,7 +8494,7 @@
           <p:cNvPr id="4" name="">
             <a:extLst xmlns:a="http://schemas.openxmlformats.org/drawingml/2006/main">
               <a:ext uri="{FF2B5EF4-FFF2-40B4-BE49-F238E27FC236}">
-                <a16:creationId xmlns:a16="http://schemas.microsoft.com/office/drawing/2014/main" id="{BA5DC5E1-CFCF-49B3-BEBA-DA725071118B}"/>
+                <a16:creationId xmlns:a16="http://schemas.microsoft.com/office/drawing/2014/main" id="{4E7DAD78-B937-468E-9838-878D038EF0C3}"/>
               </a:ext>
             </a:extLst>
           </p:cNvPr>
@@ -7633,7 +8551,7 @@
           <p:cNvPr id="5" name="">
             <a:extLst xmlns:a="http://schemas.openxmlformats.org/drawingml/2006/main">
               <a:ext uri="{FF2B5EF4-FFF2-40B4-BE49-F238E27FC236}">
-                <a16:creationId xmlns:a16="http://schemas.microsoft.com/office/drawing/2014/main" id="{665E53AE-C34D-4F74-B4CA-E356168EEE29}"/>
+                <a16:creationId xmlns:a16="http://schemas.microsoft.com/office/drawing/2014/main" id="{DBEC53BB-2846-4A26-84D4-C3903796E74F}"/>
               </a:ext>
             </a:extLst>
           </p:cNvPr>
@@ -7663,7 +8581,7 @@
           <p:cNvPr id="6" name="">
             <a:extLst xmlns:a="http://schemas.openxmlformats.org/drawingml/2006/main">
               <a:ext uri="{FF2B5EF4-FFF2-40B4-BE49-F238E27FC236}">
-                <a16:creationId xmlns:a16="http://schemas.microsoft.com/office/drawing/2014/main" id="{1AF66A5E-F38E-4E29-B77E-5946FAEEBA74}"/>
+                <a16:creationId xmlns:a16="http://schemas.microsoft.com/office/drawing/2014/main" id="{EBE31559-B083-414C-9FDC-22DFED4DDA12}"/>
               </a:ext>
             </a:extLst>
           </p:cNvPr>
@@ -7720,7 +8638,7 @@
           <p:cNvPr id="7" name="">
             <a:extLst xmlns:a="http://schemas.openxmlformats.org/drawingml/2006/main">
               <a:ext uri="{FF2B5EF4-FFF2-40B4-BE49-F238E27FC236}">
-                <a16:creationId xmlns:a16="http://schemas.microsoft.com/office/drawing/2014/main" id="{6E5F1C94-8389-43E0-8078-502A6ADFF2DC}"/>
+                <a16:creationId xmlns:a16="http://schemas.microsoft.com/office/drawing/2014/main" id="{889B43F8-97D6-4136-8D6D-020E8765BFB1}"/>
               </a:ext>
             </a:extLst>
           </p:cNvPr>
@@ -7750,7 +8668,7 @@
           <p:cNvPr id="8" name="">
             <a:extLst xmlns:a="http://schemas.openxmlformats.org/drawingml/2006/main">
               <a:ext uri="{FF2B5EF4-FFF2-40B4-BE49-F238E27FC236}">
-                <a16:creationId xmlns:a16="http://schemas.microsoft.com/office/drawing/2014/main" id="{18BA3832-E383-4B5D-BABA-831E45E509F4}"/>
+                <a16:creationId xmlns:a16="http://schemas.microsoft.com/office/drawing/2014/main" id="{D242D444-9EB3-4F33-AB01-C15AD766E1DD}"/>
               </a:ext>
             </a:extLst>
           </p:cNvPr>
@@ -7807,7 +8725,7 @@
           <p:cNvPr id="9" name="">
             <a:extLst xmlns:a="http://schemas.openxmlformats.org/drawingml/2006/main">
               <a:ext uri="{FF2B5EF4-FFF2-40B4-BE49-F238E27FC236}">
-                <a16:creationId xmlns:a16="http://schemas.microsoft.com/office/drawing/2014/main" id="{79D57F8D-2C1C-4DCF-98E6-37AAB7193931}"/>
+                <a16:creationId xmlns:a16="http://schemas.microsoft.com/office/drawing/2014/main" id="{3E52B2FF-493C-4DD7-AA94-3432DA12274B}"/>
               </a:ext>
             </a:extLst>
           </p:cNvPr>
@@ -7837,7 +8755,7 @@
           <p:cNvPr id="10" name="">
             <a:extLst xmlns:a="http://schemas.openxmlformats.org/drawingml/2006/main">
               <a:ext uri="{FF2B5EF4-FFF2-40B4-BE49-F238E27FC236}">
-                <a16:creationId xmlns:a16="http://schemas.microsoft.com/office/drawing/2014/main" id="{412DBF04-D8E1-4695-A9A8-8C1108A2DB51}"/>
+                <a16:creationId xmlns:a16="http://schemas.microsoft.com/office/drawing/2014/main" id="{F8253011-0DA3-418B-B9EC-C732CBBE5D50}"/>
               </a:ext>
             </a:extLst>
           </p:cNvPr>
@@ -7894,7 +8812,7 @@
           <p:cNvPr id="11" name="">
             <a:extLst xmlns:a="http://schemas.openxmlformats.org/drawingml/2006/main">
               <a:ext uri="{FF2B5EF4-FFF2-40B4-BE49-F238E27FC236}">
-                <a16:creationId xmlns:a16="http://schemas.microsoft.com/office/drawing/2014/main" id="{458C3C24-3DB7-4F62-8901-288F8D98E400}"/>
+                <a16:creationId xmlns:a16="http://schemas.microsoft.com/office/drawing/2014/main" id="{681223D0-E5AB-4313-AA47-A04B5CB1EE61}"/>
               </a:ext>
             </a:extLst>
           </p:cNvPr>
@@ -7951,7 +8869,7 @@
           <p:cNvPr id="12" name="">
             <a:extLst xmlns:a="http://schemas.openxmlformats.org/drawingml/2006/main">
               <a:ext uri="{FF2B5EF4-FFF2-40B4-BE49-F238E27FC236}">
-                <a16:creationId xmlns:a16="http://schemas.microsoft.com/office/drawing/2014/main" id="{997A6923-A248-4A8B-8097-504449042804}"/>
+                <a16:creationId xmlns:a16="http://schemas.microsoft.com/office/drawing/2014/main" id="{6FE7FE4A-311B-4972-80C7-AAF4F6FD0A66}"/>
               </a:ext>
             </a:extLst>
           </p:cNvPr>
@@ -8008,7 +8926,7 @@
           <p:cNvPr id="13" name="">
             <a:extLst xmlns:a="http://schemas.openxmlformats.org/drawingml/2006/main">
               <a:ext uri="{FF2B5EF4-FFF2-40B4-BE49-F238E27FC236}">
-                <a16:creationId xmlns:a16="http://schemas.microsoft.com/office/drawing/2014/main" id="{CD044AFE-F59C-4F17-B76F-D932DC890A1F}"/>
+                <a16:creationId xmlns:a16="http://schemas.microsoft.com/office/drawing/2014/main" id="{00CD59A0-D0D3-4FD4-B6F6-86CEC2B5B71A}"/>
               </a:ext>
             </a:extLst>
           </p:cNvPr>
@@ -8065,7 +8983,7 @@
           <p:cNvPr id="14" name="">
             <a:extLst xmlns:a="http://schemas.openxmlformats.org/drawingml/2006/main">
               <a:ext uri="{FF2B5EF4-FFF2-40B4-BE49-F238E27FC236}">
-                <a16:creationId xmlns:a16="http://schemas.microsoft.com/office/drawing/2014/main" id="{0697F50C-27EA-48F5-8B56-18C3DD3A18F3}"/>
+                <a16:creationId xmlns:a16="http://schemas.microsoft.com/office/drawing/2014/main" id="{5E623D4E-1386-4D6E-9090-ECB1796B6D0F}"/>
               </a:ext>
             </a:extLst>
           </p:cNvPr>
@@ -8097,7 +9015,7 @@
           <p:cNvPr id="15" name="">
             <a:extLst xmlns:a="http://schemas.openxmlformats.org/drawingml/2006/main">
               <a:ext uri="{FF2B5EF4-FFF2-40B4-BE49-F238E27FC236}">
-                <a16:creationId xmlns:a16="http://schemas.microsoft.com/office/drawing/2014/main" id="{29EC72A4-A38B-4936-80F5-3C6343DD46EB}"/>
+                <a16:creationId xmlns:a16="http://schemas.microsoft.com/office/drawing/2014/main" id="{6397D189-71BA-4986-8D68-07D8B682AB4D}"/>
               </a:ext>
             </a:extLst>
           </p:cNvPr>
@@ -8127,7 +9045,7 @@
           <p:cNvPr id="16" name="">
             <a:extLst xmlns:a="http://schemas.openxmlformats.org/drawingml/2006/main">
               <a:ext uri="{FF2B5EF4-FFF2-40B4-BE49-F238E27FC236}">
-                <a16:creationId xmlns:a16="http://schemas.microsoft.com/office/drawing/2014/main" id="{570C9158-5EFC-4E45-B74A-78CD49D604FA}"/>
+                <a16:creationId xmlns:a16="http://schemas.microsoft.com/office/drawing/2014/main" id="{97EC65EA-6AA1-467B-9A3E-9800859F3E6F}"/>
               </a:ext>
             </a:extLst>
           </p:cNvPr>
@@ -8184,7 +9102,7 @@
           <p:cNvPr id="17" name="">
             <a:extLst xmlns:a="http://schemas.openxmlformats.org/drawingml/2006/main">
               <a:ext uri="{FF2B5EF4-FFF2-40B4-BE49-F238E27FC236}">
-                <a16:creationId xmlns:a16="http://schemas.microsoft.com/office/drawing/2014/main" id="{D9681703-9728-4D06-9639-230EFFA5679F}"/>
+                <a16:creationId xmlns:a16="http://schemas.microsoft.com/office/drawing/2014/main" id="{40325BFA-0D69-4AD6-91C1-3D52BE91B68A}"/>
               </a:ext>
             </a:extLst>
           </p:cNvPr>
@@ -8264,7 +9182,7 @@
           <p:cNvPr id="18" name="">
             <a:extLst xmlns:a="http://schemas.openxmlformats.org/drawingml/2006/main">
               <a:ext uri="{FF2B5EF4-FFF2-40B4-BE49-F238E27FC236}">
-                <a16:creationId xmlns:a16="http://schemas.microsoft.com/office/drawing/2014/main" id="{A2177D58-915A-4696-90DC-372CA8F2F772}"/>
+                <a16:creationId xmlns:a16="http://schemas.microsoft.com/office/drawing/2014/main" id="{826E8923-FC34-421B-9522-31C600C364E9}"/>
               </a:ext>
             </a:extLst>
           </p:cNvPr>
@@ -8294,7 +9212,7 @@
           <p:cNvPr id="19" name="">
             <a:extLst xmlns:a="http://schemas.openxmlformats.org/drawingml/2006/main">
               <a:ext uri="{FF2B5EF4-FFF2-40B4-BE49-F238E27FC236}">
-                <a16:creationId xmlns:a16="http://schemas.microsoft.com/office/drawing/2014/main" id="{A49C6DAC-6EAC-400C-A563-F3CC051EFEFD}"/>
+                <a16:creationId xmlns:a16="http://schemas.microsoft.com/office/drawing/2014/main" id="{B3AFC341-EC91-427B-BA4C-E6DFA007DD84}"/>
               </a:ext>
             </a:extLst>
           </p:cNvPr>
@@ -8326,7 +9244,7 @@
           <p:cNvPr id="20" name="">
             <a:extLst xmlns:a="http://schemas.openxmlformats.org/drawingml/2006/main">
               <a:ext uri="{FF2B5EF4-FFF2-40B4-BE49-F238E27FC236}">
-                <a16:creationId xmlns:a16="http://schemas.microsoft.com/office/drawing/2014/main" id="{FCD6F791-C9D1-40F7-908E-19402764C0CC}"/>
+                <a16:creationId xmlns:a16="http://schemas.microsoft.com/office/drawing/2014/main" id="{0086B103-128B-40FC-A3B3-4BF51727276C}"/>
               </a:ext>
             </a:extLst>
           </p:cNvPr>
@@ -8356,7 +9274,7 @@
           <p:cNvPr id="21" name="">
             <a:extLst xmlns:a="http://schemas.openxmlformats.org/drawingml/2006/main">
               <a:ext uri="{FF2B5EF4-FFF2-40B4-BE49-F238E27FC236}">
-                <a16:creationId xmlns:a16="http://schemas.microsoft.com/office/drawing/2014/main" id="{28C27A6F-4FCB-4082-A0EE-7F8065F75352}"/>
+                <a16:creationId xmlns:a16="http://schemas.microsoft.com/office/drawing/2014/main" id="{5ED353FF-4F78-475B-AAF9-A9A1D1456A30}"/>
               </a:ext>
             </a:extLst>
           </p:cNvPr>
@@ -8413,7 +9331,7 @@
           <p:cNvPr id="22" name="">
             <a:extLst xmlns:a="http://schemas.openxmlformats.org/drawingml/2006/main">
               <a:ext uri="{FF2B5EF4-FFF2-40B4-BE49-F238E27FC236}">
-                <a16:creationId xmlns:a16="http://schemas.microsoft.com/office/drawing/2014/main" id="{A609EFB6-6CA9-47CA-AF04-01E1F96B3838}"/>
+                <a16:creationId xmlns:a16="http://schemas.microsoft.com/office/drawing/2014/main" id="{A34C1AB8-D5F9-439E-8B76-B12CF934E0C4}"/>
               </a:ext>
             </a:extLst>
           </p:cNvPr>
@@ -8470,7 +9388,7 @@
           <p:cNvPr id="23" name="">
             <a:extLst xmlns:a="http://schemas.openxmlformats.org/drawingml/2006/main">
               <a:ext uri="{FF2B5EF4-FFF2-40B4-BE49-F238E27FC236}">
-                <a16:creationId xmlns:a16="http://schemas.microsoft.com/office/drawing/2014/main" id="{413F9202-8F64-4A4D-9FEE-3210B549C66E}"/>
+                <a16:creationId xmlns:a16="http://schemas.microsoft.com/office/drawing/2014/main" id="{AC21DF5B-29B4-47B3-80BA-F36CA384AEC3}"/>
               </a:ext>
             </a:extLst>
           </p:cNvPr>
@@ -8500,7 +9418,7 @@
           <p:cNvPr id="24" name="">
             <a:extLst xmlns:a="http://schemas.openxmlformats.org/drawingml/2006/main">
               <a:ext uri="{FF2B5EF4-FFF2-40B4-BE49-F238E27FC236}">
-                <a16:creationId xmlns:a16="http://schemas.microsoft.com/office/drawing/2014/main" id="{BB8711D6-1AFD-4106-9596-04A8E02EF1CA}"/>
+                <a16:creationId xmlns:a16="http://schemas.microsoft.com/office/drawing/2014/main" id="{EC711022-20B3-4E32-BF6F-C2E317706906}"/>
               </a:ext>
             </a:extLst>
           </p:cNvPr>
@@ -8532,7 +9450,7 @@
           <p:cNvPr id="25" name="">
             <a:extLst xmlns:a="http://schemas.openxmlformats.org/drawingml/2006/main">
               <a:ext uri="{FF2B5EF4-FFF2-40B4-BE49-F238E27FC236}">
-                <a16:creationId xmlns:a16="http://schemas.microsoft.com/office/drawing/2014/main" id="{A40E2E35-B88B-4B43-A54C-AF37DAB2EDC6}"/>
+                <a16:creationId xmlns:a16="http://schemas.microsoft.com/office/drawing/2014/main" id="{1AE1A014-73BE-41A1-8F8B-B786C855C69E}"/>
               </a:ext>
             </a:extLst>
           </p:cNvPr>
@@ -8562,7 +9480,7 @@
           <p:cNvPr id="26" name="">
             <a:extLst xmlns:a="http://schemas.openxmlformats.org/drawingml/2006/main">
               <a:ext uri="{FF2B5EF4-FFF2-40B4-BE49-F238E27FC236}">
-                <a16:creationId xmlns:a16="http://schemas.microsoft.com/office/drawing/2014/main" id="{5FCBAE87-1FFA-482D-B7B7-6E07E50DA5F9}"/>
+                <a16:creationId xmlns:a16="http://schemas.microsoft.com/office/drawing/2014/main" id="{DFAD1639-C744-4677-847F-5DC4F45AEC55}"/>
               </a:ext>
             </a:extLst>
           </p:cNvPr>
@@ -8619,7 +9537,7 @@
           <p:cNvPr id="27" name="">
             <a:extLst xmlns:a="http://schemas.openxmlformats.org/drawingml/2006/main">
               <a:ext uri="{FF2B5EF4-FFF2-40B4-BE49-F238E27FC236}">
-                <a16:creationId xmlns:a16="http://schemas.microsoft.com/office/drawing/2014/main" id="{6778B403-7634-4692-9220-8D52934667B7}"/>
+                <a16:creationId xmlns:a16="http://schemas.microsoft.com/office/drawing/2014/main" id="{77284CEF-9903-4404-8899-910055772F5A}"/>
               </a:ext>
             </a:extLst>
           </p:cNvPr>
@@ -8699,7 +9617,7 @@
           <p:cNvPr id="28" name="">
             <a:extLst xmlns:a="http://schemas.openxmlformats.org/drawingml/2006/main">
               <a:ext uri="{FF2B5EF4-FFF2-40B4-BE49-F238E27FC236}">
-                <a16:creationId xmlns:a16="http://schemas.microsoft.com/office/drawing/2014/main" id="{00A1E8C2-3E3C-41F0-BC59-BA5EB3D763FE}"/>
+                <a16:creationId xmlns:a16="http://schemas.microsoft.com/office/drawing/2014/main" id="{CFE51F51-4690-475D-BB4F-983DFD6BABA0}"/>
               </a:ext>
             </a:extLst>
           </p:cNvPr>
@@ -8754,7 +9672,7 @@
     </p:spTree>
     <p:extLst>
       <p:ext uri="{BB962C8B-B14F-4D97-AF65-F5344CB8AC3E}">
-        <p14:creationId xmlns:p14="http://schemas.microsoft.com/office/powerpoint/2010/main" val="1206414069"/>
+        <p14:creationId xmlns:p14="http://schemas.microsoft.com/office/powerpoint/2010/main" val="2083639057"/>
       </p:ext>
     </p:extLst>
   </p:cSld>
@@ -8785,7 +9703,7 @@
           <p:cNvPr id="24" name="">
             <a:extLst xmlns:a="http://schemas.openxmlformats.org/drawingml/2006/main">
               <a:ext uri="{FF2B5EF4-FFF2-40B4-BE49-F238E27FC236}">
-                <a16:creationId xmlns:a16="http://schemas.microsoft.com/office/drawing/2014/main" id="{8A02A518-5974-4761-A65F-F6CD074037B4}"/>
+                <a16:creationId xmlns:a16="http://schemas.microsoft.com/office/drawing/2014/main" id="{90B0FFFA-79D6-4C0A-B29D-6CD7C7DDD619}"/>
               </a:ext>
             </a:extLst>
           </p:cNvPr>
@@ -8815,7 +9733,7 @@
           <p:cNvPr id="2" name="">
             <a:extLst xmlns:a="http://schemas.openxmlformats.org/drawingml/2006/main">
               <a:ext uri="{FF2B5EF4-FFF2-40B4-BE49-F238E27FC236}">
-                <a16:creationId xmlns:a16="http://schemas.microsoft.com/office/drawing/2014/main" id="{A00870FD-814F-4FD9-8EA9-1DFDAA01758A}"/>
+                <a16:creationId xmlns:a16="http://schemas.microsoft.com/office/drawing/2014/main" id="{320E5ED0-19EC-4AA0-9E97-A7A5B3362730}"/>
               </a:ext>
             </a:extLst>
           </p:cNvPr>
@@ -8872,7 +9790,7 @@
           <p:cNvPr id="3" name="">
             <a:extLst xmlns:a="http://schemas.openxmlformats.org/drawingml/2006/main">
               <a:ext uri="{FF2B5EF4-FFF2-40B4-BE49-F238E27FC236}">
-                <a16:creationId xmlns:a16="http://schemas.microsoft.com/office/drawing/2014/main" id="{D0F3EDB7-33AA-43CC-AD99-D3899B49D9E5}"/>
+                <a16:creationId xmlns:a16="http://schemas.microsoft.com/office/drawing/2014/main" id="{7C8A21C4-F017-4A7E-9B23-673B6B040AAF}"/>
               </a:ext>
             </a:extLst>
           </p:cNvPr>
@@ -8902,7 +9820,7 @@
           <p:cNvPr id="4" name="">
             <a:extLst xmlns:a="http://schemas.openxmlformats.org/drawingml/2006/main">
               <a:ext uri="{FF2B5EF4-FFF2-40B4-BE49-F238E27FC236}">
-                <a16:creationId xmlns:a16="http://schemas.microsoft.com/office/drawing/2014/main" id="{31B26490-0EED-46B9-9168-5EF16A8FAA56}"/>
+                <a16:creationId xmlns:a16="http://schemas.microsoft.com/office/drawing/2014/main" id="{C79A775E-D5A6-46E8-AD05-3394C0DC6BA9}"/>
               </a:ext>
             </a:extLst>
           </p:cNvPr>
@@ -8959,7 +9877,7 @@
           <p:cNvPr id="5" name="">
             <a:extLst xmlns:a="http://schemas.openxmlformats.org/drawingml/2006/main">
               <a:ext uri="{FF2B5EF4-FFF2-40B4-BE49-F238E27FC236}">
-                <a16:creationId xmlns:a16="http://schemas.microsoft.com/office/drawing/2014/main" id="{385F56B0-7211-4A9F-9BB1-C82D7F4198A7}"/>
+                <a16:creationId xmlns:a16="http://schemas.microsoft.com/office/drawing/2014/main" id="{F013351E-255C-409C-B6BC-73B1045AA02F}"/>
               </a:ext>
             </a:extLst>
           </p:cNvPr>
@@ -8989,7 +9907,7 @@
           <p:cNvPr id="6" name="">
             <a:extLst xmlns:a="http://schemas.openxmlformats.org/drawingml/2006/main">
               <a:ext uri="{FF2B5EF4-FFF2-40B4-BE49-F238E27FC236}">
-                <a16:creationId xmlns:a16="http://schemas.microsoft.com/office/drawing/2014/main" id="{8E0879F9-5D9D-4122-9255-DE213D5347FF}"/>
+                <a16:creationId xmlns:a16="http://schemas.microsoft.com/office/drawing/2014/main" id="{57E51A0D-B4D7-4A1E-8B88-32B4E63EA6F5}"/>
               </a:ext>
             </a:extLst>
           </p:cNvPr>
@@ -9046,7 +9964,7 @@
           <p:cNvPr id="7" name="">
             <a:extLst xmlns:a="http://schemas.openxmlformats.org/drawingml/2006/main">
               <a:ext uri="{FF2B5EF4-FFF2-40B4-BE49-F238E27FC236}">
-                <a16:creationId xmlns:a16="http://schemas.microsoft.com/office/drawing/2014/main" id="{EC1F0D41-FB65-4B40-A340-C27A2F09969C}"/>
+                <a16:creationId xmlns:a16="http://schemas.microsoft.com/office/drawing/2014/main" id="{F47CDD09-3AA1-4D7D-81D3-B558646380B7}"/>
               </a:ext>
             </a:extLst>
           </p:cNvPr>
@@ -9076,7 +9994,7 @@
           <p:cNvPr id="8" name="">
             <a:extLst xmlns:a="http://schemas.openxmlformats.org/drawingml/2006/main">
               <a:ext uri="{FF2B5EF4-FFF2-40B4-BE49-F238E27FC236}">
-                <a16:creationId xmlns:a16="http://schemas.microsoft.com/office/drawing/2014/main" id="{ECA25FB7-173A-4CA7-AAD9-53AF9106FEE4}"/>
+                <a16:creationId xmlns:a16="http://schemas.microsoft.com/office/drawing/2014/main" id="{B3D340EC-A91A-48EF-9A15-B416F88BFCE2}"/>
               </a:ext>
             </a:extLst>
           </p:cNvPr>
@@ -9133,7 +10051,7 @@
           <p:cNvPr id="9" name="">
             <a:extLst xmlns:a="http://schemas.openxmlformats.org/drawingml/2006/main">
               <a:ext uri="{FF2B5EF4-FFF2-40B4-BE49-F238E27FC236}">
-                <a16:creationId xmlns:a16="http://schemas.microsoft.com/office/drawing/2014/main" id="{2149E1C7-E2CB-47CC-BCFE-ACAEA7FB8AA6}"/>
+                <a16:creationId xmlns:a16="http://schemas.microsoft.com/office/drawing/2014/main" id="{1568B199-5306-4755-9477-D883B222AE72}"/>
               </a:ext>
             </a:extLst>
           </p:cNvPr>
@@ -9163,7 +10081,7 @@
           <p:cNvPr id="10" name="">
             <a:extLst xmlns:a="http://schemas.openxmlformats.org/drawingml/2006/main">
               <a:ext uri="{FF2B5EF4-FFF2-40B4-BE49-F238E27FC236}">
-                <a16:creationId xmlns:a16="http://schemas.microsoft.com/office/drawing/2014/main" id="{E8908246-50DD-4457-9658-2C4D5128B8CE}"/>
+                <a16:creationId xmlns:a16="http://schemas.microsoft.com/office/drawing/2014/main" id="{97CC9689-9A92-41DA-BC32-B7C1BC7CCFE9}"/>
               </a:ext>
             </a:extLst>
           </p:cNvPr>
@@ -9220,7 +10138,7 @@
           <p:cNvPr id="11" name="">
             <a:extLst xmlns:a="http://schemas.openxmlformats.org/drawingml/2006/main">
               <a:ext uri="{FF2B5EF4-FFF2-40B4-BE49-F238E27FC236}">
-                <a16:creationId xmlns:a16="http://schemas.microsoft.com/office/drawing/2014/main" id="{CC225B55-8CFC-4F47-B6B1-9C9C460D3740}"/>
+                <a16:creationId xmlns:a16="http://schemas.microsoft.com/office/drawing/2014/main" id="{7368C505-D842-4949-88E0-B593315D7E0E}"/>
               </a:ext>
             </a:extLst>
           </p:cNvPr>
@@ -9277,7 +10195,7 @@
           <p:cNvPr id="12" name="">
             <a:extLst xmlns:a="http://schemas.openxmlformats.org/drawingml/2006/main">
               <a:ext uri="{FF2B5EF4-FFF2-40B4-BE49-F238E27FC236}">
-                <a16:creationId xmlns:a16="http://schemas.microsoft.com/office/drawing/2014/main" id="{FC2B94C8-CD94-4B07-ABEC-B5A98900CE20}"/>
+                <a16:creationId xmlns:a16="http://schemas.microsoft.com/office/drawing/2014/main" id="{7ACEE59B-B686-40C3-8FCA-66CAE375B7C1}"/>
               </a:ext>
             </a:extLst>
           </p:cNvPr>
@@ -9334,7 +10252,7 @@
           <p:cNvPr id="13" name="">
             <a:extLst xmlns:a="http://schemas.openxmlformats.org/drawingml/2006/main">
               <a:ext uri="{FF2B5EF4-FFF2-40B4-BE49-F238E27FC236}">
-                <a16:creationId xmlns:a16="http://schemas.microsoft.com/office/drawing/2014/main" id="{6F494B29-9043-4090-B951-CE2E212831E8}"/>
+                <a16:creationId xmlns:a16="http://schemas.microsoft.com/office/drawing/2014/main" id="{C8066DDC-D709-4F1E-920B-B4477D8D6B8B}"/>
               </a:ext>
             </a:extLst>
           </p:cNvPr>
@@ -9391,7 +10309,7 @@
           <p:cNvPr id="14" name="">
             <a:extLst xmlns:a="http://schemas.openxmlformats.org/drawingml/2006/main">
               <a:ext uri="{FF2B5EF4-FFF2-40B4-BE49-F238E27FC236}">
-                <a16:creationId xmlns:a16="http://schemas.microsoft.com/office/drawing/2014/main" id="{6961F733-2CF3-4A0F-A91C-05E4FD660B35}"/>
+                <a16:creationId xmlns:a16="http://schemas.microsoft.com/office/drawing/2014/main" id="{B3FB65B4-2F74-42D6-886A-F95628DD2FE0}"/>
               </a:ext>
             </a:extLst>
           </p:cNvPr>
@@ -9423,7 +10341,7 @@
           <p:cNvPr id="15" name="">
             <a:extLst xmlns:a="http://schemas.openxmlformats.org/drawingml/2006/main">
               <a:ext uri="{FF2B5EF4-FFF2-40B4-BE49-F238E27FC236}">
-                <a16:creationId xmlns:a16="http://schemas.microsoft.com/office/drawing/2014/main" id="{CF058983-C62F-40B9-9D7A-8DFA7FBE9501}"/>
+                <a16:creationId xmlns:a16="http://schemas.microsoft.com/office/drawing/2014/main" id="{1C02ADF6-CF49-4CEF-B928-B019F2449EA0}"/>
               </a:ext>
             </a:extLst>
           </p:cNvPr>
@@ -9453,7 +10371,7 @@
           <p:cNvPr id="16" name="">
             <a:extLst xmlns:a="http://schemas.openxmlformats.org/drawingml/2006/main">
               <a:ext uri="{FF2B5EF4-FFF2-40B4-BE49-F238E27FC236}">
-                <a16:creationId xmlns:a16="http://schemas.microsoft.com/office/drawing/2014/main" id="{4FDA241A-8BAB-47E0-B138-82864741D1D7}"/>
+                <a16:creationId xmlns:a16="http://schemas.microsoft.com/office/drawing/2014/main" id="{EC5557B7-D3AE-4C82-8B23-F48736685AFA}"/>
               </a:ext>
             </a:extLst>
           </p:cNvPr>
@@ -9510,7 +10428,7 @@
           <p:cNvPr id="17" name="">
             <a:extLst xmlns:a="http://schemas.openxmlformats.org/drawingml/2006/main">
               <a:ext uri="{FF2B5EF4-FFF2-40B4-BE49-F238E27FC236}">
-                <a16:creationId xmlns:a16="http://schemas.microsoft.com/office/drawing/2014/main" id="{DEF95A86-D7D5-4B30-9D88-25A353D99864}"/>
+                <a16:creationId xmlns:a16="http://schemas.microsoft.com/office/drawing/2014/main" id="{5281846B-1FF8-40FA-90A0-92EC8F321EBC}"/>
               </a:ext>
             </a:extLst>
           </p:cNvPr>
@@ -9590,7 +10508,7 @@
           <p:cNvPr id="18" name="">
             <a:extLst xmlns:a="http://schemas.openxmlformats.org/drawingml/2006/main">
               <a:ext uri="{FF2B5EF4-FFF2-40B4-BE49-F238E27FC236}">
-                <a16:creationId xmlns:a16="http://schemas.microsoft.com/office/drawing/2014/main" id="{C46A6636-6413-4ADC-B4AE-A2CA9A9CA313}"/>
+                <a16:creationId xmlns:a16="http://schemas.microsoft.com/office/drawing/2014/main" id="{7339C89B-7DF6-4D22-BEF4-D1A5EA511661}"/>
               </a:ext>
             </a:extLst>
           </p:cNvPr>
@@ -9622,7 +10540,7 @@
           <p:cNvPr id="19" name="">
             <a:extLst xmlns:a="http://schemas.openxmlformats.org/drawingml/2006/main">
               <a:ext uri="{FF2B5EF4-FFF2-40B4-BE49-F238E27FC236}">
-                <a16:creationId xmlns:a16="http://schemas.microsoft.com/office/drawing/2014/main" id="{3E49CAF2-FFBC-48D2-A299-15ED082D6500}"/>
+                <a16:creationId xmlns:a16="http://schemas.microsoft.com/office/drawing/2014/main" id="{EAB28CA0-9BC3-4B3B-A3D1-DC3704B3E020}"/>
               </a:ext>
             </a:extLst>
           </p:cNvPr>
@@ -9652,7 +10570,7 @@
           <p:cNvPr id="20" name="">
             <a:extLst xmlns:a="http://schemas.openxmlformats.org/drawingml/2006/main">
               <a:ext uri="{FF2B5EF4-FFF2-40B4-BE49-F238E27FC236}">
-                <a16:creationId xmlns:a16="http://schemas.microsoft.com/office/drawing/2014/main" id="{8ECE4265-170B-4C56-B3EC-09A0E0F318CA}"/>
+                <a16:creationId xmlns:a16="http://schemas.microsoft.com/office/drawing/2014/main" id="{B34DC1DC-9429-4D56-AC81-29B67805416E}"/>
               </a:ext>
             </a:extLst>
           </p:cNvPr>
@@ -9709,7 +10627,7 @@
           <p:cNvPr id="21" name="">
             <a:extLst xmlns:a="http://schemas.openxmlformats.org/drawingml/2006/main">
               <a:ext uri="{FF2B5EF4-FFF2-40B4-BE49-F238E27FC236}">
-                <a16:creationId xmlns:a16="http://schemas.microsoft.com/office/drawing/2014/main" id="{28F4B798-106B-4277-9E3B-6C80DF70F7C1}"/>
+                <a16:creationId xmlns:a16="http://schemas.microsoft.com/office/drawing/2014/main" id="{3D31C170-F9A7-427C-9F19-26BD49395874}"/>
               </a:ext>
             </a:extLst>
           </p:cNvPr>
@@ -9766,7 +10684,7 @@
           <p:cNvPr id="22" name="">
             <a:extLst xmlns:a="http://schemas.openxmlformats.org/drawingml/2006/main">
               <a:ext uri="{FF2B5EF4-FFF2-40B4-BE49-F238E27FC236}">
-                <a16:creationId xmlns:a16="http://schemas.microsoft.com/office/drawing/2014/main" id="{AF71CD91-656F-4217-8A6A-44150768E92E}"/>
+                <a16:creationId xmlns:a16="http://schemas.microsoft.com/office/drawing/2014/main" id="{928BFE91-06C6-4D65-BEA7-23758888F470}"/>
               </a:ext>
             </a:extLst>
           </p:cNvPr>
@@ -9798,7 +10716,7 @@
           <p:cNvPr id="23" name="">
             <a:extLst xmlns:a="http://schemas.openxmlformats.org/drawingml/2006/main">
               <a:ext uri="{FF2B5EF4-FFF2-40B4-BE49-F238E27FC236}">
-                <a16:creationId xmlns:a16="http://schemas.microsoft.com/office/drawing/2014/main" id="{6E85E624-04C5-41F0-B053-EA48D972F712}"/>
+                <a16:creationId xmlns:a16="http://schemas.microsoft.com/office/drawing/2014/main" id="{6552D942-D7E0-4C0A-94B1-67816CB51B22}"/>
               </a:ext>
             </a:extLst>
           </p:cNvPr>
@@ -9853,7 +10771,7 @@
     </p:spTree>
     <p:extLst>
       <p:ext uri="{BB962C8B-B14F-4D97-AF65-F5344CB8AC3E}">
-        <p14:creationId xmlns:p14="http://schemas.microsoft.com/office/powerpoint/2010/main" val="1018127274"/>
+        <p14:creationId xmlns:p14="http://schemas.microsoft.com/office/powerpoint/2010/main" val="1173887764"/>
       </p:ext>
     </p:extLst>
   </p:cSld>
@@ -9884,7 +10802,7 @@
           <p:cNvPr id="33" name="">
             <a:extLst xmlns:a="http://schemas.openxmlformats.org/drawingml/2006/main">
               <a:ext uri="{FF2B5EF4-FFF2-40B4-BE49-F238E27FC236}">
-                <a16:creationId xmlns:a16="http://schemas.microsoft.com/office/drawing/2014/main" id="{08D0D9E6-C119-49DA-AEBF-06BF4F68576E}"/>
+                <a16:creationId xmlns:a16="http://schemas.microsoft.com/office/drawing/2014/main" id="{814F5B41-92E8-415D-BCD7-7B1A771BDBA0}"/>
               </a:ext>
             </a:extLst>
           </p:cNvPr>
@@ -9914,7 +10832,7 @@
           <p:cNvPr id="2" name="">
             <a:extLst xmlns:a="http://schemas.openxmlformats.org/drawingml/2006/main">
               <a:ext uri="{FF2B5EF4-FFF2-40B4-BE49-F238E27FC236}">
-                <a16:creationId xmlns:a16="http://schemas.microsoft.com/office/drawing/2014/main" id="{1CA33FD3-0C20-4B5F-AD10-2F4E302A94A0}"/>
+                <a16:creationId xmlns:a16="http://schemas.microsoft.com/office/drawing/2014/main" id="{3069E17D-38FE-4ECF-B0F7-40540BBB2329}"/>
               </a:ext>
             </a:extLst>
           </p:cNvPr>
@@ -9971,7 +10889,7 @@
           <p:cNvPr id="3" name="">
             <a:extLst xmlns:a="http://schemas.openxmlformats.org/drawingml/2006/main">
               <a:ext uri="{FF2B5EF4-FFF2-40B4-BE49-F238E27FC236}">
-                <a16:creationId xmlns:a16="http://schemas.microsoft.com/office/drawing/2014/main" id="{A8058090-7335-4BAD-90ED-EE35EA56399B}"/>
+                <a16:creationId xmlns:a16="http://schemas.microsoft.com/office/drawing/2014/main" id="{04B9DD13-4C63-434D-96A4-B88F5AFC111A}"/>
               </a:ext>
             </a:extLst>
           </p:cNvPr>
@@ -10001,7 +10919,7 @@
           <p:cNvPr id="4" name="">
             <a:extLst xmlns:a="http://schemas.openxmlformats.org/drawingml/2006/main">
               <a:ext uri="{FF2B5EF4-FFF2-40B4-BE49-F238E27FC236}">
-                <a16:creationId xmlns:a16="http://schemas.microsoft.com/office/drawing/2014/main" id="{977D0E81-C0DD-4765-874D-AED5BE337102}"/>
+                <a16:creationId xmlns:a16="http://schemas.microsoft.com/office/drawing/2014/main" id="{92696CC5-145D-4143-94B1-2BA2DB21B045}"/>
               </a:ext>
             </a:extLst>
           </p:cNvPr>
@@ -10058,7 +10976,7 @@
           <p:cNvPr id="5" name="">
             <a:extLst xmlns:a="http://schemas.openxmlformats.org/drawingml/2006/main">
               <a:ext uri="{FF2B5EF4-FFF2-40B4-BE49-F238E27FC236}">
-                <a16:creationId xmlns:a16="http://schemas.microsoft.com/office/drawing/2014/main" id="{1465AC72-5FF5-4D02-BEA8-0BCA8147CDEB}"/>
+                <a16:creationId xmlns:a16="http://schemas.microsoft.com/office/drawing/2014/main" id="{ACB9CCBC-D400-4834-B4DF-CA7F548E5E93}"/>
               </a:ext>
             </a:extLst>
           </p:cNvPr>
@@ -10088,7 +11006,7 @@
           <p:cNvPr id="6" name="">
             <a:extLst xmlns:a="http://schemas.openxmlformats.org/drawingml/2006/main">
               <a:ext uri="{FF2B5EF4-FFF2-40B4-BE49-F238E27FC236}">
-                <a16:creationId xmlns:a16="http://schemas.microsoft.com/office/drawing/2014/main" id="{CA021DBE-A865-495B-BB88-A0E315E0D4EF}"/>
+                <a16:creationId xmlns:a16="http://schemas.microsoft.com/office/drawing/2014/main" id="{350252BA-F19E-4382-89A5-A577A39CF4C0}"/>
               </a:ext>
             </a:extLst>
           </p:cNvPr>
@@ -10145,7 +11063,7 @@
           <p:cNvPr id="7" name="">
             <a:extLst xmlns:a="http://schemas.openxmlformats.org/drawingml/2006/main">
               <a:ext uri="{FF2B5EF4-FFF2-40B4-BE49-F238E27FC236}">
-                <a16:creationId xmlns:a16="http://schemas.microsoft.com/office/drawing/2014/main" id="{E304B2B6-4E29-467D-9032-BB25B696BCDF}"/>
+                <a16:creationId xmlns:a16="http://schemas.microsoft.com/office/drawing/2014/main" id="{8D1ABE1C-5CA8-40B2-B7F5-67EC9BA90630}"/>
               </a:ext>
             </a:extLst>
           </p:cNvPr>
@@ -10175,7 +11093,7 @@
           <p:cNvPr id="8" name="">
             <a:extLst xmlns:a="http://schemas.openxmlformats.org/drawingml/2006/main">
               <a:ext uri="{FF2B5EF4-FFF2-40B4-BE49-F238E27FC236}">
-                <a16:creationId xmlns:a16="http://schemas.microsoft.com/office/drawing/2014/main" id="{5EEF6F7E-B9CA-4B01-B45B-4462129EB101}"/>
+                <a16:creationId xmlns:a16="http://schemas.microsoft.com/office/drawing/2014/main" id="{2B1A004F-E273-4DD9-B297-CC71F4B18E3B}"/>
               </a:ext>
             </a:extLst>
           </p:cNvPr>
@@ -10232,7 +11150,7 @@
           <p:cNvPr id="9" name="">
             <a:extLst xmlns:a="http://schemas.openxmlformats.org/drawingml/2006/main">
               <a:ext uri="{FF2B5EF4-FFF2-40B4-BE49-F238E27FC236}">
-                <a16:creationId xmlns:a16="http://schemas.microsoft.com/office/drawing/2014/main" id="{5A40B7B5-F724-4647-9693-4DC839C6E9AE}"/>
+                <a16:creationId xmlns:a16="http://schemas.microsoft.com/office/drawing/2014/main" id="{C07ECD54-190D-45BE-9EF9-0FACF765C301}"/>
               </a:ext>
             </a:extLst>
           </p:cNvPr>
@@ -10262,7 +11180,7 @@
           <p:cNvPr id="10" name="">
             <a:extLst xmlns:a="http://schemas.openxmlformats.org/drawingml/2006/main">
               <a:ext uri="{FF2B5EF4-FFF2-40B4-BE49-F238E27FC236}">
-                <a16:creationId xmlns:a16="http://schemas.microsoft.com/office/drawing/2014/main" id="{57BC7D57-9E51-421A-A859-9CF5C3B326A6}"/>
+                <a16:creationId xmlns:a16="http://schemas.microsoft.com/office/drawing/2014/main" id="{AD417FAE-9AB1-46DC-96E5-ABE4670D19CF}"/>
               </a:ext>
             </a:extLst>
           </p:cNvPr>
@@ -10319,7 +11237,7 @@
           <p:cNvPr id="11" name="">
             <a:extLst xmlns:a="http://schemas.openxmlformats.org/drawingml/2006/main">
               <a:ext uri="{FF2B5EF4-FFF2-40B4-BE49-F238E27FC236}">
-                <a16:creationId xmlns:a16="http://schemas.microsoft.com/office/drawing/2014/main" id="{5D843792-F03A-420D-B378-8E66034A66AF}"/>
+                <a16:creationId xmlns:a16="http://schemas.microsoft.com/office/drawing/2014/main" id="{84EDBCF2-3351-4231-8DCE-B014A33DD033}"/>
               </a:ext>
             </a:extLst>
           </p:cNvPr>
@@ -10376,7 +11294,7 @@
           <p:cNvPr id="12" name="">
             <a:extLst xmlns:a="http://schemas.openxmlformats.org/drawingml/2006/main">
               <a:ext uri="{FF2B5EF4-FFF2-40B4-BE49-F238E27FC236}">
-                <a16:creationId xmlns:a16="http://schemas.microsoft.com/office/drawing/2014/main" id="{AB6BBB0F-E03D-4AFD-87D4-989BA17FC9CE}"/>
+                <a16:creationId xmlns:a16="http://schemas.microsoft.com/office/drawing/2014/main" id="{620D0AC5-7A23-4001-B815-D6BCE1438824}"/>
               </a:ext>
             </a:extLst>
           </p:cNvPr>
@@ -10433,7 +11351,7 @@
           <p:cNvPr id="13" name="">
             <a:extLst xmlns:a="http://schemas.openxmlformats.org/drawingml/2006/main">
               <a:ext uri="{FF2B5EF4-FFF2-40B4-BE49-F238E27FC236}">
-                <a16:creationId xmlns:a16="http://schemas.microsoft.com/office/drawing/2014/main" id="{470A070B-6899-4B88-AC0C-0465DFB99814}"/>
+                <a16:creationId xmlns:a16="http://schemas.microsoft.com/office/drawing/2014/main" id="{FF02F62A-8FD1-4022-9DA9-0FAA97AF6A47}"/>
               </a:ext>
             </a:extLst>
           </p:cNvPr>
@@ -10490,7 +11408,7 @@
           <p:cNvPr id="14" name="">
             <a:extLst xmlns:a="http://schemas.openxmlformats.org/drawingml/2006/main">
               <a:ext uri="{FF2B5EF4-FFF2-40B4-BE49-F238E27FC236}">
-                <a16:creationId xmlns:a16="http://schemas.microsoft.com/office/drawing/2014/main" id="{DCF0C120-0B33-4324-BC80-7D4D92DAD287}"/>
+                <a16:creationId xmlns:a16="http://schemas.microsoft.com/office/drawing/2014/main" id="{D5E165DC-BD41-448D-B3CE-C935EE8F3BF9}"/>
               </a:ext>
             </a:extLst>
           </p:cNvPr>
@@ -10524,7 +11442,7 @@
           <p:cNvPr id="15" name="">
             <a:extLst xmlns:a="http://schemas.openxmlformats.org/drawingml/2006/main">
               <a:ext uri="{FF2B5EF4-FFF2-40B4-BE49-F238E27FC236}">
-                <a16:creationId xmlns:a16="http://schemas.microsoft.com/office/drawing/2014/main" id="{386B01C5-8C06-4761-B45F-31B9FC6CFC24}"/>
+                <a16:creationId xmlns:a16="http://schemas.microsoft.com/office/drawing/2014/main" id="{DED4DEDC-130D-4E69-BDFD-F683DAF33404}"/>
               </a:ext>
             </a:extLst>
           </p:cNvPr>
@@ -10554,7 +11472,7 @@
           <p:cNvPr id="16" name="">
             <a:extLst xmlns:a="http://schemas.openxmlformats.org/drawingml/2006/main">
               <a:ext uri="{FF2B5EF4-FFF2-40B4-BE49-F238E27FC236}">
-                <a16:creationId xmlns:a16="http://schemas.microsoft.com/office/drawing/2014/main" id="{0B5C5AA9-80BC-4B1F-BE8E-BD0C17971F0E}"/>
+                <a16:creationId xmlns:a16="http://schemas.microsoft.com/office/drawing/2014/main" id="{1B7E6C5F-6CBB-43FD-8741-482077924EEC}"/>
               </a:ext>
             </a:extLst>
           </p:cNvPr>
@@ -10611,7 +11529,7 @@
           <p:cNvPr id="17" name="">
             <a:extLst xmlns:a="http://schemas.openxmlformats.org/drawingml/2006/main">
               <a:ext uri="{FF2B5EF4-FFF2-40B4-BE49-F238E27FC236}">
-                <a16:creationId xmlns:a16="http://schemas.microsoft.com/office/drawing/2014/main" id="{4B970731-046A-4431-A234-415A43A6FFB9}"/>
+                <a16:creationId xmlns:a16="http://schemas.microsoft.com/office/drawing/2014/main" id="{04BFA510-1418-4E2D-BAF3-82C76EDF82A5}"/>
               </a:ext>
             </a:extLst>
           </p:cNvPr>
@@ -10668,7 +11586,7 @@
           <p:cNvPr id="18" name="">
             <a:extLst xmlns:a="http://schemas.openxmlformats.org/drawingml/2006/main">
               <a:ext uri="{FF2B5EF4-FFF2-40B4-BE49-F238E27FC236}">
-                <a16:creationId xmlns:a16="http://schemas.microsoft.com/office/drawing/2014/main" id="{A7232744-2955-4EE4-85F9-F9FD28BFB93F}"/>
+                <a16:creationId xmlns:a16="http://schemas.microsoft.com/office/drawing/2014/main" id="{6907C65B-2A61-4A43-B317-3608DDD56D5E}"/>
               </a:ext>
             </a:extLst>
           </p:cNvPr>
@@ -10698,7 +11616,7 @@
           <p:cNvPr id="19" name="">
             <a:extLst xmlns:a="http://schemas.openxmlformats.org/drawingml/2006/main">
               <a:ext uri="{FF2B5EF4-FFF2-40B4-BE49-F238E27FC236}">
-                <a16:creationId xmlns:a16="http://schemas.microsoft.com/office/drawing/2014/main" id="{84B2EA5E-D365-4538-A2C3-2DE1B2FB83B8}"/>
+                <a16:creationId xmlns:a16="http://schemas.microsoft.com/office/drawing/2014/main" id="{06FE968F-5899-4D73-9DBD-9B8E88347115}"/>
               </a:ext>
             </a:extLst>
           </p:cNvPr>
@@ -10732,7 +11650,7 @@
           <p:cNvPr id="20" name="">
             <a:extLst xmlns:a="http://schemas.openxmlformats.org/drawingml/2006/main">
               <a:ext uri="{FF2B5EF4-FFF2-40B4-BE49-F238E27FC236}">
-                <a16:creationId xmlns:a16="http://schemas.microsoft.com/office/drawing/2014/main" id="{E44D649B-A330-4417-B9FA-50E2EA29876E}"/>
+                <a16:creationId xmlns:a16="http://schemas.microsoft.com/office/drawing/2014/main" id="{3D44DC8B-DB6A-4780-AF00-7D49E090FAE7}"/>
               </a:ext>
             </a:extLst>
           </p:cNvPr>
@@ -10762,7 +11680,7 @@
           <p:cNvPr id="21" name="">
             <a:extLst xmlns:a="http://schemas.openxmlformats.org/drawingml/2006/main">
               <a:ext uri="{FF2B5EF4-FFF2-40B4-BE49-F238E27FC236}">
-                <a16:creationId xmlns:a16="http://schemas.microsoft.com/office/drawing/2014/main" id="{4A6997B9-8082-47EA-817F-32D43A8642BB}"/>
+                <a16:creationId xmlns:a16="http://schemas.microsoft.com/office/drawing/2014/main" id="{1F0ED488-6FBC-47A3-B5FB-71BC13DA123A}"/>
               </a:ext>
             </a:extLst>
           </p:cNvPr>
@@ -10819,7 +11737,7 @@
           <p:cNvPr id="22" name="">
             <a:extLst xmlns:a="http://schemas.openxmlformats.org/drawingml/2006/main">
               <a:ext uri="{FF2B5EF4-FFF2-40B4-BE49-F238E27FC236}">
-                <a16:creationId xmlns:a16="http://schemas.microsoft.com/office/drawing/2014/main" id="{076A774C-F64B-4F60-A507-7D61794EF263}"/>
+                <a16:creationId xmlns:a16="http://schemas.microsoft.com/office/drawing/2014/main" id="{5137648F-CAEC-4280-86FE-665566ED5048}"/>
               </a:ext>
             </a:extLst>
           </p:cNvPr>
@@ -10876,7 +11794,7 @@
           <p:cNvPr id="23" name="">
             <a:extLst xmlns:a="http://schemas.openxmlformats.org/drawingml/2006/main">
               <a:ext uri="{FF2B5EF4-FFF2-40B4-BE49-F238E27FC236}">
-                <a16:creationId xmlns:a16="http://schemas.microsoft.com/office/drawing/2014/main" id="{525940BD-DB6A-4222-BFC4-9F2F9D490DCA}"/>
+                <a16:creationId xmlns:a16="http://schemas.microsoft.com/office/drawing/2014/main" id="{59D2EF61-B0B4-4CF0-B09F-7E3143DBA200}"/>
               </a:ext>
             </a:extLst>
           </p:cNvPr>
@@ -10906,7 +11824,7 @@
           <p:cNvPr id="24" name="">
             <a:extLst xmlns:a="http://schemas.openxmlformats.org/drawingml/2006/main">
               <a:ext uri="{FF2B5EF4-FFF2-40B4-BE49-F238E27FC236}">
-                <a16:creationId xmlns:a16="http://schemas.microsoft.com/office/drawing/2014/main" id="{8EAD4BFB-AF69-445F-993B-E58A11F10E85}"/>
+                <a16:creationId xmlns:a16="http://schemas.microsoft.com/office/drawing/2014/main" id="{1CE85868-3F8C-43A6-A693-1A661809DFF4}"/>
               </a:ext>
             </a:extLst>
           </p:cNvPr>
@@ -10940,7 +11858,7 @@
           <p:cNvPr id="25" name="">
             <a:extLst xmlns:a="http://schemas.openxmlformats.org/drawingml/2006/main">
               <a:ext uri="{FF2B5EF4-FFF2-40B4-BE49-F238E27FC236}">
-                <a16:creationId xmlns:a16="http://schemas.microsoft.com/office/drawing/2014/main" id="{7DDDE5F2-C801-4BC6-955F-10578EFA45AE}"/>
+                <a16:creationId xmlns:a16="http://schemas.microsoft.com/office/drawing/2014/main" id="{4021F9B0-9E82-4254-BA27-14E2BE45BB79}"/>
               </a:ext>
             </a:extLst>
           </p:cNvPr>
@@ -10970,7 +11888,7 @@
           <p:cNvPr id="26" name="">
             <a:extLst xmlns:a="http://schemas.openxmlformats.org/drawingml/2006/main">
               <a:ext uri="{FF2B5EF4-FFF2-40B4-BE49-F238E27FC236}">
-                <a16:creationId xmlns:a16="http://schemas.microsoft.com/office/drawing/2014/main" id="{9F822802-1F25-408B-B382-53D0F781BEB1}"/>
+                <a16:creationId xmlns:a16="http://schemas.microsoft.com/office/drawing/2014/main" id="{4AF6D3CF-7DC5-4D5E-A885-2DCFE29199A8}"/>
               </a:ext>
             </a:extLst>
           </p:cNvPr>
@@ -11027,7 +11945,7 @@
           <p:cNvPr id="27" name="">
             <a:extLst xmlns:a="http://schemas.openxmlformats.org/drawingml/2006/main">
               <a:ext uri="{FF2B5EF4-FFF2-40B4-BE49-F238E27FC236}">
-                <a16:creationId xmlns:a16="http://schemas.microsoft.com/office/drawing/2014/main" id="{E29D93B7-6D98-49FD-BA38-C6282857ECFF}"/>
+                <a16:creationId xmlns:a16="http://schemas.microsoft.com/office/drawing/2014/main" id="{F9825E26-E357-41E9-BCBF-4865F6D39CA7}"/>
               </a:ext>
             </a:extLst>
           </p:cNvPr>
@@ -11084,7 +12002,7 @@
           <p:cNvPr id="28" name="">
             <a:extLst xmlns:a="http://schemas.openxmlformats.org/drawingml/2006/main">
               <a:ext uri="{FF2B5EF4-FFF2-40B4-BE49-F238E27FC236}">
-                <a16:creationId xmlns:a16="http://schemas.microsoft.com/office/drawing/2014/main" id="{E7CB6C2A-7837-4E2F-998D-BCDD69BA94E5}"/>
+                <a16:creationId xmlns:a16="http://schemas.microsoft.com/office/drawing/2014/main" id="{E63C98E8-322C-4338-AF06-8F0DE793EF12}"/>
               </a:ext>
             </a:extLst>
           </p:cNvPr>
@@ -11114,7 +12032,7 @@
           <p:cNvPr id="29" name="">
             <a:extLst xmlns:a="http://schemas.openxmlformats.org/drawingml/2006/main">
               <a:ext uri="{FF2B5EF4-FFF2-40B4-BE49-F238E27FC236}">
-                <a16:creationId xmlns:a16="http://schemas.microsoft.com/office/drawing/2014/main" id="{DB2A7206-0A1B-424B-ADD2-91E377E36330}"/>
+                <a16:creationId xmlns:a16="http://schemas.microsoft.com/office/drawing/2014/main" id="{63F14288-B42D-4A29-B6DE-A7A7A1F179CD}"/>
               </a:ext>
             </a:extLst>
           </p:cNvPr>
@@ -11148,7 +12066,7 @@
           <p:cNvPr id="30" name="">
             <a:extLst xmlns:a="http://schemas.openxmlformats.org/drawingml/2006/main">
               <a:ext uri="{FF2B5EF4-FFF2-40B4-BE49-F238E27FC236}">
-                <a16:creationId xmlns:a16="http://schemas.microsoft.com/office/drawing/2014/main" id="{6875E926-145C-4181-9702-882B00D14691}"/>
+                <a16:creationId xmlns:a16="http://schemas.microsoft.com/office/drawing/2014/main" id="{BE89B451-10F5-46D7-A7C0-972D792EE3A8}"/>
               </a:ext>
             </a:extLst>
           </p:cNvPr>
@@ -11178,7 +12096,7 @@
           <p:cNvPr id="31" name="">
             <a:extLst xmlns:a="http://schemas.openxmlformats.org/drawingml/2006/main">
               <a:ext uri="{FF2B5EF4-FFF2-40B4-BE49-F238E27FC236}">
-                <a16:creationId xmlns:a16="http://schemas.microsoft.com/office/drawing/2014/main" id="{98F5A0CC-7189-40E0-9B2E-4A794ACA614D}"/>
+                <a16:creationId xmlns:a16="http://schemas.microsoft.com/office/drawing/2014/main" id="{984B398D-C58F-4FAD-B0A6-4DF021786B20}"/>
               </a:ext>
             </a:extLst>
           </p:cNvPr>
@@ -11235,7 +12153,7 @@
           <p:cNvPr id="32" name="">
             <a:extLst xmlns:a="http://schemas.openxmlformats.org/drawingml/2006/main">
               <a:ext uri="{FF2B5EF4-FFF2-40B4-BE49-F238E27FC236}">
-                <a16:creationId xmlns:a16="http://schemas.microsoft.com/office/drawing/2014/main" id="{C946F372-0725-4D9A-90F0-4F545F2F5573}"/>
+                <a16:creationId xmlns:a16="http://schemas.microsoft.com/office/drawing/2014/main" id="{A8F7B22F-8C94-4092-A1D4-3FE87EDF7856}"/>
               </a:ext>
             </a:extLst>
           </p:cNvPr>
@@ -11290,7 +12208,7 @@
     </p:spTree>
     <p:extLst>
       <p:ext uri="{BB962C8B-B14F-4D97-AF65-F5344CB8AC3E}">
-        <p14:creationId xmlns:p14="http://schemas.microsoft.com/office/powerpoint/2010/main" val="2102587403"/>
+        <p14:creationId xmlns:p14="http://schemas.microsoft.com/office/powerpoint/2010/main" val="30760304"/>
       </p:ext>
     </p:extLst>
   </p:cSld>
@@ -11321,7 +12239,7 @@
           <p:cNvPr id="28" name="">
             <a:extLst xmlns:a="http://schemas.openxmlformats.org/drawingml/2006/main">
               <a:ext uri="{FF2B5EF4-FFF2-40B4-BE49-F238E27FC236}">
-                <a16:creationId xmlns:a16="http://schemas.microsoft.com/office/drawing/2014/main" id="{A2B36533-1786-40F2-97B7-A80C5A71EC74}"/>
+                <a16:creationId xmlns:a16="http://schemas.microsoft.com/office/drawing/2014/main" id="{92152680-1AFB-4AF2-AFF9-4A5064E29FA0}"/>
               </a:ext>
             </a:extLst>
           </p:cNvPr>
@@ -11351,7 +12269,7 @@
           <p:cNvPr id="2" name="">
             <a:extLst xmlns:a="http://schemas.openxmlformats.org/drawingml/2006/main">
               <a:ext uri="{FF2B5EF4-FFF2-40B4-BE49-F238E27FC236}">
-                <a16:creationId xmlns:a16="http://schemas.microsoft.com/office/drawing/2014/main" id="{8D957846-BD08-4D38-BCF7-6F98B2FFD321}"/>
+                <a16:creationId xmlns:a16="http://schemas.microsoft.com/office/drawing/2014/main" id="{81BBB278-09AC-454A-B8A6-4CBEAA7FCD1D}"/>
               </a:ext>
             </a:extLst>
           </p:cNvPr>
@@ -11408,7 +12326,7 @@
           <p:cNvPr id="3" name="">
             <a:extLst xmlns:a="http://schemas.openxmlformats.org/drawingml/2006/main">
               <a:ext uri="{FF2B5EF4-FFF2-40B4-BE49-F238E27FC236}">
-                <a16:creationId xmlns:a16="http://schemas.microsoft.com/office/drawing/2014/main" id="{D1D28FA9-D529-4BEC-81B9-3A68AD01FBC4}"/>
+                <a16:creationId xmlns:a16="http://schemas.microsoft.com/office/drawing/2014/main" id="{4123F4BE-459A-4428-BC15-FEE719212D21}"/>
               </a:ext>
             </a:extLst>
           </p:cNvPr>
@@ -11438,7 +12356,7 @@
           <p:cNvPr id="4" name="">
             <a:extLst xmlns:a="http://schemas.openxmlformats.org/drawingml/2006/main">
               <a:ext uri="{FF2B5EF4-FFF2-40B4-BE49-F238E27FC236}">
-                <a16:creationId xmlns:a16="http://schemas.microsoft.com/office/drawing/2014/main" id="{B4E05661-28E1-4859-ADA3-E470F7AF96D5}"/>
+                <a16:creationId xmlns:a16="http://schemas.microsoft.com/office/drawing/2014/main" id="{E15F78D7-8962-4C5A-ABF7-9177B8E10EE8}"/>
               </a:ext>
             </a:extLst>
           </p:cNvPr>
@@ -11495,7 +12413,7 @@
           <p:cNvPr id="5" name="">
             <a:extLst xmlns:a="http://schemas.openxmlformats.org/drawingml/2006/main">
               <a:ext uri="{FF2B5EF4-FFF2-40B4-BE49-F238E27FC236}">
-                <a16:creationId xmlns:a16="http://schemas.microsoft.com/office/drawing/2014/main" id="{20E73E50-800E-4EE4-BFC7-D2455EDD20A6}"/>
+                <a16:creationId xmlns:a16="http://schemas.microsoft.com/office/drawing/2014/main" id="{05C90F76-DC19-4A27-AC79-AC310F26ED8B}"/>
               </a:ext>
             </a:extLst>
           </p:cNvPr>
@@ -11525,7 +12443,7 @@
           <p:cNvPr id="6" name="">
             <a:extLst xmlns:a="http://schemas.openxmlformats.org/drawingml/2006/main">
               <a:ext uri="{FF2B5EF4-FFF2-40B4-BE49-F238E27FC236}">
-                <a16:creationId xmlns:a16="http://schemas.microsoft.com/office/drawing/2014/main" id="{B712AFDD-41DC-4B0D-A636-2B3E3E09C71E}"/>
+                <a16:creationId xmlns:a16="http://schemas.microsoft.com/office/drawing/2014/main" id="{DCE84398-75C6-4CE7-AEA2-DFABB1A2B7E9}"/>
               </a:ext>
             </a:extLst>
           </p:cNvPr>
@@ -11582,7 +12500,7 @@
           <p:cNvPr id="7" name="">
             <a:extLst xmlns:a="http://schemas.openxmlformats.org/drawingml/2006/main">
               <a:ext uri="{FF2B5EF4-FFF2-40B4-BE49-F238E27FC236}">
-                <a16:creationId xmlns:a16="http://schemas.microsoft.com/office/drawing/2014/main" id="{2DCD6B9A-988D-4EF7-83D8-ED1809183CC8}"/>
+                <a16:creationId xmlns:a16="http://schemas.microsoft.com/office/drawing/2014/main" id="{89D6FEF1-4CD6-45FC-B629-C66A975AAE64}"/>
               </a:ext>
             </a:extLst>
           </p:cNvPr>
@@ -11612,7 +12530,7 @@
           <p:cNvPr id="8" name="">
             <a:extLst xmlns:a="http://schemas.openxmlformats.org/drawingml/2006/main">
               <a:ext uri="{FF2B5EF4-FFF2-40B4-BE49-F238E27FC236}">
-                <a16:creationId xmlns:a16="http://schemas.microsoft.com/office/drawing/2014/main" id="{59AD8DF3-8198-43B7-9793-D1441A7AB6B7}"/>
+                <a16:creationId xmlns:a16="http://schemas.microsoft.com/office/drawing/2014/main" id="{725D8534-10FA-48A5-8F6B-B582226F9918}"/>
               </a:ext>
             </a:extLst>
           </p:cNvPr>
@@ -11669,7 +12587,7 @@
           <p:cNvPr id="9" name="">
             <a:extLst xmlns:a="http://schemas.openxmlformats.org/drawingml/2006/main">
               <a:ext uri="{FF2B5EF4-FFF2-40B4-BE49-F238E27FC236}">
-                <a16:creationId xmlns:a16="http://schemas.microsoft.com/office/drawing/2014/main" id="{11773FF7-10E5-46CD-9014-2B02AAB4744C}"/>
+                <a16:creationId xmlns:a16="http://schemas.microsoft.com/office/drawing/2014/main" id="{18111D90-A6FE-427D-9C09-1186D7850D34}"/>
               </a:ext>
             </a:extLst>
           </p:cNvPr>
@@ -11699,7 +12617,7 @@
           <p:cNvPr id="10" name="">
             <a:extLst xmlns:a="http://schemas.openxmlformats.org/drawingml/2006/main">
               <a:ext uri="{FF2B5EF4-FFF2-40B4-BE49-F238E27FC236}">
-                <a16:creationId xmlns:a16="http://schemas.microsoft.com/office/drawing/2014/main" id="{5FC39C6E-298C-4057-9409-EFCB8A009DB2}"/>
+                <a16:creationId xmlns:a16="http://schemas.microsoft.com/office/drawing/2014/main" id="{BC8964CD-A44B-4EFD-9C82-BC62DECDDE9C}"/>
               </a:ext>
             </a:extLst>
           </p:cNvPr>
@@ -11756,7 +12674,7 @@
           <p:cNvPr id="11" name="">
             <a:extLst xmlns:a="http://schemas.openxmlformats.org/drawingml/2006/main">
               <a:ext uri="{FF2B5EF4-FFF2-40B4-BE49-F238E27FC236}">
-                <a16:creationId xmlns:a16="http://schemas.microsoft.com/office/drawing/2014/main" id="{1CE4C1C9-E262-4708-8F3D-3A03FC45DD56}"/>
+                <a16:creationId xmlns:a16="http://schemas.microsoft.com/office/drawing/2014/main" id="{6CCDCC95-6BE0-4689-95FB-AA020E8C05BF}"/>
               </a:ext>
             </a:extLst>
           </p:cNvPr>
@@ -11813,7 +12731,7 @@
           <p:cNvPr id="12" name="">
             <a:extLst xmlns:a="http://schemas.openxmlformats.org/drawingml/2006/main">
               <a:ext uri="{FF2B5EF4-FFF2-40B4-BE49-F238E27FC236}">
-                <a16:creationId xmlns:a16="http://schemas.microsoft.com/office/drawing/2014/main" id="{5013878E-E797-4771-8371-1216765BCF18}"/>
+                <a16:creationId xmlns:a16="http://schemas.microsoft.com/office/drawing/2014/main" id="{1DF2BF86-704B-4190-AC27-7962C5C72A9C}"/>
               </a:ext>
             </a:extLst>
           </p:cNvPr>
@@ -11870,7 +12788,7 @@
           <p:cNvPr id="13" name="">
             <a:extLst xmlns:a="http://schemas.openxmlformats.org/drawingml/2006/main">
               <a:ext uri="{FF2B5EF4-FFF2-40B4-BE49-F238E27FC236}">
-                <a16:creationId xmlns:a16="http://schemas.microsoft.com/office/drawing/2014/main" id="{E29D772D-9360-43A0-95C3-20DC8CCA6E15}"/>
+                <a16:creationId xmlns:a16="http://schemas.microsoft.com/office/drawing/2014/main" id="{3933BE17-8DB0-4CFE-B28A-8C1E8D8018BB}"/>
               </a:ext>
             </a:extLst>
           </p:cNvPr>
@@ -11927,7 +12845,7 @@
           <p:cNvPr id="14" name="">
             <a:extLst xmlns:a="http://schemas.openxmlformats.org/drawingml/2006/main">
               <a:ext uri="{FF2B5EF4-FFF2-40B4-BE49-F238E27FC236}">
-                <a16:creationId xmlns:a16="http://schemas.microsoft.com/office/drawing/2014/main" id="{829B8484-C6CE-4395-9A4E-9E99DFEA9434}"/>
+                <a16:creationId xmlns:a16="http://schemas.microsoft.com/office/drawing/2014/main" id="{DEE6B349-D92B-4E4D-9DF8-BCD7A04B8D2D}"/>
               </a:ext>
             </a:extLst>
           </p:cNvPr>
@@ -11984,7 +12902,7 @@
           <p:cNvPr id="15" name="">
             <a:extLst xmlns:a="http://schemas.openxmlformats.org/drawingml/2006/main">
               <a:ext uri="{FF2B5EF4-FFF2-40B4-BE49-F238E27FC236}">
-                <a16:creationId xmlns:a16="http://schemas.microsoft.com/office/drawing/2014/main" id="{EE277156-ABD8-494C-BC0D-E82E5FCDBFF8}"/>
+                <a16:creationId xmlns:a16="http://schemas.microsoft.com/office/drawing/2014/main" id="{A93BF851-61CA-43AC-BD37-68093FA9CE9E}"/>
               </a:ext>
             </a:extLst>
           </p:cNvPr>
@@ -12064,7 +12982,7 @@
           <p:cNvPr id="16" name="">
             <a:extLst xmlns:a="http://schemas.openxmlformats.org/drawingml/2006/main">
               <a:ext uri="{FF2B5EF4-FFF2-40B4-BE49-F238E27FC236}">
-                <a16:creationId xmlns:a16="http://schemas.microsoft.com/office/drawing/2014/main" id="{8A18828C-E7F5-474B-977F-EFAFFAA455A4}"/>
+                <a16:creationId xmlns:a16="http://schemas.microsoft.com/office/drawing/2014/main" id="{01343BF0-0CE3-407A-9F3A-F75DEC9EDA57}"/>
               </a:ext>
             </a:extLst>
           </p:cNvPr>
@@ -12121,7 +13039,7 @@
           <p:cNvPr id="17" name="">
             <a:extLst xmlns:a="http://schemas.openxmlformats.org/drawingml/2006/main">
               <a:ext uri="{FF2B5EF4-FFF2-40B4-BE49-F238E27FC236}">
-                <a16:creationId xmlns:a16="http://schemas.microsoft.com/office/drawing/2014/main" id="{58FE0ABC-FAD7-40AA-8020-CEEF442BDE5F}"/>
+                <a16:creationId xmlns:a16="http://schemas.microsoft.com/office/drawing/2014/main" id="{B330254F-6D2F-46B1-8A32-3387CBCBDD69}"/>
               </a:ext>
             </a:extLst>
           </p:cNvPr>
@@ -12151,7 +13069,7 @@
           <p:cNvPr id="18" name="">
             <a:extLst xmlns:a="http://schemas.openxmlformats.org/drawingml/2006/main">
               <a:ext uri="{FF2B5EF4-FFF2-40B4-BE49-F238E27FC236}">
-                <a16:creationId xmlns:a16="http://schemas.microsoft.com/office/drawing/2014/main" id="{94C9CA61-F33E-4BB5-B48F-4060077C82E2}"/>
+                <a16:creationId xmlns:a16="http://schemas.microsoft.com/office/drawing/2014/main" id="{A2341CE0-C6AB-4EFE-A645-32A110F590BD}"/>
               </a:ext>
             </a:extLst>
           </p:cNvPr>
@@ -12208,7 +13126,7 @@
           <p:cNvPr id="19" name="">
             <a:extLst xmlns:a="http://schemas.openxmlformats.org/drawingml/2006/main">
               <a:ext uri="{FF2B5EF4-FFF2-40B4-BE49-F238E27FC236}">
-                <a16:creationId xmlns:a16="http://schemas.microsoft.com/office/drawing/2014/main" id="{F5753220-B25E-41F1-9B1E-0D1907CAC206}"/>
+                <a16:creationId xmlns:a16="http://schemas.microsoft.com/office/drawing/2014/main" id="{7AC98678-1550-4417-90BB-6C37C29411BF}"/>
               </a:ext>
             </a:extLst>
           </p:cNvPr>
@@ -12238,7 +13156,7 @@
           <p:cNvPr id="20" name="">
             <a:extLst xmlns:a="http://schemas.openxmlformats.org/drawingml/2006/main">
               <a:ext uri="{FF2B5EF4-FFF2-40B4-BE49-F238E27FC236}">
-                <a16:creationId xmlns:a16="http://schemas.microsoft.com/office/drawing/2014/main" id="{BFCD4D76-8F81-4D10-A7EC-3B9D800E80EE}"/>
+                <a16:creationId xmlns:a16="http://schemas.microsoft.com/office/drawing/2014/main" id="{646233B9-9CCC-42D9-9D76-8206589A2824}"/>
               </a:ext>
             </a:extLst>
           </p:cNvPr>
@@ -12295,7 +13213,7 @@
           <p:cNvPr id="21" name="">
             <a:extLst xmlns:a="http://schemas.openxmlformats.org/drawingml/2006/main">
               <a:ext uri="{FF2B5EF4-FFF2-40B4-BE49-F238E27FC236}">
-                <a16:creationId xmlns:a16="http://schemas.microsoft.com/office/drawing/2014/main" id="{2BD26DF4-CAF3-4F9D-B077-CA7645D0DDF6}"/>
+                <a16:creationId xmlns:a16="http://schemas.microsoft.com/office/drawing/2014/main" id="{C1488B0D-FA8F-49F1-9D7F-3D703E387220}"/>
               </a:ext>
             </a:extLst>
           </p:cNvPr>
@@ -12325,7 +13243,7 @@
           <p:cNvPr id="22" name="">
             <a:extLst xmlns:a="http://schemas.openxmlformats.org/drawingml/2006/main">
               <a:ext uri="{FF2B5EF4-FFF2-40B4-BE49-F238E27FC236}">
-                <a16:creationId xmlns:a16="http://schemas.microsoft.com/office/drawing/2014/main" id="{2A122D7D-99E5-4C7D-9F63-C02754F4D4D2}"/>
+                <a16:creationId xmlns:a16="http://schemas.microsoft.com/office/drawing/2014/main" id="{8393D206-F720-4498-BAB3-7658E8E445B4}"/>
               </a:ext>
             </a:extLst>
           </p:cNvPr>
@@ -12382,7 +13300,7 @@
           <p:cNvPr id="23" name="">
             <a:extLst xmlns:a="http://schemas.openxmlformats.org/drawingml/2006/main">
               <a:ext uri="{FF2B5EF4-FFF2-40B4-BE49-F238E27FC236}">
-                <a16:creationId xmlns:a16="http://schemas.microsoft.com/office/drawing/2014/main" id="{4CDF73FB-8063-4EF7-9351-3255F1638EF4}"/>
+                <a16:creationId xmlns:a16="http://schemas.microsoft.com/office/drawing/2014/main" id="{3C860649-BA03-4AFD-94E6-B9703B8DBB34}"/>
               </a:ext>
             </a:extLst>
           </p:cNvPr>
@@ -12412,7 +13330,7 @@
           <p:cNvPr id="24" name="">
             <a:extLst xmlns:a="http://schemas.openxmlformats.org/drawingml/2006/main">
               <a:ext uri="{FF2B5EF4-FFF2-40B4-BE49-F238E27FC236}">
-                <a16:creationId xmlns:a16="http://schemas.microsoft.com/office/drawing/2014/main" id="{5F4D53FE-8554-4726-A840-F95E90235D57}"/>
+                <a16:creationId xmlns:a16="http://schemas.microsoft.com/office/drawing/2014/main" id="{008A09CF-D890-4AE5-B085-C1FD78AD2B49}"/>
               </a:ext>
             </a:extLst>
           </p:cNvPr>
@@ -12469,7 +13387,7 @@
           <p:cNvPr id="25" name="">
             <a:extLst xmlns:a="http://schemas.openxmlformats.org/drawingml/2006/main">
               <a:ext uri="{FF2B5EF4-FFF2-40B4-BE49-F238E27FC236}">
-                <a16:creationId xmlns:a16="http://schemas.microsoft.com/office/drawing/2014/main" id="{04D98B59-D6FC-4C4C-91B1-3FA3CC62DD30}"/>
+                <a16:creationId xmlns:a16="http://schemas.microsoft.com/office/drawing/2014/main" id="{0BFAE042-1C60-46B1-A53E-1B0FE690C02D}"/>
               </a:ext>
             </a:extLst>
           </p:cNvPr>
@@ -12526,7 +13444,7 @@
           <p:cNvPr id="26" name="">
             <a:extLst xmlns:a="http://schemas.openxmlformats.org/drawingml/2006/main">
               <a:ext uri="{FF2B5EF4-FFF2-40B4-BE49-F238E27FC236}">
-                <a16:creationId xmlns:a16="http://schemas.microsoft.com/office/drawing/2014/main" id="{91D5A9AA-5B38-4C64-A275-4B4ED66B34F1}"/>
+                <a16:creationId xmlns:a16="http://schemas.microsoft.com/office/drawing/2014/main" id="{2BB1E642-DA26-4ABB-A2FD-0522AC4236AA}"/>
               </a:ext>
             </a:extLst>
           </p:cNvPr>
@@ -12556,7 +13474,7 @@
           <p:cNvPr id="27" name="">
             <a:extLst xmlns:a="http://schemas.openxmlformats.org/drawingml/2006/main">
               <a:ext uri="{FF2B5EF4-FFF2-40B4-BE49-F238E27FC236}">
-                <a16:creationId xmlns:a16="http://schemas.microsoft.com/office/drawing/2014/main" id="{60372744-C79B-40D3-86A2-1EE17E868160}"/>
+                <a16:creationId xmlns:a16="http://schemas.microsoft.com/office/drawing/2014/main" id="{1A36AB70-1DD6-486E-8076-758145A4338F}"/>
               </a:ext>
             </a:extLst>
           </p:cNvPr>
@@ -12611,7 +13529,7 @@
     </p:spTree>
     <p:extLst>
       <p:ext uri="{BB962C8B-B14F-4D97-AF65-F5344CB8AC3E}">
-        <p14:creationId xmlns:p14="http://schemas.microsoft.com/office/powerpoint/2010/main" val="1374334495"/>
+        <p14:creationId xmlns:p14="http://schemas.microsoft.com/office/powerpoint/2010/main" val="430862266"/>
       </p:ext>
     </p:extLst>
   </p:cSld>
@@ -12642,7 +13560,7 @@
           <p:cNvPr id="29" name="">
             <a:extLst xmlns:a="http://schemas.openxmlformats.org/drawingml/2006/main">
               <a:ext uri="{FF2B5EF4-FFF2-40B4-BE49-F238E27FC236}">
-                <a16:creationId xmlns:a16="http://schemas.microsoft.com/office/drawing/2014/main" id="{9FE32811-2D32-4707-BE84-1A942F1DBBB1}"/>
+                <a16:creationId xmlns:a16="http://schemas.microsoft.com/office/drawing/2014/main" id="{8DAAED9A-9814-41A4-AC7F-6DA5D5A95214}"/>
               </a:ext>
             </a:extLst>
           </p:cNvPr>
@@ -12672,7 +13590,7 @@
           <p:cNvPr id="2" name="">
             <a:extLst xmlns:a="http://schemas.openxmlformats.org/drawingml/2006/main">
               <a:ext uri="{FF2B5EF4-FFF2-40B4-BE49-F238E27FC236}">
-                <a16:creationId xmlns:a16="http://schemas.microsoft.com/office/drawing/2014/main" id="{72F80A96-F2BD-4799-B62A-35200F0535E1}"/>
+                <a16:creationId xmlns:a16="http://schemas.microsoft.com/office/drawing/2014/main" id="{9BBF4C8D-C61F-4336-8E23-6086F5540EE3}"/>
               </a:ext>
             </a:extLst>
           </p:cNvPr>
@@ -12729,7 +13647,7 @@
           <p:cNvPr id="3" name="">
             <a:extLst xmlns:a="http://schemas.openxmlformats.org/drawingml/2006/main">
               <a:ext uri="{FF2B5EF4-FFF2-40B4-BE49-F238E27FC236}">
-                <a16:creationId xmlns:a16="http://schemas.microsoft.com/office/drawing/2014/main" id="{4060F77A-AC92-4C3F-8232-369BBC956A71}"/>
+                <a16:creationId xmlns:a16="http://schemas.microsoft.com/office/drawing/2014/main" id="{510E5991-CFFA-4C96-87C1-3369A072EFDE}"/>
               </a:ext>
             </a:extLst>
           </p:cNvPr>
@@ -12759,7 +13677,7 @@
           <p:cNvPr id="4" name="">
             <a:extLst xmlns:a="http://schemas.openxmlformats.org/drawingml/2006/main">
               <a:ext uri="{FF2B5EF4-FFF2-40B4-BE49-F238E27FC236}">
-                <a16:creationId xmlns:a16="http://schemas.microsoft.com/office/drawing/2014/main" id="{EEB1D821-95FC-485F-8979-DA4C00354717}"/>
+                <a16:creationId xmlns:a16="http://schemas.microsoft.com/office/drawing/2014/main" id="{71C0177B-3C64-4A37-A4D9-9B3DF807D562}"/>
               </a:ext>
             </a:extLst>
           </p:cNvPr>
@@ -12816,7 +13734,7 @@
           <p:cNvPr id="5" name="">
             <a:extLst xmlns:a="http://schemas.openxmlformats.org/drawingml/2006/main">
               <a:ext uri="{FF2B5EF4-FFF2-40B4-BE49-F238E27FC236}">
-                <a16:creationId xmlns:a16="http://schemas.microsoft.com/office/drawing/2014/main" id="{9FE789C5-9991-4E66-BC86-C3C3988D1AE8}"/>
+                <a16:creationId xmlns:a16="http://schemas.microsoft.com/office/drawing/2014/main" id="{ACF1D7AB-522A-4CC6-9E1A-BBEEBFD7D690}"/>
               </a:ext>
             </a:extLst>
           </p:cNvPr>
@@ -12846,7 +13764,7 @@
           <p:cNvPr id="6" name="">
             <a:extLst xmlns:a="http://schemas.openxmlformats.org/drawingml/2006/main">
               <a:ext uri="{FF2B5EF4-FFF2-40B4-BE49-F238E27FC236}">
-                <a16:creationId xmlns:a16="http://schemas.microsoft.com/office/drawing/2014/main" id="{1FB33764-4A22-4B75-B178-44156E76589B}"/>
+                <a16:creationId xmlns:a16="http://schemas.microsoft.com/office/drawing/2014/main" id="{F8AAD556-7BC7-49E6-9C08-E65A0DBD4F73}"/>
               </a:ext>
             </a:extLst>
           </p:cNvPr>
@@ -12903,7 +13821,7 @@
           <p:cNvPr id="7" name="">
             <a:extLst xmlns:a="http://schemas.openxmlformats.org/drawingml/2006/main">
               <a:ext uri="{FF2B5EF4-FFF2-40B4-BE49-F238E27FC236}">
-                <a16:creationId xmlns:a16="http://schemas.microsoft.com/office/drawing/2014/main" id="{0BADB852-AB1A-468C-995B-880DFADBAEE9}"/>
+                <a16:creationId xmlns:a16="http://schemas.microsoft.com/office/drawing/2014/main" id="{69C3420D-32BE-4371-B316-C8F7911B246D}"/>
               </a:ext>
             </a:extLst>
           </p:cNvPr>
@@ -12933,7 +13851,7 @@
           <p:cNvPr id="8" name="">
             <a:extLst xmlns:a="http://schemas.openxmlformats.org/drawingml/2006/main">
               <a:ext uri="{FF2B5EF4-FFF2-40B4-BE49-F238E27FC236}">
-                <a16:creationId xmlns:a16="http://schemas.microsoft.com/office/drawing/2014/main" id="{7B8F4233-9D85-4401-9E35-1B75F7DDC0F3}"/>
+                <a16:creationId xmlns:a16="http://schemas.microsoft.com/office/drawing/2014/main" id="{63DC0A70-BAE0-43BD-9B30-0909595F1765}"/>
               </a:ext>
             </a:extLst>
           </p:cNvPr>
@@ -12990,7 +13908,7 @@
           <p:cNvPr id="9" name="">
             <a:extLst xmlns:a="http://schemas.openxmlformats.org/drawingml/2006/main">
               <a:ext uri="{FF2B5EF4-FFF2-40B4-BE49-F238E27FC236}">
-                <a16:creationId xmlns:a16="http://schemas.microsoft.com/office/drawing/2014/main" id="{A7E17A89-C1B3-4453-98E7-21C27414BC47}"/>
+                <a16:creationId xmlns:a16="http://schemas.microsoft.com/office/drawing/2014/main" id="{F84074D4-5356-46B1-8451-642638680FC7}"/>
               </a:ext>
             </a:extLst>
           </p:cNvPr>
@@ -13020,7 +13938,7 @@
           <p:cNvPr id="10" name="">
             <a:extLst xmlns:a="http://schemas.openxmlformats.org/drawingml/2006/main">
               <a:ext uri="{FF2B5EF4-FFF2-40B4-BE49-F238E27FC236}">
-                <a16:creationId xmlns:a16="http://schemas.microsoft.com/office/drawing/2014/main" id="{C72225BA-3E7E-46ED-9D24-8EBC42525F7C}"/>
+                <a16:creationId xmlns:a16="http://schemas.microsoft.com/office/drawing/2014/main" id="{2412591D-3440-4AAB-B288-88AAE191B550}"/>
               </a:ext>
             </a:extLst>
           </p:cNvPr>
@@ -13077,7 +13995,7 @@
           <p:cNvPr id="11" name="">
             <a:extLst xmlns:a="http://schemas.openxmlformats.org/drawingml/2006/main">
               <a:ext uri="{FF2B5EF4-FFF2-40B4-BE49-F238E27FC236}">
-                <a16:creationId xmlns:a16="http://schemas.microsoft.com/office/drawing/2014/main" id="{8573C655-2170-424A-A863-91C3F6C86915}"/>
+                <a16:creationId xmlns:a16="http://schemas.microsoft.com/office/drawing/2014/main" id="{E16F7390-31E8-4E53-9FA0-68FC28C8D886}"/>
               </a:ext>
             </a:extLst>
           </p:cNvPr>
@@ -13134,7 +14052,7 @@
           <p:cNvPr id="12" name="">
             <a:extLst xmlns:a="http://schemas.openxmlformats.org/drawingml/2006/main">
               <a:ext uri="{FF2B5EF4-FFF2-40B4-BE49-F238E27FC236}">
-                <a16:creationId xmlns:a16="http://schemas.microsoft.com/office/drawing/2014/main" id="{AC972327-FD35-49AD-A792-012C7A9F5718}"/>
+                <a16:creationId xmlns:a16="http://schemas.microsoft.com/office/drawing/2014/main" id="{87656D3B-0E3C-48AE-BF15-DB444B038A05}"/>
               </a:ext>
             </a:extLst>
           </p:cNvPr>
@@ -13191,7 +14109,7 @@
           <p:cNvPr id="13" name="">
             <a:extLst xmlns:a="http://schemas.openxmlformats.org/drawingml/2006/main">
               <a:ext uri="{FF2B5EF4-FFF2-40B4-BE49-F238E27FC236}">
-                <a16:creationId xmlns:a16="http://schemas.microsoft.com/office/drawing/2014/main" id="{A43E1E20-87E8-461C-8D5C-3365FEBD2363}"/>
+                <a16:creationId xmlns:a16="http://schemas.microsoft.com/office/drawing/2014/main" id="{52425CA2-C5B6-4C38-9179-676DA02EBB84}"/>
               </a:ext>
             </a:extLst>
           </p:cNvPr>
@@ -13248,7 +14166,7 @@
           <p:cNvPr id="14" name="">
             <a:extLst xmlns:a="http://schemas.openxmlformats.org/drawingml/2006/main">
               <a:ext uri="{FF2B5EF4-FFF2-40B4-BE49-F238E27FC236}">
-                <a16:creationId xmlns:a16="http://schemas.microsoft.com/office/drawing/2014/main" id="{DA6AA3FE-FB92-4214-B730-A4F7F68F65F0}"/>
+                <a16:creationId xmlns:a16="http://schemas.microsoft.com/office/drawing/2014/main" id="{D11DD436-17D2-4399-B936-94533CF1F267}"/>
               </a:ext>
             </a:extLst>
           </p:cNvPr>
@@ -13278,7 +14196,7 @@
           <p:cNvPr id="15" name="">
             <a:extLst xmlns:a="http://schemas.openxmlformats.org/drawingml/2006/main">
               <a:ext uri="{FF2B5EF4-FFF2-40B4-BE49-F238E27FC236}">
-                <a16:creationId xmlns:a16="http://schemas.microsoft.com/office/drawing/2014/main" id="{7D4A891D-10FA-44AA-926C-6F7F43430512}"/>
+                <a16:creationId xmlns:a16="http://schemas.microsoft.com/office/drawing/2014/main" id="{06821E88-F704-47E1-A716-13ED24D3A8E4}"/>
               </a:ext>
             </a:extLst>
           </p:cNvPr>
@@ -13308,7 +14226,7 @@
           <p:cNvPr id="16" name="">
             <a:extLst xmlns:a="http://schemas.openxmlformats.org/drawingml/2006/main">
               <a:ext uri="{FF2B5EF4-FFF2-40B4-BE49-F238E27FC236}">
-                <a16:creationId xmlns:a16="http://schemas.microsoft.com/office/drawing/2014/main" id="{F1D2E33D-CBB6-4BB4-8866-9393E8DD5819}"/>
+                <a16:creationId xmlns:a16="http://schemas.microsoft.com/office/drawing/2014/main" id="{BE88A122-C930-4075-BD2C-7AD3E0F0A143}"/>
               </a:ext>
             </a:extLst>
           </p:cNvPr>
@@ -13365,7 +14283,7 @@
           <p:cNvPr id="17" name="">
             <a:extLst xmlns:a="http://schemas.openxmlformats.org/drawingml/2006/main">
               <a:ext uri="{FF2B5EF4-FFF2-40B4-BE49-F238E27FC236}">
-                <a16:creationId xmlns:a16="http://schemas.microsoft.com/office/drawing/2014/main" id="{762AAC75-AF18-48BB-8B57-1467EE227A06}"/>
+                <a16:creationId xmlns:a16="http://schemas.microsoft.com/office/drawing/2014/main" id="{B2854BEB-BC22-409B-9ABE-324CC5776622}"/>
               </a:ext>
             </a:extLst>
           </p:cNvPr>
@@ -13395,7 +14313,7 @@
           <p:cNvPr id="18" name="">
             <a:extLst xmlns:a="http://schemas.openxmlformats.org/drawingml/2006/main">
               <a:ext uri="{FF2B5EF4-FFF2-40B4-BE49-F238E27FC236}">
-                <a16:creationId xmlns:a16="http://schemas.microsoft.com/office/drawing/2014/main" id="{8D51525B-F31E-4D64-B2B6-7D389EF9B774}"/>
+                <a16:creationId xmlns:a16="http://schemas.microsoft.com/office/drawing/2014/main" id="{49ABA1D2-8224-43C2-A4BD-724B19FD4A3D}"/>
               </a:ext>
             </a:extLst>
           </p:cNvPr>
@@ -13452,7 +14370,7 @@
           <p:cNvPr id="19" name="">
             <a:extLst xmlns:a="http://schemas.openxmlformats.org/drawingml/2006/main">
               <a:ext uri="{FF2B5EF4-FFF2-40B4-BE49-F238E27FC236}">
-                <a16:creationId xmlns:a16="http://schemas.microsoft.com/office/drawing/2014/main" id="{75370E6F-9457-421D-AFB3-E7121A712179}"/>
+                <a16:creationId xmlns:a16="http://schemas.microsoft.com/office/drawing/2014/main" id="{731BECC7-F66B-442D-88B7-E71A87D4A909}"/>
               </a:ext>
             </a:extLst>
           </p:cNvPr>
@@ -13482,7 +14400,7 @@
           <p:cNvPr id="20" name="">
             <a:extLst xmlns:a="http://schemas.openxmlformats.org/drawingml/2006/main">
               <a:ext uri="{FF2B5EF4-FFF2-40B4-BE49-F238E27FC236}">
-                <a16:creationId xmlns:a16="http://schemas.microsoft.com/office/drawing/2014/main" id="{B018EE71-457F-476B-8556-F71FE94ECD50}"/>
+                <a16:creationId xmlns:a16="http://schemas.microsoft.com/office/drawing/2014/main" id="{F8F972DC-CEF2-4AA0-937D-C216D4E5445F}"/>
               </a:ext>
             </a:extLst>
           </p:cNvPr>
@@ -13512,7 +14430,7 @@
           <p:cNvPr id="21" name="">
             <a:extLst xmlns:a="http://schemas.openxmlformats.org/drawingml/2006/main">
               <a:ext uri="{FF2B5EF4-FFF2-40B4-BE49-F238E27FC236}">
-                <a16:creationId xmlns:a16="http://schemas.microsoft.com/office/drawing/2014/main" id="{3D8D1747-BFE2-42BB-BAC5-3AF8B130A98D}"/>
+                <a16:creationId xmlns:a16="http://schemas.microsoft.com/office/drawing/2014/main" id="{13D0D703-03E1-4EF6-972C-8FC369CB7D5E}"/>
               </a:ext>
             </a:extLst>
           </p:cNvPr>
@@ -13569,7 +14487,7 @@
           <p:cNvPr id="22" name="">
             <a:extLst xmlns:a="http://schemas.openxmlformats.org/drawingml/2006/main">
               <a:ext uri="{FF2B5EF4-FFF2-40B4-BE49-F238E27FC236}">
-                <a16:creationId xmlns:a16="http://schemas.microsoft.com/office/drawing/2014/main" id="{0257F958-E798-4790-BB36-80B99B249650}"/>
+                <a16:creationId xmlns:a16="http://schemas.microsoft.com/office/drawing/2014/main" id="{6A48D2BF-EE62-4E88-B466-AFD3CEA9ACEB}"/>
               </a:ext>
             </a:extLst>
           </p:cNvPr>
@@ -13599,7 +14517,7 @@
           <p:cNvPr id="23" name="">
             <a:extLst xmlns:a="http://schemas.openxmlformats.org/drawingml/2006/main">
               <a:ext uri="{FF2B5EF4-FFF2-40B4-BE49-F238E27FC236}">
-                <a16:creationId xmlns:a16="http://schemas.microsoft.com/office/drawing/2014/main" id="{81D2B866-B0FF-4A04-B08B-209DF998193D}"/>
+                <a16:creationId xmlns:a16="http://schemas.microsoft.com/office/drawing/2014/main" id="{A24FFC1D-3B4C-4997-B0AC-C6DC35428D11}"/>
               </a:ext>
             </a:extLst>
           </p:cNvPr>
@@ -13656,7 +14574,7 @@
           <p:cNvPr id="24" name="">
             <a:extLst xmlns:a="http://schemas.openxmlformats.org/drawingml/2006/main">
               <a:ext uri="{FF2B5EF4-FFF2-40B4-BE49-F238E27FC236}">
-                <a16:creationId xmlns:a16="http://schemas.microsoft.com/office/drawing/2014/main" id="{7D81F3E2-02B7-493E-9E23-7AA18EC9E965}"/>
+                <a16:creationId xmlns:a16="http://schemas.microsoft.com/office/drawing/2014/main" id="{6F32FECA-349A-4B43-80F9-EEB87076203D}"/>
               </a:ext>
             </a:extLst>
           </p:cNvPr>
@@ -13686,7 +14604,7 @@
           <p:cNvPr id="25" name="">
             <a:extLst xmlns:a="http://schemas.openxmlformats.org/drawingml/2006/main">
               <a:ext uri="{FF2B5EF4-FFF2-40B4-BE49-F238E27FC236}">
-                <a16:creationId xmlns:a16="http://schemas.microsoft.com/office/drawing/2014/main" id="{5B7623C1-961C-4847-8172-244FBE7E642D}"/>
+                <a16:creationId xmlns:a16="http://schemas.microsoft.com/office/drawing/2014/main" id="{555EAA57-BC12-4A29-8F70-3E676B450B95}"/>
               </a:ext>
             </a:extLst>
           </p:cNvPr>
@@ -13716,7 +14634,7 @@
           <p:cNvPr id="26" name="">
             <a:extLst xmlns:a="http://schemas.openxmlformats.org/drawingml/2006/main">
               <a:ext uri="{FF2B5EF4-FFF2-40B4-BE49-F238E27FC236}">
-                <a16:creationId xmlns:a16="http://schemas.microsoft.com/office/drawing/2014/main" id="{98ECDE4D-5690-4B92-AA57-198E3A42093A}"/>
+                <a16:creationId xmlns:a16="http://schemas.microsoft.com/office/drawing/2014/main" id="{9714259D-7DAF-4D7A-92BA-BA8E4A5D963A}"/>
               </a:ext>
             </a:extLst>
           </p:cNvPr>
@@ -13773,7 +14691,7 @@
           <p:cNvPr id="27" name="">
             <a:extLst xmlns:a="http://schemas.openxmlformats.org/drawingml/2006/main">
               <a:ext uri="{FF2B5EF4-FFF2-40B4-BE49-F238E27FC236}">
-                <a16:creationId xmlns:a16="http://schemas.microsoft.com/office/drawing/2014/main" id="{F443C387-DCAC-414F-8A1F-802B34A55E78}"/>
+                <a16:creationId xmlns:a16="http://schemas.microsoft.com/office/drawing/2014/main" id="{1DDD40E4-724D-4D5F-ABEE-57D056F888D6}"/>
               </a:ext>
             </a:extLst>
           </p:cNvPr>
@@ -13803,7 +14721,7 @@
           <p:cNvPr id="28" name="">
             <a:extLst xmlns:a="http://schemas.openxmlformats.org/drawingml/2006/main">
               <a:ext uri="{FF2B5EF4-FFF2-40B4-BE49-F238E27FC236}">
-                <a16:creationId xmlns:a16="http://schemas.microsoft.com/office/drawing/2014/main" id="{2AF22CAC-22E3-4856-9C28-8CAE52AB8B7D}"/>
+                <a16:creationId xmlns:a16="http://schemas.microsoft.com/office/drawing/2014/main" id="{608FAB40-9F8B-489B-A60B-FBEA2142F81F}"/>
               </a:ext>
             </a:extLst>
           </p:cNvPr>
@@ -13858,7 +14776,7 @@
     </p:spTree>
     <p:extLst>
       <p:ext uri="{BB962C8B-B14F-4D97-AF65-F5344CB8AC3E}">
-        <p14:creationId xmlns:p14="http://schemas.microsoft.com/office/powerpoint/2010/main" val="1000938797"/>
+        <p14:creationId xmlns:p14="http://schemas.microsoft.com/office/powerpoint/2010/main" val="666759551"/>
       </p:ext>
     </p:extLst>
   </p:cSld>
@@ -13889,7 +14807,7 @@
           <p:cNvPr id="23" name="">
             <a:extLst xmlns:a="http://schemas.openxmlformats.org/drawingml/2006/main">
               <a:ext uri="{FF2B5EF4-FFF2-40B4-BE49-F238E27FC236}">
-                <a16:creationId xmlns:a16="http://schemas.microsoft.com/office/drawing/2014/main" id="{9C74FC40-7FB5-43E9-A070-5070C816E8B4}"/>
+                <a16:creationId xmlns:a16="http://schemas.microsoft.com/office/drawing/2014/main" id="{9FA9D8CE-4248-4B40-B7FC-8CEEEF69C212}"/>
               </a:ext>
             </a:extLst>
           </p:cNvPr>
@@ -13919,7 +14837,7 @@
           <p:cNvPr id="2" name="">
             <a:extLst xmlns:a="http://schemas.openxmlformats.org/drawingml/2006/main">
               <a:ext uri="{FF2B5EF4-FFF2-40B4-BE49-F238E27FC236}">
-                <a16:creationId xmlns:a16="http://schemas.microsoft.com/office/drawing/2014/main" id="{B3DB6981-24A5-4D71-9136-98DDE63A9ED0}"/>
+                <a16:creationId xmlns:a16="http://schemas.microsoft.com/office/drawing/2014/main" id="{88224BAB-5CC1-4FC5-94E4-3F636DB4641A}"/>
               </a:ext>
             </a:extLst>
           </p:cNvPr>
@@ -13976,7 +14894,7 @@
           <p:cNvPr id="3" name="">
             <a:extLst xmlns:a="http://schemas.openxmlformats.org/drawingml/2006/main">
               <a:ext uri="{FF2B5EF4-FFF2-40B4-BE49-F238E27FC236}">
-                <a16:creationId xmlns:a16="http://schemas.microsoft.com/office/drawing/2014/main" id="{DADAB2A0-4BB7-4324-949D-0F13FB9C7A67}"/>
+                <a16:creationId xmlns:a16="http://schemas.microsoft.com/office/drawing/2014/main" id="{F782F273-C66F-4254-9C6D-6740AFB570DF}"/>
               </a:ext>
             </a:extLst>
           </p:cNvPr>
@@ -14006,7 +14924,7 @@
           <p:cNvPr id="4" name="">
             <a:extLst xmlns:a="http://schemas.openxmlformats.org/drawingml/2006/main">
               <a:ext uri="{FF2B5EF4-FFF2-40B4-BE49-F238E27FC236}">
-                <a16:creationId xmlns:a16="http://schemas.microsoft.com/office/drawing/2014/main" id="{8179499E-D72C-4B9B-A590-90135BF20028}"/>
+                <a16:creationId xmlns:a16="http://schemas.microsoft.com/office/drawing/2014/main" id="{F922B017-E6A6-46E0-8737-C476D1414B2A}"/>
               </a:ext>
             </a:extLst>
           </p:cNvPr>
@@ -14063,7 +14981,7 @@
           <p:cNvPr id="5" name="">
             <a:extLst xmlns:a="http://schemas.openxmlformats.org/drawingml/2006/main">
               <a:ext uri="{FF2B5EF4-FFF2-40B4-BE49-F238E27FC236}">
-                <a16:creationId xmlns:a16="http://schemas.microsoft.com/office/drawing/2014/main" id="{0C3C5257-E033-4800-97C0-7B99B6436687}"/>
+                <a16:creationId xmlns:a16="http://schemas.microsoft.com/office/drawing/2014/main" id="{65B8B449-6BEC-4E05-A498-6142069E7DB6}"/>
               </a:ext>
             </a:extLst>
           </p:cNvPr>
@@ -14093,7 +15011,7 @@
           <p:cNvPr id="6" name="">
             <a:extLst xmlns:a="http://schemas.openxmlformats.org/drawingml/2006/main">
               <a:ext uri="{FF2B5EF4-FFF2-40B4-BE49-F238E27FC236}">
-                <a16:creationId xmlns:a16="http://schemas.microsoft.com/office/drawing/2014/main" id="{D7A3EC54-8D3B-4AC0-85C4-D275C6B162CB}"/>
+                <a16:creationId xmlns:a16="http://schemas.microsoft.com/office/drawing/2014/main" id="{FE07EF7E-557C-4F17-B633-ED69E1E51442}"/>
               </a:ext>
             </a:extLst>
           </p:cNvPr>
@@ -14150,7 +15068,7 @@
           <p:cNvPr id="7" name="">
             <a:extLst xmlns:a="http://schemas.openxmlformats.org/drawingml/2006/main">
               <a:ext uri="{FF2B5EF4-FFF2-40B4-BE49-F238E27FC236}">
-                <a16:creationId xmlns:a16="http://schemas.microsoft.com/office/drawing/2014/main" id="{2E54CF43-5B13-44F6-A436-1232EAB805DA}"/>
+                <a16:creationId xmlns:a16="http://schemas.microsoft.com/office/drawing/2014/main" id="{3E33823B-82F6-4234-9906-3FDCD1505C4C}"/>
               </a:ext>
             </a:extLst>
           </p:cNvPr>
@@ -14180,7 +15098,7 @@
           <p:cNvPr id="8" name="">
             <a:extLst xmlns:a="http://schemas.openxmlformats.org/drawingml/2006/main">
               <a:ext uri="{FF2B5EF4-FFF2-40B4-BE49-F238E27FC236}">
-                <a16:creationId xmlns:a16="http://schemas.microsoft.com/office/drawing/2014/main" id="{EA30CE76-8423-4861-AE76-56EE0C150B1B}"/>
+                <a16:creationId xmlns:a16="http://schemas.microsoft.com/office/drawing/2014/main" id="{1BA0E13C-60E5-45A9-8D5C-07DCFC712915}"/>
               </a:ext>
             </a:extLst>
           </p:cNvPr>
@@ -14237,7 +15155,7 @@
           <p:cNvPr id="9" name="">
             <a:extLst xmlns:a="http://schemas.openxmlformats.org/drawingml/2006/main">
               <a:ext uri="{FF2B5EF4-FFF2-40B4-BE49-F238E27FC236}">
-                <a16:creationId xmlns:a16="http://schemas.microsoft.com/office/drawing/2014/main" id="{1498E049-F0F1-4DA6-9D25-CDCC66832AF3}"/>
+                <a16:creationId xmlns:a16="http://schemas.microsoft.com/office/drawing/2014/main" id="{578A487D-8F2D-4064-A516-957028EF4870}"/>
               </a:ext>
             </a:extLst>
           </p:cNvPr>
@@ -14267,7 +15185,7 @@
           <p:cNvPr id="10" name="">
             <a:extLst xmlns:a="http://schemas.openxmlformats.org/drawingml/2006/main">
               <a:ext uri="{FF2B5EF4-FFF2-40B4-BE49-F238E27FC236}">
-                <a16:creationId xmlns:a16="http://schemas.microsoft.com/office/drawing/2014/main" id="{33095FC1-A6BD-45BE-B05D-A3AEC2D15201}"/>
+                <a16:creationId xmlns:a16="http://schemas.microsoft.com/office/drawing/2014/main" id="{AD5CD450-A373-4CB3-BBDE-AEC4EF7FF601}"/>
               </a:ext>
             </a:extLst>
           </p:cNvPr>
@@ -14324,7 +15242,7 @@
           <p:cNvPr id="11" name="">
             <a:extLst xmlns:a="http://schemas.openxmlformats.org/drawingml/2006/main">
               <a:ext uri="{FF2B5EF4-FFF2-40B4-BE49-F238E27FC236}">
-                <a16:creationId xmlns:a16="http://schemas.microsoft.com/office/drawing/2014/main" id="{90D0287D-B042-4595-B36E-A9E357CD8856}"/>
+                <a16:creationId xmlns:a16="http://schemas.microsoft.com/office/drawing/2014/main" id="{7E8CA27A-2B7E-47B7-866D-F721EA9C2991}"/>
               </a:ext>
             </a:extLst>
           </p:cNvPr>
@@ -14381,7 +15299,7 @@
           <p:cNvPr id="12" name="">
             <a:extLst xmlns:a="http://schemas.openxmlformats.org/drawingml/2006/main">
               <a:ext uri="{FF2B5EF4-FFF2-40B4-BE49-F238E27FC236}">
-                <a16:creationId xmlns:a16="http://schemas.microsoft.com/office/drawing/2014/main" id="{7D970FAB-1394-490A-B6B3-3894421BF1C1}"/>
+                <a16:creationId xmlns:a16="http://schemas.microsoft.com/office/drawing/2014/main" id="{E722FEBA-156E-4B50-9ABA-D3D730D3B5D3}"/>
               </a:ext>
             </a:extLst>
           </p:cNvPr>
@@ -14438,7 +15356,7 @@
           <p:cNvPr id="13" name="">
             <a:extLst xmlns:a="http://schemas.openxmlformats.org/drawingml/2006/main">
               <a:ext uri="{FF2B5EF4-FFF2-40B4-BE49-F238E27FC236}">
-                <a16:creationId xmlns:a16="http://schemas.microsoft.com/office/drawing/2014/main" id="{899EE455-2EC1-4D52-9096-A7FF90BF31B8}"/>
+                <a16:creationId xmlns:a16="http://schemas.microsoft.com/office/drawing/2014/main" id="{3DAC3019-8D34-4B0A-9190-F1429060E227}"/>
               </a:ext>
             </a:extLst>
           </p:cNvPr>
@@ -14495,7 +15413,7 @@
           <p:cNvPr id="14" name="">
             <a:extLst xmlns:a="http://schemas.openxmlformats.org/drawingml/2006/main">
               <a:ext uri="{FF2B5EF4-FFF2-40B4-BE49-F238E27FC236}">
-                <a16:creationId xmlns:a16="http://schemas.microsoft.com/office/drawing/2014/main" id="{2887E11D-EE97-4AC6-AB66-5DC9008F365E}"/>
+                <a16:creationId xmlns:a16="http://schemas.microsoft.com/office/drawing/2014/main" id="{9CBC8FDA-30AA-41A1-A932-18E93E041335}"/>
               </a:ext>
             </a:extLst>
           </p:cNvPr>
@@ -14527,7 +15445,7 @@
           <p:cNvPr id="15" name="">
             <a:extLst xmlns:a="http://schemas.openxmlformats.org/drawingml/2006/main">
               <a:ext uri="{FF2B5EF4-FFF2-40B4-BE49-F238E27FC236}">
-                <a16:creationId xmlns:a16="http://schemas.microsoft.com/office/drawing/2014/main" id="{BF1EEC7F-CCF6-4B53-B4FE-95BD7C8F6051}"/>
+                <a16:creationId xmlns:a16="http://schemas.microsoft.com/office/drawing/2014/main" id="{241FE682-70F5-4D32-8021-28E0E0D22FE5}"/>
               </a:ext>
             </a:extLst>
           </p:cNvPr>
@@ -14557,7 +15475,7 @@
           <p:cNvPr id="16" name="">
             <a:extLst xmlns:a="http://schemas.openxmlformats.org/drawingml/2006/main">
               <a:ext uri="{FF2B5EF4-FFF2-40B4-BE49-F238E27FC236}">
-                <a16:creationId xmlns:a16="http://schemas.microsoft.com/office/drawing/2014/main" id="{2F7322E1-9793-4A96-8918-F66DF981891F}"/>
+                <a16:creationId xmlns:a16="http://schemas.microsoft.com/office/drawing/2014/main" id="{96833414-FD48-4DE8-8DFB-4229234962A9}"/>
               </a:ext>
             </a:extLst>
           </p:cNvPr>
@@ -14614,7 +15532,7 @@
           <p:cNvPr id="17" name="">
             <a:extLst xmlns:a="http://schemas.openxmlformats.org/drawingml/2006/main">
               <a:ext uri="{FF2B5EF4-FFF2-40B4-BE49-F238E27FC236}">
-                <a16:creationId xmlns:a16="http://schemas.microsoft.com/office/drawing/2014/main" id="{26C2B4CD-A139-40F6-AFE6-56D4D9321DD2}"/>
+                <a16:creationId xmlns:a16="http://schemas.microsoft.com/office/drawing/2014/main" id="{0D2AA944-4931-40A6-AD68-A528B2BE2D61}"/>
               </a:ext>
             </a:extLst>
           </p:cNvPr>
@@ -14717,7 +15635,7 @@
           <p:cNvPr id="18" name="">
             <a:extLst xmlns:a="http://schemas.openxmlformats.org/drawingml/2006/main">
               <a:ext uri="{FF2B5EF4-FFF2-40B4-BE49-F238E27FC236}">
-                <a16:creationId xmlns:a16="http://schemas.microsoft.com/office/drawing/2014/main" id="{3BA3886C-3B80-4942-927A-C078FAC69CEA}"/>
+                <a16:creationId xmlns:a16="http://schemas.microsoft.com/office/drawing/2014/main" id="{CD216ADB-CF2C-4B22-AEE3-EEEC3B219279}"/>
               </a:ext>
             </a:extLst>
           </p:cNvPr>
@@ -14749,7 +15667,7 @@
           <p:cNvPr id="19" name="">
             <a:extLst xmlns:a="http://schemas.openxmlformats.org/drawingml/2006/main">
               <a:ext uri="{FF2B5EF4-FFF2-40B4-BE49-F238E27FC236}">
-                <a16:creationId xmlns:a16="http://schemas.microsoft.com/office/drawing/2014/main" id="{068AF01C-47C3-4155-A403-09BEDC55EFD9}"/>
+                <a16:creationId xmlns:a16="http://schemas.microsoft.com/office/drawing/2014/main" id="{4F386A1D-A2BA-404D-BE0B-3513027A21B1}"/>
               </a:ext>
             </a:extLst>
           </p:cNvPr>
@@ -14779,7 +15697,7 @@
           <p:cNvPr id="20" name="">
             <a:extLst xmlns:a="http://schemas.openxmlformats.org/drawingml/2006/main">
               <a:ext uri="{FF2B5EF4-FFF2-40B4-BE49-F238E27FC236}">
-                <a16:creationId xmlns:a16="http://schemas.microsoft.com/office/drawing/2014/main" id="{6D0F4723-8D92-4AA9-8E32-93A5A4EAFDC1}"/>
+                <a16:creationId xmlns:a16="http://schemas.microsoft.com/office/drawing/2014/main" id="{8948208C-0CE6-4112-93BB-A09DA6056D32}"/>
               </a:ext>
             </a:extLst>
           </p:cNvPr>
@@ -14836,7 +15754,7 @@
           <p:cNvPr id="21" name="">
             <a:extLst xmlns:a="http://schemas.openxmlformats.org/drawingml/2006/main">
               <a:ext uri="{FF2B5EF4-FFF2-40B4-BE49-F238E27FC236}">
-                <a16:creationId xmlns:a16="http://schemas.microsoft.com/office/drawing/2014/main" id="{17323F95-FB92-438E-B2F5-A26359225C06}"/>
+                <a16:creationId xmlns:a16="http://schemas.microsoft.com/office/drawing/2014/main" id="{1D6CBC1E-AB8F-4294-8A61-AF528EA71F74}"/>
               </a:ext>
             </a:extLst>
           </p:cNvPr>
@@ -14939,7 +15857,7 @@
           <p:cNvPr id="22" name="">
             <a:extLst xmlns:a="http://schemas.openxmlformats.org/drawingml/2006/main">
               <a:ext uri="{FF2B5EF4-FFF2-40B4-BE49-F238E27FC236}">
-                <a16:creationId xmlns:a16="http://schemas.microsoft.com/office/drawing/2014/main" id="{175F87C7-8A98-4B46-8143-EE49BB462A9F}"/>
+                <a16:creationId xmlns:a16="http://schemas.microsoft.com/office/drawing/2014/main" id="{BF2DD8C0-F55A-45FC-AE2C-A1607BD177BA}"/>
               </a:ext>
             </a:extLst>
           </p:cNvPr>
@@ -14994,7 +15912,7 @@
     </p:spTree>
     <p:extLst>
       <p:ext uri="{BB962C8B-B14F-4D97-AF65-F5344CB8AC3E}">
-        <p14:creationId xmlns:p14="http://schemas.microsoft.com/office/powerpoint/2010/main" val="437716448"/>
+        <p14:creationId xmlns:p14="http://schemas.microsoft.com/office/powerpoint/2010/main" val="2094328452"/>
       </p:ext>
     </p:extLst>
   </p:cSld>

</xml_diff>